<commit_message>
docs: record scale-out, consistency and first CD results; update presentation
</commit_message>
<xml_diff>
--- a/docs/presentation/JiKeDa_Team3_Presentation.pptx
+++ b/docs/presentation/JiKeDa_Team3_Presentation.pptx
@@ -26,9 +26,10 @@
     <p:sldId id="274" r:id="rId20"/>
     <p:sldId id="275" r:id="rId21"/>
     <p:sldId id="276" r:id="rId22"/>
+    <p:sldId id="277" r:id="rId23"/>
   </p:sldIdLst>
   <p:notesMasterIdLst>
-    <p:notesMasterId r:id="rId23"/>
+    <p:notesMasterId r:id="rId24"/>
   </p:notesMasterIdLst>
   <p:sldSz cx="9144000" cy="5143500"/>
   <p:notesSz cx="5143500" cy="9144000"/>
@@ -127,20 +128,20 @@
   <p:extLst>
     <p:ext uri="{521415D9-36F7-43E2-AB2F-B90AF26B5E84}">
       <p14:sectionLst xmlns:p14="http://schemas.microsoft.com/office/powerpoint/2010/main">
-        <p14:section name="Overview" id="{2a8e9327-ff7c-25b9-4118-fd82f2498e89}">
+        <p14:section name="Overview" id="{a847c0a9-bfc9-042f-bd3e-c93108dce479}">
           <p14:sldIdLst>
             <p14:sldId id="256"/>
             <p14:sldId id="257"/>
             <p14:sldId id="258"/>
           </p14:sldIdLst>
         </p14:section>
-        <p14:section name="Project conduct" id="{acc24a65-5be8-3b3c-3f3e-2316314c8227}">
+        <p14:section name="Project conduct" id="{fe386cf6-7dcb-d7f8-196c-65d19957df08}">
           <p14:sldIdLst>
             <p14:sldId id="259"/>
             <p14:sldId id="260"/>
           </p14:sldIdLst>
         </p14:section>
-        <p14:section name="Logical architecture" id="{5abed75a-dd58-a3c0-e9ea-09b8eb1d8160}">
+        <p14:section name="Logical architecture" id="{057f9eb6-2c73-6ff0-4711-8b7e70d89747}">
           <p14:sldIdLst>
             <p14:sldId id="261"/>
             <p14:sldId id="262"/>
@@ -148,7 +149,7 @@
             <p14:sldId id="264"/>
           </p14:sldIdLst>
         </p14:section>
-        <p14:section name="Physical architecture" id="{00d6a1ed-8aac-a322-c31c-f9c5af66d075}">
+        <p14:section name="Physical architecture" id="{144960f9-130b-51b0-0940-69fb2e6aed95}">
           <p14:sldIdLst>
             <p14:sldId id="265"/>
             <p14:sldId id="266"/>
@@ -157,7 +158,7 @@
             <p14:sldId id="269"/>
           </p14:sldIdLst>
         </p14:section>
-        <p14:section name="DevOps and lifecycle" id="{be1e076c-d72a-c4f8-1503-348b1df3a521}">
+        <p14:section name="DevOps and lifecycle" id="{b5300931-003f-ad29-6be2-5835ac9408ae}">
           <p14:sldIdLst>
             <p14:sldId id="270"/>
             <p14:sldId id="271"/>
@@ -165,15 +166,16 @@
             <p14:sldId id="273"/>
           </p14:sldIdLst>
         </p14:section>
-        <p14:section name="Demo" id="{88b2da7a-adb0-8330-5942-1260753e65c9}">
+        <p14:section name="Demo" id="{e89e3b76-d2eb-9291-064c-eef997ed605c}">
           <p14:sldIdLst>
             <p14:sldId id="274"/>
+            <p14:sldId id="275"/>
           </p14:sldIdLst>
         </p14:section>
-        <p14:section name="Wrap-up" id="{7d2c8bd2-b648-4f67-273c-0dce0d7138b7}">
+        <p14:section name="Wrap-up" id="{b477ff2e-f21e-9eac-11d5-09cdf5c024c7}">
           <p14:sldIdLst>
-            <p14:sldId id="275"/>
             <p14:sldId id="276"/>
+            <p14:sldId id="277"/>
           </p14:sldIdLst>
         </p14:section>
       </p14:sectionLst>
@@ -1460,7 +1462,7 @@
           <a:p>
             <a:r>
               <a:rPr lang="en-US" dirty="0"/>
-              <a:t>Demo, 8 minutes plus 2 for questions. Suggested split: use cases about 4.5 minutes; quality attributes about 3.5 minutes. Rehearse once on the staging stack before the session and keep the smoke script ready as a fallback in case of network trouble on Zoom. The guidelines ask for a quality attribute demo such as performance or scalability; if a scripted load test has been added by then, show its result here and update this slide.</a:t>
+              <a:t>Quality attribute evidence, shown in the demo section. Scalability: the same stack was run with 1, 2 and 3 API replicas behind nginx; each replica is limited to one CPU, as on a managed platform. Throughput rose to about 2.5 times with three replicas. All numbers come from a GitHub Actions run (scale-test workflow), and another run gave a similar trend, so say that the trend is the evidence. Consistency: 30 customers race for 20 units and each sends the checkout twice; exactly 20 orders exist, duplicates return the stored order, stock ends at 0. Be explicit that scaling was manual: we did not build auto-scaling.</a:t>
             </a:r>
             <a:endParaRPr lang="en-US" dirty="0"/>
           </a:p>
@@ -1636,7 +1638,7 @@
           <a:p>
             <a:r>
               <a:rPr lang="en-US" dirty="0"/>
-              <a:t>About 30 seconds. Close with the lessons. The first next step answers the likely question about scalability: we know what to do, and the architecture leaves room for it, but we have not done it yet.</a:t>
+              <a:t>Demo, 8 minutes plus 2 for questions. Suggested split: use cases about 4.5 minutes; quality attributes about 3.5 minutes. Rehearse once on the staging stack before the session and keep the smoke script ready as a fallback in case of network trouble on Zoom. The guidelines ask for a quality attribute demo such as performance or scalability; if a scripted load test has been added by then, show its result here and update this slide.</a:t>
             </a:r>
             <a:endParaRPr lang="en-US" dirty="0"/>
           </a:p>
@@ -1724,7 +1726,7 @@
           <a:p>
             <a:r>
               <a:rPr lang="en-US" dirty="0"/>
-              <a:t>Q&amp;A. Likely questions: How would you scale it? (stateless API, replicas behind the proxy, one database; not done yet.) Why a monolith? (one transaction across cart, stock and order for a five-person team.) What if the payment provider is slow? (the charge happens inside the transaction today; a real provider would need a pending state and a webhook.) How is double charging prevented? (idempotency key unique per user plus the cart claim.)</a:t>
+              <a:t>About 30 seconds. Close with the lessons. The first next step answers the likely question about scalability: we know what to do, and the architecture leaves room for it, but we have not done it yet.</a:t>
             </a:r>
             <a:endParaRPr lang="en-US" dirty="0"/>
           </a:p>
@@ -1748,6 +1750,94 @@
             <a:fld id="{F7021451-1387-4CA6-816F-3879F97B5CBC}" type="slidenum">
               <a:rPr lang="en-US"/>
               <a:t>21</a:t>
+            </a:fld>
+            <a:endParaRPr lang="en-US"/>
+          </a:p>
+        </p:txBody>
+      </p:sp>
+    </p:spTree>
+    <p:extLst>
+      <p:ext uri="{BB962C8B-B14F-4D97-AF65-F5344CB8AC3E}">
+        <p14:creationId xmlns:p14="http://schemas.microsoft.com/office/powerpoint/2010/main" val="1024086991"/>
+      </p:ext>
+    </p:extLst>
+  </p:cSld>
+  <p:clrMapOvr>
+    <a:masterClrMapping/>
+  </p:clrMapOvr>
+</p:notes>
+</file>
+
+<file path=ppt/notesSlides/notesSlide22.xml><?xml version="1.0" encoding="utf-8"?>
+<p:notes xmlns:a="http://schemas.openxmlformats.org/drawingml/2006/main" xmlns:r="http://schemas.openxmlformats.org/officeDocument/2006/relationships" xmlns:p="http://schemas.openxmlformats.org/presentationml/2006/main">
+  <p:cSld>
+    <p:spTree>
+      <p:nvGrpSpPr>
+        <p:cNvPr id="1" name=""/>
+        <p:cNvGrpSpPr/>
+        <p:nvPr/>
+      </p:nvGrpSpPr>
+      <p:grpSpPr>
+        <a:xfrm>
+          <a:off x="0" y="0"/>
+          <a:ext cx="0" cy="0"/>
+          <a:chOff x="0" y="0"/>
+          <a:chExt cx="0" cy="0"/>
+        </a:xfrm>
+      </p:grpSpPr>
+      <p:sp>
+        <p:nvSpPr>
+          <p:cNvPr id="2" name="Slide Image Placeholder 1"/>
+          <p:cNvSpPr>
+            <a:spLocks noGrp="1" noRot="1" noChangeAspect="1"/>
+          </p:cNvSpPr>
+          <p:nvPr>
+            <p:ph type="sldImg"/>
+          </p:nvPr>
+        </p:nvSpPr>
+        <p:spPr/>
+      </p:sp>
+      <p:sp>
+        <p:nvSpPr>
+          <p:cNvPr id="3" name="Notes Placeholder 2"/>
+          <p:cNvSpPr>
+            <a:spLocks noGrp="1"/>
+          </p:cNvSpPr>
+          <p:nvPr>
+            <p:ph type="body" idx="1"/>
+          </p:nvPr>
+        </p:nvSpPr>
+        <p:spPr/>
+        <p:txBody>
+          <a:bodyPr/>
+          <a:lstStyle/>
+          <a:p>
+            <a:r>
+              <a:rPr lang="en-US" dirty="0"/>
+              <a:t>Q&amp;A. Likely questions: How would you scale it? (stateless API, replicas behind the proxy, one database; not done yet.) Why a monolith? (one transaction across cart, stock and order for a five-person team.) What if the payment provider is slow? (the charge happens inside the transaction today; a real provider would need a pending state and a webhook.) How is double charging prevented? (idempotency key unique per user plus the cart claim.)</a:t>
+            </a:r>
+            <a:endParaRPr lang="en-US" dirty="0"/>
+          </a:p>
+        </p:txBody>
+      </p:sp>
+      <p:sp>
+        <p:nvSpPr>
+          <p:cNvPr id="4" name="Slide Number Placeholder 3"/>
+          <p:cNvSpPr>
+            <a:spLocks noGrp="1"/>
+          </p:cNvSpPr>
+          <p:nvPr>
+            <p:ph type="sldNum" sz="quarter" idx="10"/>
+          </p:nvPr>
+        </p:nvSpPr>
+        <p:spPr/>
+        <p:txBody>
+          <a:bodyPr/>
+          <a:lstStyle/>
+          <a:p>
+            <a:fld id="{F7021451-1387-4CA6-816F-3879F97B5CBC}" type="slidenum">
+              <a:rPr lang="en-US"/>
+              <a:t>22</a:t>
             </a:fld>
             <a:endParaRPr lang="en-US"/>
           </a:p>
@@ -1900,7 +1990,7 @@
           <a:p>
             <a:r>
               <a:rPr lang="en-US" dirty="0"/>
-              <a:t>About 1 minute. The proposal promised four services on Azure with Service Bus and measured scale-out. We delivered one modular API on Docker Compose. THE TEAM MUST AGREE ON THE REASON for the change before Wednesday and state it here in one sentence; the technical argument available is that checkout changes cart, stock, coupons and the order in one database transaction. Be direct about what is not built (cloud, scale-out evidence, menu display) and say what you will show instead. Update the CD row if the pull request has been merged and the first CD run has completed.</a:t>
+              <a:t>About 1 minute. The proposal promised four services on Azure with Service Bus and measured scale-out. We delivered one modular API on Docker Compose. THE TEAM MUST AGREE ON THE REASON for the change before Wednesday and state it here in one sentence; the technical argument available is that checkout changes cart, stock, coupons and the order in one database transaction. Be direct about what is not built (Azure, auto-scaling, menu display) and say what you show instead: replicas scaled by hand and measured with k6, and a consistency race.</a:t>
             </a:r>
             <a:endParaRPr lang="en-US" dirty="0"/>
           </a:p>
@@ -3842,7 +3932,7 @@
                   <a:schemeClr val="bg1"/>
                 </a:solidFill>
               </a:rPr>
-              <a:t>non-root, cap_drop ALL, /api/health</a:t>
+              <a:t>non-root, 1 to N replicas, /api/health</a:t>
             </a:r>
             <a:endParaRPr lang="en-US" sz="1100" dirty="0"/>
           </a:p>
@@ -5919,7 +6009,25 @@
                   <a:schemeClr val="bg1"/>
                 </a:solidFill>
               </a:rPr>
-              <a:t>The proposed Azure target (Container Apps, Service Bus) and the scale-out measurements are not built.</a:t>
+              <a:t>Measured: three replicas gave 2.5 times the throughput (k6). Scaled by hand, not auto-scaled.</a:t>
+            </a:r>
+            <a:endParaRPr lang="en-US" sz="1300" dirty="0"/>
+          </a:p>
+          <a:p>
+            <a:pPr marL="177800" indent="-177800">
+              <a:spcAft>
+                <a:spcPts val="800"/>
+              </a:spcAft>
+              <a:buSzPct val="100000"/>
+              <a:buChar char="•"/>
+            </a:pPr>
+            <a:r>
+              <a:rPr lang="en-US" sz="1300" dirty="0">
+                <a:solidFill>
+                  <a:schemeClr val="bg1"/>
+                </a:solidFill>
+              </a:rPr>
+              <a:t>The proposed Azure target (Container Apps, Service Bus) is not built.</a:t>
             </a:r>
             <a:endParaRPr lang="en-US" sz="1300" dirty="0"/>
           </a:p>
@@ -11458,7 +11566,7 @@
                   <a:schemeClr val="accent1"/>
                 </a:solidFill>
               </a:rPr>
-              <a:t>287</a:t>
+              <a:t>289</a:t>
             </a:r>
             <a:endParaRPr lang="en-US" sz="5400" dirty="0"/>
           </a:p>
@@ -12731,7 +12839,7 @@
                   <a:schemeClr val="tx1"/>
                 </a:solidFill>
               </a:rPr>
-              <a:t>PostgreSQL service in CI: 287 tests run, none skipped.</a:t>
+              <a:t>PostgreSQL service in CI: all 289 backend tests run, none skipped.</a:t>
             </a:r>
             <a:endParaRPr lang="en-US" sz="1200" dirty="0"/>
           </a:p>
@@ -12900,7 +13008,7 @@
                   <a:schemeClr val="tx1"/>
                 </a:solidFill>
               </a:rPr>
-              <a:t>Demo plan (8 minutes)</a:t>
+              <a:t>Scale-out and consistency evidence</a:t>
             </a:r>
             <a:endParaRPr lang="en-US" sz="3000" dirty="0"/>
           </a:p>
@@ -12908,14 +13016,14 @@
       </p:sp>
       <p:sp>
         <p:nvSpPr>
-          <p:cNvPr id="3" name="Use cases card"/>
+          <p:cNvPr id="3" name="Throughput card"/>
           <p:cNvSpPr/>
           <p:nvPr/>
         </p:nvSpPr>
         <p:spPr>
           <a:xfrm>
             <a:off x="457200" y="1097280"/>
-            <a:ext cx="4114800" cy="3017520"/>
+            <a:ext cx="5029200" cy="3017520"/>
           </a:xfrm>
           <a:prstGeom prst="roundRect">
             <a:avLst>
@@ -12935,14 +13043,14 @@
       </p:sp>
       <p:sp>
         <p:nvSpPr>
-          <p:cNvPr id="4" name="Use cases heading"/>
+          <p:cNvPr id="4" name="Throughput heading"/>
           <p:cNvSpPr txBox="1"/>
           <p:nvPr/>
         </p:nvSpPr>
         <p:spPr>
           <a:xfrm>
             <a:off x="640080" y="1188720"/>
-            <a:ext cx="3657600" cy="320040"/>
+            <a:ext cx="4663440" cy="320040"/>
           </a:xfrm>
           <a:prstGeom prst="rect">
             <a:avLst/>
@@ -12958,27 +13066,27 @@
               <a:buNone/>
             </a:pPr>
             <a:r>
-              <a:rPr lang="en-US" sz="1600" b="1" dirty="0">
-                <a:solidFill>
-                  <a:schemeClr val="accent1"/>
-                </a:solidFill>
-              </a:rPr>
-              <a:t>Use cases</a:t>
-            </a:r>
-            <a:endParaRPr lang="en-US" sz="1600" dirty="0"/>
-          </a:p>
-        </p:txBody>
-      </p:sp>
-      <p:sp>
-        <p:nvSpPr>
-          <p:cNvPr id="5" name="Use case steps"/>
+              <a:rPr lang="en-US" sz="1500" b="1" dirty="0">
+                <a:solidFill>
+                  <a:schemeClr val="tx1"/>
+                </a:solidFill>
+              </a:rPr>
+              <a:t>Requests per second by API replicas</a:t>
+            </a:r>
+            <a:endParaRPr lang="en-US" sz="1500" dirty="0"/>
+          </a:p>
+        </p:txBody>
+      </p:sp>
+      <p:sp>
+        <p:nvSpPr>
+          <p:cNvPr id="5" name="1 replica label"/>
           <p:cNvSpPr txBox="1"/>
           <p:nvPr/>
         </p:nvSpPr>
         <p:spPr>
           <a:xfrm>
-            <a:off x="640080" y="1600200"/>
-            <a:ext cx="3749040" cy="2377440"/>
+            <a:off x="640080" y="1691640"/>
+            <a:ext cx="1051560" cy="457200"/>
           </a:xfrm>
           <a:prstGeom prst="rect">
             <a:avLst/>
@@ -12987,97 +13095,722 @@
           <a:ln/>
         </p:spPr>
         <p:txBody>
+          <a:bodyPr wrap="square" lIns="0" tIns="0" rIns="0" bIns="0" rtlCol="0" anchor="ctr"/>
+          <a:lstStyle/>
+          <a:p>
+            <a:pPr indent="0" marL="0">
+              <a:buNone/>
+            </a:pPr>
+            <a:r>
+              <a:rPr lang="en-US" sz="1300" dirty="0">
+                <a:solidFill>
+                  <a:schemeClr val="tx1"/>
+                </a:solidFill>
+              </a:rPr>
+              <a:t>1 replica</a:t>
+            </a:r>
+            <a:endParaRPr lang="en-US" sz="1300" dirty="0"/>
+          </a:p>
+        </p:txBody>
+      </p:sp>
+      <p:sp>
+        <p:nvSpPr>
+          <p:cNvPr id="6" name="1 replica bar"/>
+          <p:cNvSpPr/>
+          <p:nvPr/>
+        </p:nvSpPr>
+        <p:spPr>
+          <a:xfrm>
+            <a:off x="1737360" y="1691640"/>
+            <a:ext cx="955548" cy="457200"/>
+          </a:xfrm>
+          <a:prstGeom prst="roundRect">
+            <a:avLst>
+              <a:gd name="adj" fmla="val 8000"/>
+            </a:avLst>
+          </a:prstGeom>
+          <a:solidFill>
+            <a:schemeClr val="accent1"/>
+          </a:solidFill>
+          <a:ln w="12700">
+            <a:solidFill>
+              <a:schemeClr val="accent1"/>
+            </a:solidFill>
+            <a:prstDash val="solid"/>
+          </a:ln>
+        </p:spPr>
+      </p:sp>
+      <p:sp>
+        <p:nvSpPr>
+          <p:cNvPr id="7" name="1 replica value"/>
+          <p:cNvSpPr txBox="1"/>
+          <p:nvPr/>
+        </p:nvSpPr>
+        <p:spPr>
+          <a:xfrm>
+            <a:off x="2784348" y="1691640"/>
+            <a:ext cx="1463040" cy="457200"/>
+          </a:xfrm>
+          <a:prstGeom prst="rect">
+            <a:avLst/>
+          </a:prstGeom>
+          <a:noFill/>
+          <a:ln/>
+        </p:spPr>
+        <p:txBody>
+          <a:bodyPr wrap="square" lIns="0" tIns="0" rIns="0" bIns="0" rtlCol="0" anchor="ctr"/>
+          <a:lstStyle/>
+          <a:p>
+            <a:pPr indent="0" marL="0">
+              <a:buNone/>
+            </a:pPr>
+            <a:r>
+              <a:rPr lang="en-US" sz="1200" b="1" dirty="0">
+                <a:solidFill>
+                  <a:schemeClr val="tx1"/>
+                </a:solidFill>
+              </a:rPr>
+              <a:t>11   p95 7.1 s</a:t>
+            </a:r>
+            <a:endParaRPr lang="en-US" sz="1200" dirty="0"/>
+          </a:p>
+        </p:txBody>
+      </p:sp>
+      <p:sp>
+        <p:nvSpPr>
+          <p:cNvPr id="8" name="2 replicas label"/>
+          <p:cNvSpPr txBox="1"/>
+          <p:nvPr/>
+        </p:nvSpPr>
+        <p:spPr>
+          <a:xfrm>
+            <a:off x="640080" y="2377440"/>
+            <a:ext cx="1051560" cy="457200"/>
+          </a:xfrm>
+          <a:prstGeom prst="rect">
+            <a:avLst/>
+          </a:prstGeom>
+          <a:noFill/>
+          <a:ln/>
+        </p:spPr>
+        <p:txBody>
+          <a:bodyPr wrap="square" lIns="0" tIns="0" rIns="0" bIns="0" rtlCol="0" anchor="ctr"/>
+          <a:lstStyle/>
+          <a:p>
+            <a:pPr indent="0" marL="0">
+              <a:buNone/>
+            </a:pPr>
+            <a:r>
+              <a:rPr lang="en-US" sz="1300" dirty="0">
+                <a:solidFill>
+                  <a:schemeClr val="tx1"/>
+                </a:solidFill>
+              </a:rPr>
+              <a:t>2 replicas</a:t>
+            </a:r>
+            <a:endParaRPr lang="en-US" sz="1300" dirty="0"/>
+          </a:p>
+        </p:txBody>
+      </p:sp>
+      <p:sp>
+        <p:nvSpPr>
+          <p:cNvPr id="9" name="2 replicas bar"/>
+          <p:cNvSpPr/>
+          <p:nvPr/>
+        </p:nvSpPr>
+        <p:spPr>
+          <a:xfrm>
+            <a:off x="1737360" y="2377440"/>
+            <a:ext cx="1911096" cy="457200"/>
+          </a:xfrm>
+          <a:prstGeom prst="roundRect">
+            <a:avLst>
+              <a:gd name="adj" fmla="val 8000"/>
+            </a:avLst>
+          </a:prstGeom>
+          <a:solidFill>
+            <a:schemeClr val="accent1"/>
+          </a:solidFill>
+          <a:ln w="12700">
+            <a:solidFill>
+              <a:schemeClr val="accent1"/>
+            </a:solidFill>
+            <a:prstDash val="solid"/>
+          </a:ln>
+        </p:spPr>
+      </p:sp>
+      <p:sp>
+        <p:nvSpPr>
+          <p:cNvPr id="10" name="2 replicas value"/>
+          <p:cNvSpPr txBox="1"/>
+          <p:nvPr/>
+        </p:nvSpPr>
+        <p:spPr>
+          <a:xfrm>
+            <a:off x="3739896" y="2377440"/>
+            <a:ext cx="1463040" cy="457200"/>
+          </a:xfrm>
+          <a:prstGeom prst="rect">
+            <a:avLst/>
+          </a:prstGeom>
+          <a:noFill/>
+          <a:ln/>
+        </p:spPr>
+        <p:txBody>
+          <a:bodyPr wrap="square" lIns="0" tIns="0" rIns="0" bIns="0" rtlCol="0" anchor="ctr"/>
+          <a:lstStyle/>
+          <a:p>
+            <a:pPr indent="0" marL="0">
+              <a:buNone/>
+            </a:pPr>
+            <a:r>
+              <a:rPr lang="en-US" sz="1200" b="1" dirty="0">
+                <a:solidFill>
+                  <a:schemeClr val="tx1"/>
+                </a:solidFill>
+              </a:rPr>
+              <a:t>22   p95 3.2 s</a:t>
+            </a:r>
+            <a:endParaRPr lang="en-US" sz="1200" dirty="0"/>
+          </a:p>
+        </p:txBody>
+      </p:sp>
+      <p:sp>
+        <p:nvSpPr>
+          <p:cNvPr id="11" name="3 replicas label"/>
+          <p:cNvSpPr txBox="1"/>
+          <p:nvPr/>
+        </p:nvSpPr>
+        <p:spPr>
+          <a:xfrm>
+            <a:off x="640080" y="3063240"/>
+            <a:ext cx="1051560" cy="457200"/>
+          </a:xfrm>
+          <a:prstGeom prst="rect">
+            <a:avLst/>
+          </a:prstGeom>
+          <a:noFill/>
+          <a:ln/>
+        </p:spPr>
+        <p:txBody>
+          <a:bodyPr wrap="square" lIns="0" tIns="0" rIns="0" bIns="0" rtlCol="0" anchor="ctr"/>
+          <a:lstStyle/>
+          <a:p>
+            <a:pPr indent="0" marL="0">
+              <a:buNone/>
+            </a:pPr>
+            <a:r>
+              <a:rPr lang="en-US" sz="1300" dirty="0">
+                <a:solidFill>
+                  <a:schemeClr val="tx1"/>
+                </a:solidFill>
+              </a:rPr>
+              <a:t>3 replicas</a:t>
+            </a:r>
+            <a:endParaRPr lang="en-US" sz="1300" dirty="0"/>
+          </a:p>
+        </p:txBody>
+      </p:sp>
+      <p:sp>
+        <p:nvSpPr>
+          <p:cNvPr id="12" name="3 replicas bar"/>
+          <p:cNvSpPr/>
+          <p:nvPr/>
+        </p:nvSpPr>
+        <p:spPr>
+          <a:xfrm>
+            <a:off x="1737360" y="3063240"/>
+            <a:ext cx="2519172" cy="457200"/>
+          </a:xfrm>
+          <a:prstGeom prst="roundRect">
+            <a:avLst>
+              <a:gd name="adj" fmla="val 8000"/>
+            </a:avLst>
+          </a:prstGeom>
+          <a:solidFill>
+            <a:schemeClr val="accent1"/>
+          </a:solidFill>
+          <a:ln w="12700">
+            <a:solidFill>
+              <a:schemeClr val="accent1"/>
+            </a:solidFill>
+            <a:prstDash val="solid"/>
+          </a:ln>
+        </p:spPr>
+      </p:sp>
+      <p:sp>
+        <p:nvSpPr>
+          <p:cNvPr id="13" name="3 replicas value"/>
+          <p:cNvSpPr txBox="1"/>
+          <p:nvPr/>
+        </p:nvSpPr>
+        <p:spPr>
+          <a:xfrm>
+            <a:off x="4347972" y="3063240"/>
+            <a:ext cx="1463040" cy="457200"/>
+          </a:xfrm>
+          <a:prstGeom prst="rect">
+            <a:avLst/>
+          </a:prstGeom>
+          <a:noFill/>
+          <a:ln/>
+        </p:spPr>
+        <p:txBody>
+          <a:bodyPr wrap="square" lIns="0" tIns="0" rIns="0" bIns="0" rtlCol="0" anchor="ctr"/>
+          <a:lstStyle/>
+          <a:p>
+            <a:pPr indent="0" marL="0">
+              <a:buNone/>
+            </a:pPr>
+            <a:r>
+              <a:rPr lang="en-US" sz="1200" b="1" dirty="0">
+                <a:solidFill>
+                  <a:schemeClr val="tx1"/>
+                </a:solidFill>
+              </a:rPr>
+              <a:t>29   p95 3.8 s</a:t>
+            </a:r>
+            <a:endParaRPr lang="en-US" sz="1200" dirty="0"/>
+          </a:p>
+        </p:txBody>
+      </p:sp>
+      <p:sp>
+        <p:nvSpPr>
+          <p:cNvPr id="14" name="Throughput caveat"/>
+          <p:cNvSpPr txBox="1"/>
+          <p:nvPr/>
+        </p:nvSpPr>
+        <p:spPr>
+          <a:xfrm>
+            <a:off x="640080" y="3657600"/>
+            <a:ext cx="4663440" cy="411480"/>
+          </a:xfrm>
+          <a:prstGeom prst="rect">
+            <a:avLst/>
+          </a:prstGeom>
+          <a:noFill/>
+          <a:ln/>
+        </p:spPr>
+        <p:txBody>
           <a:bodyPr wrap="square" lIns="0" tIns="0" rIns="0" bIns="0" rtlCol="0" anchor="t"/>
           <a:lstStyle/>
           <a:p>
-            <a:pPr marL="342900" indent="-342900">
-              <a:spcAft>
-                <a:spcPts val="600"/>
-              </a:spcAft>
-              <a:buSzPct val="100000"/>
-              <a:buFont typeface="+mj-lt"/>
-              <a:buAutoNum type="arabicPeriod" startAt="1"/>
-            </a:pPr>
-            <a:r>
-              <a:rPr lang="en-US" sz="1600" dirty="0">
-                <a:solidFill>
-                  <a:schemeClr val="tx1"/>
-                </a:solidFill>
-              </a:rPr>
-              <a:t>Customer: sign in, fill cart, apply coupon, pay</a:t>
-            </a:r>
-            <a:endParaRPr lang="en-US" sz="1600" dirty="0"/>
-          </a:p>
-          <a:p>
-            <a:pPr marL="342900" indent="-342900">
-              <a:spcAft>
-                <a:spcPts val="600"/>
-              </a:spcAft>
-              <a:buSzPct val="100000"/>
-              <a:buFont typeface="+mj-lt"/>
-              <a:buAutoNum type="arabicPeriod" startAt="1"/>
-            </a:pPr>
-            <a:r>
-              <a:rPr lang="en-US" sz="1600" dirty="0">
-                <a:solidFill>
-                  <a:schemeClr val="tx1"/>
-                </a:solidFill>
-              </a:rPr>
-              <a:t>Merchant: accept, prepare, mark ready</a:t>
-            </a:r>
-            <a:endParaRPr lang="en-US" sz="1600" dirty="0"/>
-          </a:p>
-          <a:p>
-            <a:pPr marL="342900" indent="-342900">
-              <a:spcAft>
-                <a:spcPts val="600"/>
-              </a:spcAft>
-              <a:buSzPct val="100000"/>
-              <a:buFont typeface="+mj-lt"/>
-              <a:buAutoNum type="arabicPeriod" startAt="1"/>
-            </a:pPr>
-            <a:r>
-              <a:rPr lang="en-US" sz="1600" dirty="0">
-                <a:solidFill>
-                  <a:schemeClr val="tx1"/>
-                </a:solidFill>
-              </a:rPr>
-              <a:t>Rider: claim the order, deliver, complete</a:t>
-            </a:r>
-            <a:endParaRPr lang="en-US" sz="1600" dirty="0"/>
-          </a:p>
-          <a:p>
-            <a:pPr marL="342900" indent="-342900">
-              <a:buSzPct val="100000"/>
-              <a:buFont typeface="+mj-lt"/>
-              <a:buAutoNum type="arabicPeriod" startAt="1"/>
-            </a:pPr>
-            <a:r>
-              <a:rPr lang="en-US" sz="1600" dirty="0">
-                <a:solidFill>
-                  <a:schemeClr val="tx1"/>
-                </a:solidFill>
-              </a:rPr>
-              <a:t>Customer and administrator both see Completed</a:t>
-            </a:r>
-            <a:endParaRPr lang="en-US" sz="1600" dirty="0"/>
-          </a:p>
-        </p:txBody>
-      </p:sp>
-      <p:sp>
-        <p:nvSpPr>
-          <p:cNvPr id="6" name="Quality card"/>
+            <a:pPr indent="0" marL="0">
+              <a:buNone/>
+            </a:pPr>
+            <a:r>
+              <a:rPr lang="en-US" sz="1100" dirty="0">
+                <a:solidFill>
+                  <a:schemeClr val="tx2"/>
+                </a:solidFill>
+              </a:rPr>
+              <a:t>k6, 40 users, 45 s per step; sign-in heavy; each replica capped at 1 vCPU; one shared 4-vCPU runner. Another run gave 15 and 39 requests/s for 1 and 3 replicas.</a:t>
+            </a:r>
+            <a:endParaRPr lang="en-US" sz="1100" dirty="0"/>
+          </a:p>
+        </p:txBody>
+      </p:sp>
+      <p:sp>
+        <p:nvSpPr>
+          <p:cNvPr id="15" name="Race card"/>
           <p:cNvSpPr/>
           <p:nvPr/>
         </p:nvSpPr>
         <p:spPr>
           <a:xfrm>
-            <a:off x="4754880" y="1097280"/>
-            <a:ext cx="3931920" cy="3017520"/>
+            <a:off x="5669280" y="1097280"/>
+            <a:ext cx="3017520" cy="3017520"/>
           </a:xfrm>
           <a:prstGeom prst="roundRect">
             <a:avLst>
               <a:gd name="adj" fmla="val 2424"/>
+            </a:avLst>
+          </a:prstGeom>
+          <a:solidFill>
+            <a:schemeClr val="tx1"/>
+          </a:solidFill>
+          <a:ln w="12700">
+            <a:solidFill>
+              <a:schemeClr val="tx1"/>
+            </a:solidFill>
+            <a:prstDash val="solid"/>
+          </a:ln>
+        </p:spPr>
+      </p:sp>
+      <p:sp>
+        <p:nvSpPr>
+          <p:cNvPr id="16" name="Race heading"/>
+          <p:cNvSpPr txBox="1"/>
+          <p:nvPr/>
+        </p:nvSpPr>
+        <p:spPr>
+          <a:xfrm>
+            <a:off x="5852160" y="1188720"/>
+            <a:ext cx="2743200" cy="320040"/>
+          </a:xfrm>
+          <a:prstGeom prst="rect">
+            <a:avLst/>
+          </a:prstGeom>
+          <a:noFill/>
+          <a:ln/>
+        </p:spPr>
+        <p:txBody>
+          <a:bodyPr wrap="square" lIns="0" tIns="0" rIns="0" bIns="0" rtlCol="0" anchor="t"/>
+          <a:lstStyle/>
+          <a:p>
+            <a:pPr indent="0" marL="0">
+              <a:buNone/>
+            </a:pPr>
+            <a:r>
+              <a:rPr lang="en-US" sz="1500" b="1" dirty="0">
+                <a:solidFill>
+                  <a:schemeClr val="accent2"/>
+                </a:solidFill>
+              </a:rPr>
+              <a:t>Race for 20 units</a:t>
+            </a:r>
+            <a:endParaRPr lang="en-US" sz="1500" dirty="0"/>
+          </a:p>
+        </p:txBody>
+      </p:sp>
+      <p:sp>
+        <p:nvSpPr>
+          <p:cNvPr id="17" name="Race setup"/>
+          <p:cNvSpPr txBox="1"/>
+          <p:nvPr/>
+        </p:nvSpPr>
+        <p:spPr>
+          <a:xfrm>
+            <a:off x="5852160" y="1554480"/>
+            <a:ext cx="2697480" cy="457200"/>
+          </a:xfrm>
+          <a:prstGeom prst="rect">
+            <a:avLst/>
+          </a:prstGeom>
+          <a:noFill/>
+          <a:ln/>
+        </p:spPr>
+        <p:txBody>
+          <a:bodyPr wrap="square" lIns="0" tIns="0" rIns="0" bIns="0" rtlCol="0" anchor="t"/>
+          <a:lstStyle/>
+          <a:p>
+            <a:pPr indent="0" marL="0">
+              <a:buNone/>
+            </a:pPr>
+            <a:r>
+              <a:rPr lang="en-US" sz="1200" dirty="0">
+                <a:solidFill>
+                  <a:schemeClr val="bg1"/>
+                </a:solidFill>
+              </a:rPr>
+              <a:t>30 customers send the same checkout twice, at once</a:t>
+            </a:r>
+            <a:endParaRPr lang="en-US" sz="1200" dirty="0"/>
+          </a:p>
+        </p:txBody>
+      </p:sp>
+      <p:sp>
+        <p:nvSpPr>
+          <p:cNvPr id="18" name="Race 1 value"/>
+          <p:cNvSpPr txBox="1"/>
+          <p:nvPr/>
+        </p:nvSpPr>
+        <p:spPr>
+          <a:xfrm>
+            <a:off x="5852160" y="2103120"/>
+            <a:ext cx="548640" cy="411480"/>
+          </a:xfrm>
+          <a:prstGeom prst="rect">
+            <a:avLst/>
+          </a:prstGeom>
+          <a:noFill/>
+          <a:ln/>
+        </p:spPr>
+        <p:txBody>
+          <a:bodyPr wrap="square" lIns="0" tIns="0" rIns="0" bIns="0" rtlCol="0" anchor="ctr"/>
+          <a:lstStyle/>
+          <a:p>
+            <a:pPr indent="0" marL="0">
+              <a:buNone/>
+            </a:pPr>
+            <a:r>
+              <a:rPr lang="en-US" sz="2200" b="1" dirty="0">
+                <a:solidFill>
+                  <a:schemeClr val="accent2"/>
+                </a:solidFill>
+              </a:rPr>
+              <a:t>20</a:t>
+            </a:r>
+            <a:endParaRPr lang="en-US" sz="2200" dirty="0"/>
+          </a:p>
+        </p:txBody>
+      </p:sp>
+      <p:sp>
+        <p:nvSpPr>
+          <p:cNvPr id="19" name="Race 1 text"/>
+          <p:cNvSpPr txBox="1"/>
+          <p:nvPr/>
+        </p:nvSpPr>
+        <p:spPr>
+          <a:xfrm>
+            <a:off x="6446520" y="2103120"/>
+            <a:ext cx="2148840" cy="411480"/>
+          </a:xfrm>
+          <a:prstGeom prst="rect">
+            <a:avLst/>
+          </a:prstGeom>
+          <a:noFill/>
+          <a:ln/>
+        </p:spPr>
+        <p:txBody>
+          <a:bodyPr wrap="square" lIns="0" tIns="0" rIns="0" bIns="0" rtlCol="0" anchor="ctr"/>
+          <a:lstStyle/>
+          <a:p>
+            <a:pPr indent="0" marL="0">
+              <a:buNone/>
+            </a:pPr>
+            <a:r>
+              <a:rPr lang="en-US" sz="1200" dirty="0">
+                <a:solidFill>
+                  <a:schemeClr val="bg1"/>
+                </a:solidFill>
+              </a:rPr>
+              <a:t>orders created</a:t>
+            </a:r>
+            <a:endParaRPr lang="en-US" sz="1200" dirty="0"/>
+          </a:p>
+        </p:txBody>
+      </p:sp>
+      <p:sp>
+        <p:nvSpPr>
+          <p:cNvPr id="20" name="Race 2 value"/>
+          <p:cNvSpPr txBox="1"/>
+          <p:nvPr/>
+        </p:nvSpPr>
+        <p:spPr>
+          <a:xfrm>
+            <a:off x="5852160" y="2578608"/>
+            <a:ext cx="548640" cy="411480"/>
+          </a:xfrm>
+          <a:prstGeom prst="rect">
+            <a:avLst/>
+          </a:prstGeom>
+          <a:noFill/>
+          <a:ln/>
+        </p:spPr>
+        <p:txBody>
+          <a:bodyPr wrap="square" lIns="0" tIns="0" rIns="0" bIns="0" rtlCol="0" anchor="ctr"/>
+          <a:lstStyle/>
+          <a:p>
+            <a:pPr indent="0" marL="0">
+              <a:buNone/>
+            </a:pPr>
+            <a:r>
+              <a:rPr lang="en-US" sz="2200" b="1" dirty="0">
+                <a:solidFill>
+                  <a:schemeClr val="accent2"/>
+                </a:solidFill>
+              </a:rPr>
+              <a:t>20</a:t>
+            </a:r>
+            <a:endParaRPr lang="en-US" sz="2200" dirty="0"/>
+          </a:p>
+        </p:txBody>
+      </p:sp>
+      <p:sp>
+        <p:nvSpPr>
+          <p:cNvPr id="21" name="Race 2 text"/>
+          <p:cNvSpPr txBox="1"/>
+          <p:nvPr/>
+        </p:nvSpPr>
+        <p:spPr>
+          <a:xfrm>
+            <a:off x="6446520" y="2578608"/>
+            <a:ext cx="2148840" cy="411480"/>
+          </a:xfrm>
+          <a:prstGeom prst="rect">
+            <a:avLst/>
+          </a:prstGeom>
+          <a:noFill/>
+          <a:ln/>
+        </p:spPr>
+        <p:txBody>
+          <a:bodyPr wrap="square" lIns="0" tIns="0" rIns="0" bIns="0" rtlCol="0" anchor="ctr"/>
+          <a:lstStyle/>
+          <a:p>
+            <a:pPr indent="0" marL="0">
+              <a:buNone/>
+            </a:pPr>
+            <a:r>
+              <a:rPr lang="en-US" sz="1200" dirty="0">
+                <a:solidFill>
+                  <a:schemeClr val="bg1"/>
+                </a:solidFill>
+              </a:rPr>
+              <a:t>duplicates answered with the stored order</a:t>
+            </a:r>
+            <a:endParaRPr lang="en-US" sz="1200" dirty="0"/>
+          </a:p>
+        </p:txBody>
+      </p:sp>
+      <p:sp>
+        <p:nvSpPr>
+          <p:cNvPr id="22" name="Race 3 value"/>
+          <p:cNvSpPr txBox="1"/>
+          <p:nvPr/>
+        </p:nvSpPr>
+        <p:spPr>
+          <a:xfrm>
+            <a:off x="5852160" y="3054096"/>
+            <a:ext cx="548640" cy="411480"/>
+          </a:xfrm>
+          <a:prstGeom prst="rect">
+            <a:avLst/>
+          </a:prstGeom>
+          <a:noFill/>
+          <a:ln/>
+        </p:spPr>
+        <p:txBody>
+          <a:bodyPr wrap="square" lIns="0" tIns="0" rIns="0" bIns="0" rtlCol="0" anchor="ctr"/>
+          <a:lstStyle/>
+          <a:p>
+            <a:pPr indent="0" marL="0">
+              <a:buNone/>
+            </a:pPr>
+            <a:r>
+              <a:rPr lang="en-US" sz="2200" b="1" dirty="0">
+                <a:solidFill>
+                  <a:schemeClr val="accent2"/>
+                </a:solidFill>
+              </a:rPr>
+              <a:t>20</a:t>
+            </a:r>
+            <a:endParaRPr lang="en-US" sz="2200" dirty="0"/>
+          </a:p>
+        </p:txBody>
+      </p:sp>
+      <p:sp>
+        <p:nvSpPr>
+          <p:cNvPr id="23" name="Race 3 text"/>
+          <p:cNvSpPr txBox="1"/>
+          <p:nvPr/>
+        </p:nvSpPr>
+        <p:spPr>
+          <a:xfrm>
+            <a:off x="6446520" y="3054096"/>
+            <a:ext cx="2148840" cy="411480"/>
+          </a:xfrm>
+          <a:prstGeom prst="rect">
+            <a:avLst/>
+          </a:prstGeom>
+          <a:noFill/>
+          <a:ln/>
+        </p:spPr>
+        <p:txBody>
+          <a:bodyPr wrap="square" lIns="0" tIns="0" rIns="0" bIns="0" rtlCol="0" anchor="ctr"/>
+          <a:lstStyle/>
+          <a:p>
+            <a:pPr indent="0" marL="0">
+              <a:buNone/>
+            </a:pPr>
+            <a:r>
+              <a:rPr lang="en-US" sz="1200" dirty="0">
+                <a:solidFill>
+                  <a:schemeClr val="bg1"/>
+                </a:solidFill>
+              </a:rPr>
+              <a:t>rejected as sold out</a:t>
+            </a:r>
+            <a:endParaRPr lang="en-US" sz="1200" dirty="0"/>
+          </a:p>
+        </p:txBody>
+      </p:sp>
+      <p:sp>
+        <p:nvSpPr>
+          <p:cNvPr id="24" name="Race 4 value"/>
+          <p:cNvSpPr txBox="1"/>
+          <p:nvPr/>
+        </p:nvSpPr>
+        <p:spPr>
+          <a:xfrm>
+            <a:off x="5852160" y="3529584"/>
+            <a:ext cx="548640" cy="411480"/>
+          </a:xfrm>
+          <a:prstGeom prst="rect">
+            <a:avLst/>
+          </a:prstGeom>
+          <a:noFill/>
+          <a:ln/>
+        </p:spPr>
+        <p:txBody>
+          <a:bodyPr wrap="square" lIns="0" tIns="0" rIns="0" bIns="0" rtlCol="0" anchor="ctr"/>
+          <a:lstStyle/>
+          <a:p>
+            <a:pPr indent="0" marL="0">
+              <a:buNone/>
+            </a:pPr>
+            <a:r>
+              <a:rPr lang="en-US" sz="2200" b="1" dirty="0">
+                <a:solidFill>
+                  <a:schemeClr val="accent2"/>
+                </a:solidFill>
+              </a:rPr>
+              <a:t>0</a:t>
+            </a:r>
+            <a:endParaRPr lang="en-US" sz="2200" dirty="0"/>
+          </a:p>
+        </p:txBody>
+      </p:sp>
+      <p:sp>
+        <p:nvSpPr>
+          <p:cNvPr id="25" name="Race 4 text"/>
+          <p:cNvSpPr txBox="1"/>
+          <p:nvPr/>
+        </p:nvSpPr>
+        <p:spPr>
+          <a:xfrm>
+            <a:off x="6446520" y="3529584"/>
+            <a:ext cx="2148840" cy="411480"/>
+          </a:xfrm>
+          <a:prstGeom prst="rect">
+            <a:avLst/>
+          </a:prstGeom>
+          <a:noFill/>
+          <a:ln/>
+        </p:spPr>
+        <p:txBody>
+          <a:bodyPr wrap="square" lIns="0" tIns="0" rIns="0" bIns="0" rtlCol="0" anchor="ctr"/>
+          <a:lstStyle/>
+          <a:p>
+            <a:pPr indent="0" marL="0">
+              <a:buNone/>
+            </a:pPr>
+            <a:r>
+              <a:rPr lang="en-US" sz="1200" dirty="0">
+                <a:solidFill>
+                  <a:schemeClr val="bg1"/>
+                </a:solidFill>
+              </a:rPr>
+              <a:t>server errors; stock exactly 0</a:t>
+            </a:r>
+            <a:endParaRPr lang="en-US" sz="1200" dirty="0"/>
+          </a:p>
+        </p:txBody>
+      </p:sp>
+      <p:sp>
+        <p:nvSpPr>
+          <p:cNvPr id="26" name="Honesty card"/>
+          <p:cNvSpPr/>
+          <p:nvPr/>
+        </p:nvSpPr>
+        <p:spPr>
+          <a:xfrm>
+            <a:off x="457200" y="4206240"/>
+            <a:ext cx="8229600" cy="457200"/>
+          </a:xfrm>
+          <a:prstGeom prst="roundRect">
+            <a:avLst>
+              <a:gd name="adj" fmla="val 16000"/>
             </a:avLst>
           </a:prstGeom>
           <a:solidFill>
@@ -13093,14 +13826,14 @@
       </p:sp>
       <p:sp>
         <p:nvSpPr>
-          <p:cNvPr id="7" name="Quality heading"/>
+          <p:cNvPr id="27" name="Honesty text"/>
           <p:cNvSpPr txBox="1"/>
           <p:nvPr/>
         </p:nvSpPr>
         <p:spPr>
           <a:xfrm>
-            <a:off x="4937760" y="1188720"/>
-            <a:ext cx="3566160" cy="320040"/>
+            <a:off x="594360" y="4206240"/>
+            <a:ext cx="7955280" cy="457200"/>
           </a:xfrm>
           <a:prstGeom prst="rect">
             <a:avLst/>
@@ -13109,176 +13842,19 @@
           <a:ln/>
         </p:spPr>
         <p:txBody>
-          <a:bodyPr wrap="square" lIns="0" tIns="0" rIns="0" bIns="0" rtlCol="0" anchor="t"/>
+          <a:bodyPr wrap="square" lIns="0" tIns="0" rIns="0" bIns="0" rtlCol="0" anchor="ctr"/>
           <a:lstStyle/>
           <a:p>
             <a:pPr indent="0" marL="0">
               <a:buNone/>
             </a:pPr>
             <a:r>
-              <a:rPr lang="en-US" sz="1600" b="1" dirty="0">
-                <a:solidFill>
-                  <a:schemeClr val="accent1"/>
-                </a:solidFill>
-              </a:rPr>
-              <a:t>Quality attributes</a:t>
-            </a:r>
-            <a:endParaRPr lang="en-US" sz="1600" dirty="0"/>
-          </a:p>
-        </p:txBody>
-      </p:sp>
-      <p:sp>
-        <p:nvSpPr>
-          <p:cNvPr id="8" name="Quality steps"/>
-          <p:cNvSpPr txBox="1"/>
-          <p:nvPr/>
-        </p:nvSpPr>
-        <p:spPr>
-          <a:xfrm>
-            <a:off x="4937760" y="1600200"/>
-            <a:ext cx="3566160" cy="2377440"/>
-          </a:xfrm>
-          <a:prstGeom prst="rect">
-            <a:avLst/>
-          </a:prstGeom>
-          <a:noFill/>
-          <a:ln/>
-        </p:spPr>
-        <p:txBody>
-          <a:bodyPr wrap="square" lIns="0" tIns="0" rIns="0" bIns="0" rtlCol="0" anchor="t"/>
-          <a:lstStyle/>
-          <a:p>
-            <a:pPr marL="177800" indent="-177800">
-              <a:spcAft>
-                <a:spcPts val="600"/>
-              </a:spcAft>
-              <a:buSzPct val="100000"/>
-              <a:buChar char="•"/>
-            </a:pPr>
-            <a:r>
-              <a:rPr lang="en-US" sz="1600" dirty="0">
+              <a:rPr lang="en-US" sz="1300" b="1" dirty="0">
                 <a:solidFill>
                   <a:schemeClr val="tx1"/>
                 </a:solidFill>
               </a:rPr>
-              <a:t>Consistency: a declined payment changes nothing</a:t>
-            </a:r>
-            <a:endParaRPr lang="en-US" sz="1600" dirty="0"/>
-          </a:p>
-          <a:p>
-            <a:pPr marL="177800" indent="-177800">
-              <a:spcAft>
-                <a:spcPts val="600"/>
-              </a:spcAft>
-              <a:buSzPct val="100000"/>
-              <a:buChar char="•"/>
-            </a:pPr>
-            <a:r>
-              <a:rPr lang="en-US" sz="1600" dirty="0">
-                <a:solidFill>
-                  <a:schemeClr val="tx1"/>
-                </a:solidFill>
-              </a:rPr>
-              <a:t>Reliability: a retried payment returns the same order</a:t>
-            </a:r>
-            <a:endParaRPr lang="en-US" sz="1600" dirty="0"/>
-          </a:p>
-          <a:p>
-            <a:pPr marL="177800" indent="-177800">
-              <a:spcAft>
-                <a:spcPts val="600"/>
-              </a:spcAft>
-              <a:buSzPct val="100000"/>
-              <a:buChar char="•"/>
-            </a:pPr>
-            <a:r>
-              <a:rPr lang="en-US" sz="1600" dirty="0">
-                <a:solidFill>
-                  <a:schemeClr val="tx1"/>
-                </a:solidFill>
-              </a:rPr>
-              <a:t>Security: the old admin password is rejected</a:t>
-            </a:r>
-            <a:endParaRPr lang="en-US" sz="1600" dirty="0"/>
-          </a:p>
-          <a:p>
-            <a:pPr marL="177800" indent="-177800">
-              <a:spcAft>
-                <a:spcPts val="600"/>
-              </a:spcAft>
-              <a:buSzPct val="100000"/>
-              <a:buChar char="•"/>
-            </a:pPr>
-            <a:r>
-              <a:rPr lang="en-US" sz="1600" dirty="0">
-                <a:solidFill>
-                  <a:schemeClr val="tx1"/>
-                </a:solidFill>
-              </a:rPr>
-              <a:t>Maintainability: the pipeline run and a rollback drill</a:t>
-            </a:r>
-            <a:endParaRPr lang="en-US" sz="1600" dirty="0"/>
-          </a:p>
-        </p:txBody>
-      </p:sp>
-      <p:sp>
-        <p:nvSpPr>
-          <p:cNvPr id="9" name="Fallback card"/>
-          <p:cNvSpPr/>
-          <p:nvPr/>
-        </p:nvSpPr>
-        <p:spPr>
-          <a:xfrm>
-            <a:off x="457200" y="4206240"/>
-            <a:ext cx="8229600" cy="457200"/>
-          </a:xfrm>
-          <a:prstGeom prst="roundRect">
-            <a:avLst>
-              <a:gd name="adj" fmla="val 16000"/>
-            </a:avLst>
-          </a:prstGeom>
-          <a:solidFill>
-            <a:schemeClr val="tx1"/>
-          </a:solidFill>
-          <a:ln w="12700">
-            <a:solidFill>
-              <a:schemeClr val="tx1"/>
-            </a:solidFill>
-            <a:prstDash val="solid"/>
-          </a:ln>
-        </p:spPr>
-      </p:sp>
-      <p:sp>
-        <p:nvSpPr>
-          <p:cNvPr id="10" name="Fallback text"/>
-          <p:cNvSpPr txBox="1"/>
-          <p:nvPr/>
-        </p:nvSpPr>
-        <p:spPr>
-          <a:xfrm>
-            <a:off x="594360" y="4206240"/>
-            <a:ext cx="7955280" cy="457200"/>
-          </a:xfrm>
-          <a:prstGeom prst="rect">
-            <a:avLst/>
-          </a:prstGeom>
-          <a:noFill/>
-          <a:ln/>
-        </p:spPr>
-        <p:txBody>
-          <a:bodyPr wrap="square" lIns="0" tIns="0" rIns="0" bIns="0" rtlCol="0" anchor="ctr"/>
-          <a:lstStyle/>
-          <a:p>
-            <a:pPr indent="0" marL="0">
-              <a:buNone/>
-            </a:pPr>
-            <a:r>
-              <a:rPr lang="en-US" sz="1300" b="1" dirty="0">
-                <a:solidFill>
-                  <a:schemeClr val="bg1"/>
-                </a:solidFill>
-              </a:rPr>
-              <a:t>Backup: the scripted 19-step smoke test and a recording of the pipeline run.</a:t>
+              <a:t>Not shown: auto-scaling (replicas are added by hand) and queue-based scaling (there is no queue).</a:t>
             </a:r>
             <a:endParaRPr lang="en-US" sz="1300" dirty="0"/>
           </a:p>
@@ -14257,7 +14833,7 @@
                   <a:schemeClr val="tx1"/>
                 </a:solidFill>
               </a:rPr>
-              <a:t>Lessons and next steps</a:t>
+              <a:t>Demo plan (8 minutes)</a:t>
             </a:r>
             <a:endParaRPr lang="en-US" sz="3000" dirty="0"/>
           </a:p>
@@ -14265,18 +14841,18 @@
       </p:sp>
       <p:sp>
         <p:nvSpPr>
-          <p:cNvPr id="3" name="Lessons card"/>
+          <p:cNvPr id="3" name="Use cases card"/>
           <p:cNvSpPr/>
           <p:nvPr/>
         </p:nvSpPr>
         <p:spPr>
           <a:xfrm>
             <a:off x="457200" y="1097280"/>
-            <a:ext cx="4023360" cy="3474720"/>
+            <a:ext cx="4114800" cy="3017520"/>
           </a:xfrm>
           <a:prstGeom prst="roundRect">
             <a:avLst>
-              <a:gd name="adj" fmla="val 2105"/>
+              <a:gd name="adj" fmla="val 2424"/>
             </a:avLst>
           </a:prstGeom>
           <a:solidFill>
@@ -14292,7 +14868,7 @@
       </p:sp>
       <p:sp>
         <p:nvSpPr>
-          <p:cNvPr id="4" name="Lessons heading"/>
+          <p:cNvPr id="4" name="Use cases heading"/>
           <p:cNvSpPr txBox="1"/>
           <p:nvPr/>
         </p:nvSpPr>
@@ -14317,10 +14893,10 @@
             <a:r>
               <a:rPr lang="en-US" sz="1600" b="1" dirty="0">
                 <a:solidFill>
-                  <a:schemeClr val="accent3"/>
-                </a:solidFill>
-              </a:rPr>
-              <a:t>What we learned</a:t>
+                  <a:schemeClr val="accent1"/>
+                </a:solidFill>
+              </a:rPr>
+              <a:t>Use cases</a:t>
             </a:r>
             <a:endParaRPr lang="en-US" sz="1600" dirty="0"/>
           </a:p>
@@ -14328,14 +14904,14 @@
       </p:sp>
       <p:sp>
         <p:nvSpPr>
-          <p:cNvPr id="5" name="Lessons list"/>
+          <p:cNvPr id="5" name="Use case steps"/>
           <p:cNvSpPr txBox="1"/>
           <p:nvPr/>
         </p:nvSpPr>
         <p:spPr>
           <a:xfrm>
-            <a:off x="640080" y="1645920"/>
-            <a:ext cx="3657600" cy="2834640"/>
+            <a:off x="640080" y="1600200"/>
+            <a:ext cx="3749040" cy="2377440"/>
           </a:xfrm>
           <a:prstGeom prst="rect">
             <a:avLst/>
@@ -14347,93 +14923,94 @@
           <a:bodyPr wrap="square" lIns="0" tIns="0" rIns="0" bIns="0" rtlCol="0" anchor="t"/>
           <a:lstStyle/>
           <a:p>
-            <a:pPr marL="177800" indent="-177800">
+            <a:pPr marL="342900" indent="-342900">
               <a:spcAft>
-                <a:spcPts val="800"/>
+                <a:spcPts val="600"/>
               </a:spcAft>
               <a:buSzPct val="100000"/>
-              <a:buChar char="•"/>
-            </a:pPr>
-            <a:r>
-              <a:rPr lang="en-US" sz="1400" dirty="0">
+              <a:buFont typeface="+mj-lt"/>
+              <a:buAutoNum type="arabicPeriod" startAt="1"/>
+            </a:pPr>
+            <a:r>
+              <a:rPr lang="en-US" sz="1600" dirty="0">
                 <a:solidFill>
                   <a:schemeClr val="tx1"/>
                 </a:solidFill>
               </a:rPr>
-              <a:t>Keep authority on the server: prices, identity, totals</a:t>
-            </a:r>
-            <a:endParaRPr lang="en-US" sz="1400" dirty="0"/>
-          </a:p>
-          <a:p>
-            <a:pPr marL="177800" indent="-177800">
+              <a:t>Customer: sign in, fill cart, apply coupon, pay</a:t>
+            </a:r>
+            <a:endParaRPr lang="en-US" sz="1600" dirty="0"/>
+          </a:p>
+          <a:p>
+            <a:pPr marL="342900" indent="-342900">
               <a:spcAft>
-                <a:spcPts val="800"/>
+                <a:spcPts val="600"/>
               </a:spcAft>
               <a:buSzPct val="100000"/>
-              <a:buChar char="•"/>
-            </a:pPr>
-            <a:r>
-              <a:rPr lang="en-US" sz="1400" dirty="0">
+              <a:buFont typeface="+mj-lt"/>
+              <a:buAutoNum type="arabicPeriod" startAt="1"/>
+            </a:pPr>
+            <a:r>
+              <a:rPr lang="en-US" sz="1600" dirty="0">
                 <a:solidFill>
                   <a:schemeClr val="tx1"/>
                 </a:solidFill>
               </a:rPr>
-              <a:t>Let the database enforce what the code assumes</a:t>
-            </a:r>
-            <a:endParaRPr lang="en-US" sz="1400" dirty="0"/>
-          </a:p>
-          <a:p>
-            <a:pPr marL="177800" indent="-177800">
+              <a:t>Merchant: accept, prepare, mark ready</a:t>
+            </a:r>
+            <a:endParaRPr lang="en-US" sz="1600" dirty="0"/>
+          </a:p>
+          <a:p>
+            <a:pPr marL="342900" indent="-342900">
               <a:spcAft>
-                <a:spcPts val="800"/>
+                <a:spcPts val="600"/>
               </a:spcAft>
               <a:buSzPct val="100000"/>
-              <a:buChar char="•"/>
-            </a:pPr>
-            <a:r>
-              <a:rPr lang="en-US" sz="1400" dirty="0">
+              <a:buFont typeface="+mj-lt"/>
+              <a:buAutoNum type="arabicPeriod" startAt="1"/>
+            </a:pPr>
+            <a:r>
+              <a:rPr lang="en-US" sz="1600" dirty="0">
                 <a:solidFill>
                   <a:schemeClr val="tx1"/>
                 </a:solidFill>
               </a:rPr>
-              <a:t>Test on the real engine, from an empty database</a:t>
-            </a:r>
-            <a:endParaRPr lang="en-US" sz="1400" dirty="0"/>
-          </a:p>
-          <a:p>
-            <a:pPr marL="177800" indent="-177800">
-              <a:spcAft>
-                <a:spcPts val="800"/>
-              </a:spcAft>
+              <a:t>Rider: claim the order, deliver, complete</a:t>
+            </a:r>
+            <a:endParaRPr lang="en-US" sz="1600" dirty="0"/>
+          </a:p>
+          <a:p>
+            <a:pPr marL="342900" indent="-342900">
               <a:buSzPct val="100000"/>
-              <a:buChar char="•"/>
-            </a:pPr>
-            <a:r>
-              <a:rPr lang="en-US" sz="1400" dirty="0">
+              <a:buFont typeface="+mj-lt"/>
+              <a:buAutoNum type="arabicPeriod" startAt="1"/>
+            </a:pPr>
+            <a:r>
+              <a:rPr lang="en-US" sz="1600" dirty="0">
                 <a:solidFill>
                   <a:schemeClr val="tx1"/>
                 </a:solidFill>
               </a:rPr>
-              <a:t>Turn the demo into an automated smoke test</a:t>
-            </a:r>
-            <a:endParaRPr lang="en-US" sz="1400" dirty="0"/>
-          </a:p>
-        </p:txBody>
-      </p:sp>
-      <p:sp>
-        <p:nvSpPr>
-          <p:cNvPr id="6" name="Next steps card"/>
+              <a:t>Customer and administrator both see Completed</a:t>
+            </a:r>
+            <a:endParaRPr lang="en-US" sz="1600" dirty="0"/>
+          </a:p>
+        </p:txBody>
+      </p:sp>
+      <p:sp>
+        <p:nvSpPr>
+          <p:cNvPr id="6" name="Quality card"/>
           <p:cNvSpPr/>
           <p:nvPr/>
         </p:nvSpPr>
         <p:spPr>
           <a:xfrm>
-            <a:off x="4663440" y="1097280"/>
-            <a:ext cx="4023360" cy="3474720"/>
+            <a:off x="4754880" y="1097280"/>
+            <a:ext cx="3931920" cy="3017520"/>
           </a:xfrm>
           <a:prstGeom prst="roundRect">
             <a:avLst>
-              <a:gd name="adj" fmla="val 2105"/>
+              <a:gd name="adj" fmla="val 2424"/>
             </a:avLst>
           </a:prstGeom>
           <a:solidFill>
@@ -14449,14 +15026,14 @@
       </p:sp>
       <p:sp>
         <p:nvSpPr>
-          <p:cNvPr id="7" name="Next heading"/>
+          <p:cNvPr id="7" name="Quality heading"/>
           <p:cNvSpPr txBox="1"/>
           <p:nvPr/>
         </p:nvSpPr>
         <p:spPr>
           <a:xfrm>
-            <a:off x="4846320" y="1188720"/>
-            <a:ext cx="3657600" cy="320040"/>
+            <a:off x="4937760" y="1188720"/>
+            <a:ext cx="3566160" cy="320040"/>
           </a:xfrm>
           <a:prstGeom prst="rect">
             <a:avLst/>
@@ -14477,7 +15054,7 @@
                   <a:schemeClr val="accent1"/>
                 </a:solidFill>
               </a:rPr>
-              <a:t>What we would do next</a:t>
+              <a:t>Quality attributes</a:t>
             </a:r>
             <a:endParaRPr lang="en-US" sz="1600" dirty="0"/>
           </a:p>
@@ -14485,14 +15062,14 @@
       </p:sp>
       <p:sp>
         <p:nvSpPr>
-          <p:cNvPr id="8" name="Next list"/>
+          <p:cNvPr id="8" name="Quality steps"/>
           <p:cNvSpPr txBox="1"/>
           <p:nvPr/>
         </p:nvSpPr>
         <p:spPr>
           <a:xfrm>
-            <a:off x="4846320" y="1645920"/>
-            <a:ext cx="3657600" cy="2834640"/>
+            <a:off x="4937760" y="1600200"/>
+            <a:ext cx="3566160" cy="2377440"/>
           </a:xfrm>
           <a:prstGeom prst="rect">
             <a:avLst/>
@@ -14506,92 +15083,137 @@
           <a:p>
             <a:pPr marL="177800" indent="-177800">
               <a:spcAft>
-                <a:spcPts val="800"/>
+                <a:spcPts val="600"/>
               </a:spcAft>
               <a:buSzPct val="100000"/>
               <a:buChar char="•"/>
             </a:pPr>
             <a:r>
-              <a:rPr lang="en-US" sz="1400" dirty="0">
+              <a:rPr lang="en-US" sz="1600" dirty="0">
                 <a:solidFill>
                   <a:schemeClr val="tx1"/>
                 </a:solidFill>
               </a:rPr>
-              <a:t>Run several API replicas behind the proxy and measure with k6</a:t>
-            </a:r>
-            <a:endParaRPr lang="en-US" sz="1400" dirty="0"/>
+              <a:t>Scalability: k6 run with 1, 2 and 3 replicas (recorded)</a:t>
+            </a:r>
+            <a:endParaRPr lang="en-US" sz="1600" dirty="0"/>
           </a:p>
           <a:p>
             <a:pPr marL="177800" indent="-177800">
               <a:spcAft>
-                <a:spcPts val="800"/>
+                <a:spcPts val="600"/>
               </a:spcAft>
               <a:buSzPct val="100000"/>
               <a:buChar char="•"/>
             </a:pPr>
             <a:r>
-              <a:rPr lang="en-US" sz="1400" dirty="0">
+              <a:rPr lang="en-US" sz="1600" dirty="0">
                 <a:solidFill>
                   <a:schemeClr val="tx1"/>
                 </a:solidFill>
               </a:rPr>
-              <a:t>Deploy to a cloud host with scaling rules (Azure target)</a:t>
-            </a:r>
-            <a:endParaRPr lang="en-US" sz="1400" dirty="0"/>
+              <a:t>Consistency: race of 30 customers for 20 units, live</a:t>
+            </a:r>
+            <a:endParaRPr lang="en-US" sz="1600" dirty="0"/>
           </a:p>
           <a:p>
             <a:pPr marL="177800" indent="-177800">
               <a:spcAft>
-                <a:spcPts val="800"/>
+                <a:spcPts val="600"/>
               </a:spcAft>
               <a:buSzPct val="100000"/>
               <a:buChar char="•"/>
             </a:pPr>
             <a:r>
-              <a:rPr lang="en-US" sz="1400" dirty="0">
+              <a:rPr lang="en-US" sz="1600" dirty="0">
                 <a:solidFill>
                   <a:schemeClr val="tx1"/>
                 </a:solidFill>
               </a:rPr>
-              <a:t>Connect a real payment provider behind the gateway interface</a:t>
-            </a:r>
-            <a:endParaRPr lang="en-US" sz="1400" dirty="0"/>
+              <a:t>Reliability: a declined payment changes nothing</a:t>
+            </a:r>
+            <a:endParaRPr lang="en-US" sz="1600" dirty="0"/>
           </a:p>
           <a:p>
             <a:pPr marL="177800" indent="-177800">
               <a:spcAft>
-                <a:spcPts val="800"/>
+                <a:spcPts val="600"/>
               </a:spcAft>
               <a:buSzPct val="100000"/>
               <a:buChar char="•"/>
             </a:pPr>
             <a:r>
-              <a:rPr lang="en-US" sz="1400" dirty="0">
+              <a:rPr lang="en-US" sz="1600" dirty="0">
                 <a:solidFill>
                   <a:schemeClr val="tx1"/>
                 </a:solidFill>
               </a:rPr>
-              <a:t>Rate-limit login; alert on audit events</a:t>
-            </a:r>
-            <a:endParaRPr lang="en-US" sz="1400" dirty="0"/>
-          </a:p>
-          <a:p>
-            <a:pPr marL="177800" indent="-177800">
-              <a:spcAft>
-                <a:spcPts val="800"/>
-              </a:spcAft>
-              <a:buSzPct val="100000"/>
-              <a:buChar char="•"/>
-            </a:pPr>
-            <a:r>
-              <a:rPr lang="en-US" sz="1400" dirty="0">
-                <a:solidFill>
-                  <a:schemeClr val="tx1"/>
-                </a:solidFill>
-              </a:rPr>
-              <a:t>Store uploaded dish images on a persistent volume</a:t>
-            </a:r>
-            <a:endParaRPr lang="en-US" sz="1400" dirty="0"/>
+              <a:t>Maintainability: pipeline run and rollback drill</a:t>
+            </a:r>
+            <a:endParaRPr lang="en-US" sz="1600" dirty="0"/>
+          </a:p>
+        </p:txBody>
+      </p:sp>
+      <p:sp>
+        <p:nvSpPr>
+          <p:cNvPr id="9" name="Fallback card"/>
+          <p:cNvSpPr/>
+          <p:nvPr/>
+        </p:nvSpPr>
+        <p:spPr>
+          <a:xfrm>
+            <a:off x="457200" y="4206240"/>
+            <a:ext cx="8229600" cy="457200"/>
+          </a:xfrm>
+          <a:prstGeom prst="roundRect">
+            <a:avLst>
+              <a:gd name="adj" fmla="val 16000"/>
+            </a:avLst>
+          </a:prstGeom>
+          <a:solidFill>
+            <a:schemeClr val="tx1"/>
+          </a:solidFill>
+          <a:ln w="12700">
+            <a:solidFill>
+              <a:schemeClr val="tx1"/>
+            </a:solidFill>
+            <a:prstDash val="solid"/>
+          </a:ln>
+        </p:spPr>
+      </p:sp>
+      <p:sp>
+        <p:nvSpPr>
+          <p:cNvPr id="10" name="Fallback text"/>
+          <p:cNvSpPr txBox="1"/>
+          <p:nvPr/>
+        </p:nvSpPr>
+        <p:spPr>
+          <a:xfrm>
+            <a:off x="594360" y="4206240"/>
+            <a:ext cx="7955280" cy="457200"/>
+          </a:xfrm>
+          <a:prstGeom prst="rect">
+            <a:avLst/>
+          </a:prstGeom>
+          <a:noFill/>
+          <a:ln/>
+        </p:spPr>
+        <p:txBody>
+          <a:bodyPr wrap="square" lIns="0" tIns="0" rIns="0" bIns="0" rtlCol="0" anchor="ctr"/>
+          <a:lstStyle/>
+          <a:p>
+            <a:pPr indent="0" marL="0">
+              <a:buNone/>
+            </a:pPr>
+            <a:r>
+              <a:rPr lang="en-US" sz="1300" b="1" dirty="0">
+                <a:solidFill>
+                  <a:schemeClr val="bg1"/>
+                </a:solidFill>
+              </a:rPr>
+              <a:t>Backup: the scripted 19-step smoke test and a recording of the pipeline run.</a:t>
+            </a:r>
+            <a:endParaRPr lang="en-US" sz="1300" dirty="0"/>
           </a:p>
         </p:txBody>
       </p:sp>
@@ -14667,6 +15289,444 @@
       </p:grpSpPr>
       <p:sp>
         <p:nvSpPr>
+          <p:cNvPr id="2" name="Title"/>
+          <p:cNvSpPr txBox="1"/>
+          <p:nvPr/>
+        </p:nvSpPr>
+        <p:spPr>
+          <a:xfrm>
+            <a:off x="457200" y="274320"/>
+            <a:ext cx="8229600" cy="685800"/>
+          </a:xfrm>
+          <a:prstGeom prst="rect">
+            <a:avLst/>
+          </a:prstGeom>
+          <a:noFill/>
+          <a:ln/>
+        </p:spPr>
+        <p:txBody>
+          <a:bodyPr wrap="square" lIns="0" tIns="0" rIns="0" bIns="0" rtlCol="0" anchor="ctr"/>
+          <a:lstStyle/>
+          <a:p>
+            <a:pPr indent="0" marL="0">
+              <a:buNone/>
+            </a:pPr>
+            <a:r>
+              <a:rPr lang="en-US" sz="3000" b="1" dirty="0">
+                <a:solidFill>
+                  <a:schemeClr val="tx1"/>
+                </a:solidFill>
+              </a:rPr>
+              <a:t>Lessons and next steps</a:t>
+            </a:r>
+            <a:endParaRPr lang="en-US" sz="3000" dirty="0"/>
+          </a:p>
+        </p:txBody>
+      </p:sp>
+      <p:sp>
+        <p:nvSpPr>
+          <p:cNvPr id="3" name="Lessons card"/>
+          <p:cNvSpPr/>
+          <p:nvPr/>
+        </p:nvSpPr>
+        <p:spPr>
+          <a:xfrm>
+            <a:off x="457200" y="1097280"/>
+            <a:ext cx="4023360" cy="3474720"/>
+          </a:xfrm>
+          <a:prstGeom prst="roundRect">
+            <a:avLst>
+              <a:gd name="adj" fmla="val 2105"/>
+            </a:avLst>
+          </a:prstGeom>
+          <a:solidFill>
+            <a:schemeClr val="bg2"/>
+          </a:solidFill>
+          <a:ln w="12700">
+            <a:solidFill>
+              <a:schemeClr val="bg2"/>
+            </a:solidFill>
+            <a:prstDash val="solid"/>
+          </a:ln>
+        </p:spPr>
+      </p:sp>
+      <p:sp>
+        <p:nvSpPr>
+          <p:cNvPr id="4" name="Lessons heading"/>
+          <p:cNvSpPr txBox="1"/>
+          <p:nvPr/>
+        </p:nvSpPr>
+        <p:spPr>
+          <a:xfrm>
+            <a:off x="640080" y="1188720"/>
+            <a:ext cx="3657600" cy="320040"/>
+          </a:xfrm>
+          <a:prstGeom prst="rect">
+            <a:avLst/>
+          </a:prstGeom>
+          <a:noFill/>
+          <a:ln/>
+        </p:spPr>
+        <p:txBody>
+          <a:bodyPr wrap="square" lIns="0" tIns="0" rIns="0" bIns="0" rtlCol="0" anchor="t"/>
+          <a:lstStyle/>
+          <a:p>
+            <a:pPr indent="0" marL="0">
+              <a:buNone/>
+            </a:pPr>
+            <a:r>
+              <a:rPr lang="en-US" sz="1600" b="1" dirty="0">
+                <a:solidFill>
+                  <a:schemeClr val="accent3"/>
+                </a:solidFill>
+              </a:rPr>
+              <a:t>What we learned</a:t>
+            </a:r>
+            <a:endParaRPr lang="en-US" sz="1600" dirty="0"/>
+          </a:p>
+        </p:txBody>
+      </p:sp>
+      <p:sp>
+        <p:nvSpPr>
+          <p:cNvPr id="5" name="Lessons list"/>
+          <p:cNvSpPr txBox="1"/>
+          <p:nvPr/>
+        </p:nvSpPr>
+        <p:spPr>
+          <a:xfrm>
+            <a:off x="640080" y="1645920"/>
+            <a:ext cx="3657600" cy="2834640"/>
+          </a:xfrm>
+          <a:prstGeom prst="rect">
+            <a:avLst/>
+          </a:prstGeom>
+          <a:noFill/>
+          <a:ln/>
+        </p:spPr>
+        <p:txBody>
+          <a:bodyPr wrap="square" lIns="0" tIns="0" rIns="0" bIns="0" rtlCol="0" anchor="t"/>
+          <a:lstStyle/>
+          <a:p>
+            <a:pPr marL="177800" indent="-177800">
+              <a:spcAft>
+                <a:spcPts val="800"/>
+              </a:spcAft>
+              <a:buSzPct val="100000"/>
+              <a:buChar char="•"/>
+            </a:pPr>
+            <a:r>
+              <a:rPr lang="en-US" sz="1400" dirty="0">
+                <a:solidFill>
+                  <a:schemeClr val="tx1"/>
+                </a:solidFill>
+              </a:rPr>
+              <a:t>Keep authority on the server: prices, identity, totals</a:t>
+            </a:r>
+            <a:endParaRPr lang="en-US" sz="1400" dirty="0"/>
+          </a:p>
+          <a:p>
+            <a:pPr marL="177800" indent="-177800">
+              <a:spcAft>
+                <a:spcPts val="800"/>
+              </a:spcAft>
+              <a:buSzPct val="100000"/>
+              <a:buChar char="•"/>
+            </a:pPr>
+            <a:r>
+              <a:rPr lang="en-US" sz="1400" dirty="0">
+                <a:solidFill>
+                  <a:schemeClr val="tx1"/>
+                </a:solidFill>
+              </a:rPr>
+              <a:t>Let the database enforce what the code assumes</a:t>
+            </a:r>
+            <a:endParaRPr lang="en-US" sz="1400" dirty="0"/>
+          </a:p>
+          <a:p>
+            <a:pPr marL="177800" indent="-177800">
+              <a:spcAft>
+                <a:spcPts val="800"/>
+              </a:spcAft>
+              <a:buSzPct val="100000"/>
+              <a:buChar char="•"/>
+            </a:pPr>
+            <a:r>
+              <a:rPr lang="en-US" sz="1400" dirty="0">
+                <a:solidFill>
+                  <a:schemeClr val="tx1"/>
+                </a:solidFill>
+              </a:rPr>
+              <a:t>Test on the real engine, from an empty database</a:t>
+            </a:r>
+            <a:endParaRPr lang="en-US" sz="1400" dirty="0"/>
+          </a:p>
+          <a:p>
+            <a:pPr marL="177800" indent="-177800">
+              <a:spcAft>
+                <a:spcPts val="800"/>
+              </a:spcAft>
+              <a:buSzPct val="100000"/>
+              <a:buChar char="•"/>
+            </a:pPr>
+            <a:r>
+              <a:rPr lang="en-US" sz="1400" dirty="0">
+                <a:solidFill>
+                  <a:schemeClr val="tx1"/>
+                </a:solidFill>
+              </a:rPr>
+              <a:t>Turn the demo into an automated smoke test</a:t>
+            </a:r>
+            <a:endParaRPr lang="en-US" sz="1400" dirty="0"/>
+          </a:p>
+        </p:txBody>
+      </p:sp>
+      <p:sp>
+        <p:nvSpPr>
+          <p:cNvPr id="6" name="Next steps card"/>
+          <p:cNvSpPr/>
+          <p:nvPr/>
+        </p:nvSpPr>
+        <p:spPr>
+          <a:xfrm>
+            <a:off x="4663440" y="1097280"/>
+            <a:ext cx="4023360" cy="3474720"/>
+          </a:xfrm>
+          <a:prstGeom prst="roundRect">
+            <a:avLst>
+              <a:gd name="adj" fmla="val 2105"/>
+            </a:avLst>
+          </a:prstGeom>
+          <a:solidFill>
+            <a:schemeClr val="bg2"/>
+          </a:solidFill>
+          <a:ln w="12700">
+            <a:solidFill>
+              <a:schemeClr val="bg2"/>
+            </a:solidFill>
+            <a:prstDash val="solid"/>
+          </a:ln>
+        </p:spPr>
+      </p:sp>
+      <p:sp>
+        <p:nvSpPr>
+          <p:cNvPr id="7" name="Next heading"/>
+          <p:cNvSpPr txBox="1"/>
+          <p:nvPr/>
+        </p:nvSpPr>
+        <p:spPr>
+          <a:xfrm>
+            <a:off x="4846320" y="1188720"/>
+            <a:ext cx="3657600" cy="320040"/>
+          </a:xfrm>
+          <a:prstGeom prst="rect">
+            <a:avLst/>
+          </a:prstGeom>
+          <a:noFill/>
+          <a:ln/>
+        </p:spPr>
+        <p:txBody>
+          <a:bodyPr wrap="square" lIns="0" tIns="0" rIns="0" bIns="0" rtlCol="0" anchor="t"/>
+          <a:lstStyle/>
+          <a:p>
+            <a:pPr indent="0" marL="0">
+              <a:buNone/>
+            </a:pPr>
+            <a:r>
+              <a:rPr lang="en-US" sz="1600" b="1" dirty="0">
+                <a:solidFill>
+                  <a:schemeClr val="accent1"/>
+                </a:solidFill>
+              </a:rPr>
+              <a:t>What we would do next</a:t>
+            </a:r>
+            <a:endParaRPr lang="en-US" sz="1600" dirty="0"/>
+          </a:p>
+        </p:txBody>
+      </p:sp>
+      <p:sp>
+        <p:nvSpPr>
+          <p:cNvPr id="8" name="Next list"/>
+          <p:cNvSpPr txBox="1"/>
+          <p:nvPr/>
+        </p:nvSpPr>
+        <p:spPr>
+          <a:xfrm>
+            <a:off x="4846320" y="1645920"/>
+            <a:ext cx="3657600" cy="2834640"/>
+          </a:xfrm>
+          <a:prstGeom prst="rect">
+            <a:avLst/>
+          </a:prstGeom>
+          <a:noFill/>
+          <a:ln/>
+        </p:spPr>
+        <p:txBody>
+          <a:bodyPr wrap="square" lIns="0" tIns="0" rIns="0" bIns="0" rtlCol="0" anchor="t"/>
+          <a:lstStyle/>
+          <a:p>
+            <a:pPr marL="177800" indent="-177800">
+              <a:spcAft>
+                <a:spcPts val="800"/>
+              </a:spcAft>
+              <a:buSzPct val="100000"/>
+              <a:buChar char="•"/>
+            </a:pPr>
+            <a:r>
+              <a:rPr lang="en-US" sz="1400" dirty="0">
+                <a:solidFill>
+                  <a:schemeClr val="tx1"/>
+                </a:solidFill>
+              </a:rPr>
+              <a:t>Deploy the same images to a managed platform with auto-scaling rules</a:t>
+            </a:r>
+            <a:endParaRPr lang="en-US" sz="1400" dirty="0"/>
+          </a:p>
+          <a:p>
+            <a:pPr marL="177800" indent="-177800">
+              <a:spcAft>
+                <a:spcPts val="800"/>
+              </a:spcAft>
+              <a:buSzPct val="100000"/>
+              <a:buChar char="•"/>
+            </a:pPr>
+            <a:r>
+              <a:rPr lang="en-US" sz="1400" dirty="0">
+                <a:solidFill>
+                  <a:schemeClr val="tx1"/>
+                </a:solidFill>
+              </a:rPr>
+              <a:t>Run migrations as a separate step before replicas start</a:t>
+            </a:r>
+            <a:endParaRPr lang="en-US" sz="1400" dirty="0"/>
+          </a:p>
+          <a:p>
+            <a:pPr marL="177800" indent="-177800">
+              <a:spcAft>
+                <a:spcPts val="800"/>
+              </a:spcAft>
+              <a:buSzPct val="100000"/>
+              <a:buChar char="•"/>
+            </a:pPr>
+            <a:r>
+              <a:rPr lang="en-US" sz="1400" dirty="0">
+                <a:solidFill>
+                  <a:schemeClr val="tx1"/>
+                </a:solidFill>
+              </a:rPr>
+              <a:t>Connect a real payment provider behind the gateway interface</a:t>
+            </a:r>
+            <a:endParaRPr lang="en-US" sz="1400" dirty="0"/>
+          </a:p>
+          <a:p>
+            <a:pPr marL="177800" indent="-177800">
+              <a:spcAft>
+                <a:spcPts val="800"/>
+              </a:spcAft>
+              <a:buSzPct val="100000"/>
+              <a:buChar char="•"/>
+            </a:pPr>
+            <a:r>
+              <a:rPr lang="en-US" sz="1400" dirty="0">
+                <a:solidFill>
+                  <a:schemeClr val="tx1"/>
+                </a:solidFill>
+              </a:rPr>
+              <a:t>Rate-limit login; alert on audit events</a:t>
+            </a:r>
+            <a:endParaRPr lang="en-US" sz="1400" dirty="0"/>
+          </a:p>
+          <a:p>
+            <a:pPr marL="177800" indent="-177800">
+              <a:spcAft>
+                <a:spcPts val="800"/>
+              </a:spcAft>
+              <a:buSzPct val="100000"/>
+              <a:buChar char="•"/>
+            </a:pPr>
+            <a:r>
+              <a:rPr lang="en-US" sz="1400" dirty="0">
+                <a:solidFill>
+                  <a:schemeClr val="tx1"/>
+                </a:solidFill>
+              </a:rPr>
+              <a:t>Store uploaded dish images on a persistent volume</a:t>
+            </a:r>
+            <a:endParaRPr lang="en-US" sz="1400" dirty="0"/>
+          </a:p>
+        </p:txBody>
+      </p:sp>
+      <p:sp>
+        <p:nvSpPr>
+          <p:cNvPr id="25" name="Slide Number Placeholder 0"/>
+          <p:cNvSpPr>
+            <a:spLocks noGrp="1"/>
+          </p:cNvSpPr>
+          <p:nvPr>
+            <p:ph type="sldNum" sz="quarter" idx="4294967295"/>
+          </p:nvPr>
+        </p:nvSpPr>
+        <p:spPr>
+          <a:xfrm>
+            <a:off x="8229600" y="4754880"/>
+            <a:ext cx="457200" cy="274320"/>
+          </a:xfrm>
+          <a:prstGeom prst="rect">
+            <a:avLst/>
+          </a:prstGeom>
+          <a:extLst>
+            <a:ext uri="{C572A759-6A51-4108-AA02-DFA0A04FC94B}">
+              <ma14:wrappingTextBoxFlag xmlns:ma14="http://schemas.microsoft.com/office/mac/drawingml/2011/main" val="0"/>
+            </a:ext>
+          </a:extLst>
+        </p:spPr>
+        <p:txBody>
+          <a:bodyPr/>
+          <a:lstStyle>
+            <a:lvl1pPr>
+              <a:defRPr sz="1000">
+                <a:solidFill>
+                  <a:schemeClr val="accent5"/>
+                </a:solidFill>
+              </a:defRPr>
+            </a:lvl1pPr>
+          </a:lstStyle>
+          <a:p>
+            <a:pPr algn="r"/>
+            <a:fld id="{F7021451-1387-4CA6-816F-3879F97B5CBC}" type="slidenum">
+              <a:rPr b="0" lang="en-US"/>
+              <a:t>21</a:t>
+            </a:fld>
+            <a:endParaRPr lang="en-US"/>
+          </a:p>
+        </p:txBody>
+      </p:sp>
+    </p:spTree>
+  </p:cSld>
+  <p:clrMapOvr>
+    <a:masterClrMapping/>
+  </p:clrMapOvr>
+</p:sld>
+</file>
+
+<file path=ppt/slides/slide22.xml><?xml version="1.0" encoding="utf-8"?>
+<p:sld xmlns:a="http://schemas.openxmlformats.org/drawingml/2006/main" xmlns:r="http://schemas.openxmlformats.org/officeDocument/2006/relationships" xmlns:p="http://schemas.openxmlformats.org/presentationml/2006/main">
+  <p:cSld name="Slide 22">
+    <p:spTree>
+      <p:nvGrpSpPr>
+        <p:cNvPr id="1" name=""/>
+        <p:cNvGrpSpPr/>
+        <p:nvPr/>
+      </p:nvGrpSpPr>
+      <p:grpSpPr>
+        <a:xfrm>
+          <a:off x="0" y="0"/>
+          <a:ext cx="0" cy="0"/>
+          <a:chOff x="0" y="0"/>
+          <a:chExt cx="0" cy="0"/>
+        </a:xfrm>
+      </p:grpSpPr>
+      <p:sp>
+        <p:nvSpPr>
           <p:cNvPr id="2" name="Closing title"/>
           <p:cNvSpPr txBox="1"/>
           <p:nvPr/>
@@ -14731,7 +15791,7 @@
                   <a:schemeClr val="accent2"/>
                 </a:solidFill>
               </a:rPr>
-              <a:t>JiKeDa  ·  Team 3</a:t>
+              <a:t>JiKeDa  ·  Team 3  ·  github.com/Friedriceee/5001</a:t>
             </a:r>
             <a:endParaRPr lang="en-US" sz="2000" dirty="0"/>
           </a:p>
@@ -16399,7 +17459,7 @@
                             <a:srgbClr val="000000"/>
                           </a:solidFill>
                         </a:rPr>
-                        <a:t>Docker Compose staging; no scale-out measurements yet</a:t>
+                        <a:t>Docker Compose staging; replicas scaled by hand and measured with k6</a:t>
                       </a:r>
                       <a:endParaRPr lang="en-US" sz="1200" dirty="0"/>
                     </a:p>
@@ -16457,10 +17517,10 @@
                       <a:r>
                         <a:rPr lang="en-US" sz="1200" b="1" dirty="0">
                           <a:solidFill>
-                            <a:schemeClr val="accent1"/>
+                            <a:srgbClr val="A86A00"/>
                           </a:solidFill>
                         </a:rPr>
-                        <a:t>Not built</a:t>
+                        <a:t>Partly</a:t>
                       </a:r>
                       <a:endParaRPr lang="en-US" sz="1200" dirty="0"/>
                     </a:p>
@@ -16891,7 +17951,7 @@
                             <a:srgbClr val="000000"/>
                           </a:solidFill>
                         </a:rPr>
-                        <a:t>Six CI gates, image scan, deploy, automatic rollback</a:t>
+                        <a:t>Six CI gates, image scan, deploy, automatic rollback; first CD run passed</a:t>
                       </a:r>
                       <a:endParaRPr lang="en-US" sz="1200" dirty="0"/>
                     </a:p>
@@ -16952,7 +18012,7 @@
                             <a:schemeClr val="accent3"/>
                           </a:solidFill>
                         </a:rPr>
-                        <a:t>Done, merge pending</a:t>
+                        <a:t>Done</a:t>
                       </a:r>
                       <a:endParaRPr lang="en-US" sz="1200" dirty="0"/>
                     </a:p>
@@ -17137,7 +18197,7 @@
                             <a:srgbClr val="000000"/>
                           </a:solidFill>
                         </a:rPr>
-                        <a:t>287 backend tests on PostgreSQL, 19-step smoke; no load test yet</a:t>
+                        <a:t>289 backend tests on PostgreSQL, 19-step smoke, k6 load and race tests</a:t>
                       </a:r>
                       <a:endParaRPr lang="en-US" sz="1200" dirty="0"/>
                     </a:p>
@@ -17195,10 +18255,10 @@
                       <a:r>
                         <a:rPr lang="en-US" sz="1200" b="1" dirty="0">
                           <a:solidFill>
-                            <a:srgbClr val="A86A00"/>
+                            <a:schemeClr val="accent3"/>
                           </a:solidFill>
                         </a:rPr>
-                        <a:t>Partly</a:t>
+                        <a:t>Done</a:t>
                       </a:r>
                       <a:endParaRPr lang="en-US" sz="1200" dirty="0"/>
                     </a:p>
@@ -17280,7 +18340,7 @@
                   <a:schemeClr val="tx2"/>
                 </a:solidFill>
               </a:rPr>
-              <a:t>Also open: the pull request with containers and CD awaits merge; about 64 backend messages are in Chinese; login has no rate limit.</a:t>
+              <a:t>Also open: no cloud deployment or auto-scaling; login has no rate limit; about 64 backend messages are in Chinese.</a:t>
             </a:r>
             <a:endParaRPr lang="en-US" sz="1100" dirty="0"/>
           </a:p>
@@ -18554,7 +19614,7 @@
                   <a:schemeClr val="accent5"/>
                 </a:solidFill>
               </a:rPr>
-              <a:t>Commit counts are a rough proxy, not a measure of effort.</a:t>
+              <a:t>Commits in the team's earlier repository: a rough proxy, not effort.</a:t>
             </a:r>
             <a:endParaRPr lang="en-US" sz="1100" dirty="0"/>
           </a:p>

</xml_diff>

<commit_message>
docs(presentation): add the microservices migration to the deck
- Status and decisions now tell one story: the order flow was made correct
  as a modular monolith first, then modules move into services.
- New slide "Modules into services": YARP gateway, Identity and Catalog
  done, Order and Fulfilment moving, one database per service.
- New slide "Across a service boundary: stock": idempotent reservation,
  the PostgreSQL race and replay results, /internal not exposed.
- Pipeline and green-build slides count the services jobs (8 CI jobs,
  53 service tests); demo plan, next steps and Q&A notes updated.
- Pink "MARKER" boxes and 【待…】 notes mark items teammates must fill in;
  remove the boxes before presenting (see the presenter notes).

Co-Authored-By: Claude Opus 5.5 <noreply@anthropic.com>
</commit_message>
<xml_diff>
--- a/docs/presentation/JiKeDa_Team3_Presentation.pptx
+++ b/docs/presentation/JiKeDa_Team3_Presentation.pptx
@@ -12,6 +12,7 @@
     <p:sldId id="260" r:id="rId6"/>
     <p:sldId id="261" r:id="rId7"/>
     <p:sldId id="262" r:id="rId8"/>
+    <p:sldId id="278" r:id="rId29"/>
     <p:sldId id="263" r:id="rId9"/>
     <p:sldId id="264" r:id="rId10"/>
     <p:sldId id="265" r:id="rId11"/>
@@ -19,6 +20,7 @@
     <p:sldId id="267" r:id="rId13"/>
     <p:sldId id="268" r:id="rId14"/>
     <p:sldId id="269" r:id="rId15"/>
+    <p:sldId id="279" r:id="rId30"/>
     <p:sldId id="270" r:id="rId16"/>
     <p:sldId id="271" r:id="rId17"/>
     <p:sldId id="272" r:id="rId18"/>
@@ -669,10 +671,14 @@
           <a:lstStyle/>
           <a:p>
             <a:r>
-              <a:rPr lang="en-US" dirty="0"/>
+              <a:t>【待队友】4 Physical Architecture 主讲人：____</a:t>
+            </a:r>
+          </a:p>
+          <a:p/>
+          <a:p>
+            <a:r>
               <a:t>About 2 minutes. The browser reaches one origin: nginx serves the Vue build and proxies /api to the API container, which talks to PostgreSQL. Containers are hardened: non-root, capabilities dropped, no database port published in staging. GitHub Actions builds and scans the images and pushes them to GHCR; the Compose host pulls them. Be explicit that the host today is a CI runner or a single server, not a cloud platform.</a:t>
             </a:r>
-            <a:endParaRPr lang="en-US" dirty="0"/>
           </a:p>
         </p:txBody>
       </p:sp>
@@ -1109,10 +1115,14 @@
           <a:lstStyle/>
           <a:p>
             <a:r>
-              <a:rPr lang="en-US" dirty="0"/>
+              <a:t>【待队友】5 DevOps 主讲人：____</a:t>
+            </a:r>
+          </a:p>
+          <a:p/>
+          <a:p>
+            <a:r>
               <a:t>About 1 minute. Source strategy: trunk-based with short-lived branches, protected main, squash merges. Artifacts: images are immutable and tagged by commit; two moving tags make rollback a one-line operation. Secrets are injected at deploy time; a secret scanner fails the build if one is committed.</a:t>
             </a:r>
-            <a:endParaRPr lang="en-US" dirty="0"/>
           </a:p>
         </p:txBody>
       </p:sp>
@@ -1549,10 +1559,14 @@
           <a:lstStyle/>
           <a:p>
             <a:r>
-              <a:rPr lang="en-US" dirty="0"/>
+              <a:t>【待队友】1 Overview 主讲人：____</a:t>
+            </a:r>
+          </a:p>
+          <a:p/>
+          <a:p>
+            <a:r>
               <a:t>About 1 minute. State the business problem in one sentence: four parties, one order, and the money and stock must stay consistent. Then walk quickly across the four role cards. Stress that each role has its own portal but works on the same order.</a:t>
             </a:r>
-            <a:endParaRPr lang="en-US" dirty="0"/>
           </a:p>
         </p:txBody>
       </p:sp>
@@ -1637,10 +1651,20 @@
           <a:lstStyle/>
           <a:p>
             <a:r>
-              <a:rPr lang="en-US" dirty="0"/>
-              <a:t>Demo, 8 minutes plus 2 for questions. Suggested split: use cases about 4.5 minutes; quality attributes about 3.5 minutes. Rehearse once on the staging stack before the session and keep the smoke script ready as a fallback in case of network trouble on Zoom. The guidelines ask for a quality attribute demo such as performance or scalability; if a scripted load test has been added by then, show its result here and update this slide.</a:t>
-            </a:r>
-            <a:endParaRPr lang="en-US" dirty="0"/>
+              <a:t>【待队友】6 Demo 主讲人：____</a:t>
+            </a:r>
+          </a:p>
+          <a:p/>
+          <a:p>
+            <a:r>
+              <a:t>【待队友】Demo 主讲：____；操作屏幕：____</a:t>
+            </a:r>
+          </a:p>
+          <a:p/>
+          <a:p>
+            <a:r>
+              <a:t>Demo, 8 minutes plus 2 for questions. Use cases about 4 minutes on the monolith stack: one order from the customer through merchant and rider to Completed. Quality attributes about 4 minutes: the recorded scale-test run, the race, the microservices smoke script (gateway, Catalog menu, reserve, replay, release), and the pipeline page. Have the recording ready in case Zoom or the stack misbehaves.</a:t>
+            </a:r>
           </a:p>
         </p:txBody>
       </p:sp>
@@ -1813,10 +1837,8 @@
           <a:lstStyle/>
           <a:p>
             <a:r>
-              <a:rPr lang="en-US" dirty="0"/>
-              <a:t>Q&amp;A. Likely questions: How would you scale it? (stateless API, replicas behind the proxy, one database; not done yet.) Why a monolith? (one transaction across cart, stock and order for a five-person team.) What if the payment provider is slow? (the charge happens inside the transaction today; a real provider would need a pending state and a webhook.) How is double charging prevented? (idempotency key unique per user plus the cart claim.)</a:t>
-            </a:r>
-            <a:endParaRPr lang="en-US" dirty="0"/>
+              <a:t>Q&amp;A. Likely questions: Why not microservices from the start? (checkout needed one transaction; we got it correct first, then split along module seams; Catalog moved without changing its rules.) How do services stay consistent without one transaction? (idempotent reservation keyed by reservationId, plus release on failure; events with an outbox next.) How would you scale it? (stateless services behind the gateway; measured 2.5x with three replicas; auto-scaling not built.) How is double charging prevented? (idempotency key unique per user plus the cart claim.)</a:t>
+            </a:r>
           </a:p>
         </p:txBody>
       </p:sp>
@@ -1849,6 +1871,146 @@
         <p14:creationId xmlns:p14="http://schemas.microsoft.com/office/powerpoint/2010/main" val="1024086991"/>
       </p:ext>
     </p:extLst>
+  </p:cSld>
+  <p:clrMapOvr>
+    <a:masterClrMapping/>
+  </p:clrMapOvr>
+</p:notes>
+</file>
+
+<file path=ppt/notesSlides/notesSlide23.xml><?xml version="1.0" encoding="utf-8"?>
+<p:notes xmlns:a="http://schemas.openxmlformats.org/drawingml/2006/main" xmlns:p="http://schemas.openxmlformats.org/presentationml/2006/main" xmlns:r="http://schemas.openxmlformats.org/officeDocument/2006/relationships">
+  <p:cSld>
+    <p:spTree>
+      <p:nvGrpSpPr>
+        <p:cNvPr id="1" name=""/>
+        <p:cNvGrpSpPr/>
+        <p:nvPr/>
+      </p:nvGrpSpPr>
+      <p:grpSpPr>
+        <a:xfrm>
+          <a:off x="0" y="0"/>
+          <a:ext cx="0" cy="0"/>
+          <a:chOff x="0" y="0"/>
+          <a:chExt cx="0" cy="0"/>
+        </a:xfrm>
+      </p:grpSpPr>
+      <p:sp>
+        <p:nvSpPr>
+          <p:cNvPr id="2" name="Slide Image Placeholder 1"/>
+          <p:cNvSpPr>
+            <a:spLocks noGrp="1"/>
+          </p:cNvSpPr>
+          <p:nvPr>
+            <p:ph type="sldImg" idx="2"/>
+          </p:nvPr>
+        </p:nvSpPr>
+        <p:spPr/>
+      </p:sp>
+      <p:sp>
+        <p:nvSpPr>
+          <p:cNvPr id="3" name="Notes Placeholder 2"/>
+          <p:cNvSpPr>
+            <a:spLocks noGrp="1"/>
+          </p:cNvSpPr>
+          <p:nvPr>
+            <p:ph type="body" idx="3" sz="quarter"/>
+          </p:nvPr>
+        </p:nvSpPr>
+        <p:spPr/>
+        <p:txBody>
+          <a:bodyPr/>
+          <a:lstStyle/>
+          <a:p>
+            <a:r>
+              <a:t>About 1.5 minutes. The browser talks only to the YARP gateway, which validates the JWT as defence in depth and adds a correlation id; each service still checks roles itself. Identity owns accounts and issues tokens; Catalog owns merchants, menus and stock. Each service has its own database and migrations, and none reads another's tables. Order and Fulfilment are being moved now; until then the monolith serves the full order flow, which is what the demo uses. 【待Member4/5】Update their status before Wednesday.</a:t>
+            </a:r>
+          </a:p>
+        </p:txBody>
+      </p:sp>
+      <p:sp>
+        <p:nvSpPr>
+          <p:cNvPr id="4" name="Slide Number Placeholder 3"/>
+          <p:cNvSpPr>
+            <a:spLocks noGrp="1"/>
+          </p:cNvSpPr>
+          <p:nvPr>
+            <p:ph type="sldNum" idx="5" sz="quarter"/>
+          </p:nvPr>
+        </p:nvSpPr>
+        <p:spPr/>
+      </p:sp>
+    </p:spTree>
+  </p:cSld>
+  <p:clrMapOvr>
+    <a:masterClrMapping/>
+  </p:clrMapOvr>
+</p:notes>
+</file>
+
+<file path=ppt/notesSlides/notesSlide24.xml><?xml version="1.0" encoding="utf-8"?>
+<p:notes xmlns:a="http://schemas.openxmlformats.org/drawingml/2006/main" xmlns:p="http://schemas.openxmlformats.org/presentationml/2006/main" xmlns:r="http://schemas.openxmlformats.org/officeDocument/2006/relationships">
+  <p:cSld>
+    <p:spTree>
+      <p:nvGrpSpPr>
+        <p:cNvPr id="1" name=""/>
+        <p:cNvGrpSpPr/>
+        <p:nvPr/>
+      </p:nvGrpSpPr>
+      <p:grpSpPr>
+        <a:xfrm>
+          <a:off x="0" y="0"/>
+          <a:ext cx="0" cy="0"/>
+          <a:chOff x="0" y="0"/>
+          <a:chExt cx="0" cy="0"/>
+        </a:xfrm>
+      </p:grpSpPr>
+      <p:sp>
+        <p:nvSpPr>
+          <p:cNvPr id="2" name="Slide Image Placeholder 1"/>
+          <p:cNvSpPr>
+            <a:spLocks noGrp="1"/>
+          </p:cNvSpPr>
+          <p:nvPr>
+            <p:ph type="sldImg" idx="2"/>
+          </p:nvPr>
+        </p:nvSpPr>
+        <p:spPr/>
+      </p:sp>
+      <p:sp>
+        <p:nvSpPr>
+          <p:cNvPr id="3" name="Notes Placeholder 2"/>
+          <p:cNvSpPr>
+            <a:spLocks noGrp="1"/>
+          </p:cNvSpPr>
+          <p:nvPr>
+            <p:ph type="body" idx="3" sz="quarter"/>
+          </p:nvPr>
+        </p:nvSpPr>
+        <p:spPr/>
+        <p:txBody>
+          <a:bodyPr/>
+          <a:lstStyle/>
+          <a:p>
+            <a:r>
+              <a:t>About 1.5 minutes. When stock moved into the Catalog service, checkout could no longer change stock inside its own transaction. Catalog therefore exposes an internal reservation API keyed by a reservation id chosen by Order: a retry returns the stored result instead of deducting again, and the stock check and subtraction are one SQL UPDATE, so PostgreSQL never oversells. The race and replay tests run on a real PostgreSQL in CI and are not allowed to be skipped. This is the price of splitting: the single transaction becomes an idempotent call plus a release on failure.</a:t>
+            </a:r>
+          </a:p>
+        </p:txBody>
+      </p:sp>
+      <p:sp>
+        <p:nvSpPr>
+          <p:cNvPr id="4" name="Slide Number Placeholder 3"/>
+          <p:cNvSpPr>
+            <a:spLocks noGrp="1"/>
+          </p:cNvSpPr>
+          <p:nvPr>
+            <p:ph type="sldNum" idx="5" sz="quarter"/>
+          </p:nvPr>
+        </p:nvSpPr>
+        <p:spPr/>
+      </p:sp>
+    </p:spTree>
   </p:cSld>
   <p:clrMapOvr>
     <a:masterClrMapping/>
@@ -1989,10 +2151,14 @@
           <a:lstStyle/>
           <a:p>
             <a:r>
-              <a:rPr lang="en-US" dirty="0"/>
-              <a:t>About 1 minute. The proposal promised four services on Azure with Service Bus and measured scale-out. We delivered one modular API on Docker Compose. THE TEAM MUST AGREE ON THE REASON for the change before Wednesday and state it here in one sentence; the technical argument available is that checkout changes cart, stock, coupons and the order in one database transaction. Be direct about what is not built (Azure, auto-scaling, menu display) and say what you show instead: replicas scaled by hand and measured with k6, and a consistency race.</a:t>
-            </a:r>
-            <a:endParaRPr lang="en-US" dirty="0"/>
+              <a:t>【待队友】2 Project Conduct 主讲人：____</a:t>
+            </a:r>
+          </a:p>
+          <a:p/>
+          <a:p>
+            <a:r>
+              <a:t>About 1 minute. The proposal promised four services on Azure with Service Bus. We built the whole order flow first as a modular monolith, because checkout must change cart, stock, coupons and the order in one transaction and we wanted it correct before distributing it. We are now moving the modules out one by one behind a YARP gateway: Identity and Catalog run as separate services with their own databases; Order and Fulfilment are being moved. 【待队友】Agree this sentence as a team. Be direct about what is not built: Azure, auto-scaling, the message bus.</a:t>
+            </a:r>
           </a:p>
         </p:txBody>
       </p:sp>
@@ -2165,10 +2331,14 @@
           <a:lstStyle/>
           <a:p>
             <a:r>
-              <a:rPr lang="en-US" dirty="0"/>
-              <a:t>About 1.5 minutes. Lead with the modular monolith: with five people and a checkout that touches cart, stock, coupons and orders, one transaction is worth more than service boundaries. Then the principle that the server is the authority. Mention that we kept clear seams, so the system can be split later if scale demands it.</a:t>
-            </a:r>
-            <a:endParaRPr lang="en-US" dirty="0"/>
+              <a:t>【待队友】3 Logical Architecture 主讲人：____</a:t>
+            </a:r>
+          </a:p>
+          <a:p/>
+          <a:p>
+            <a:r>
+              <a:t>About 1.5 minutes. Lead with the first decision: correctness first in one process, then a strangler migration. The module boundaries (interfaces such as PricingService and InventoryService) became the service boundaries, which is why Catalog moved without changing its rules. Then the principle that the server is the authority.</a:t>
+            </a:r>
           </a:p>
         </p:txBody>
       </p:sp>
@@ -2253,10 +2423,8 @@
           <a:lstStyle/>
           <a:p>
             <a:r>
-              <a:rPr lang="en-US" dirty="0"/>
-              <a:t>About 2 minutes. Walk left to right. One Vue single-page app serves four portals. The API is one deployable made of feature modules; cross-cutting concerns (authentication, role checks, the uniform response wrapper, exception filter, audit) apply to all of them. PostgreSQL is the only store. The payment provider is outside the boundary and sits behind an interface.</a:t>
-            </a:r>
-            <a:endParaRPr lang="en-US" dirty="0"/>
+              <a:t>About 2 minutes. Walk left to right. One Vue single-page app serves four portals. The API is one deployable made of feature modules; cross-cutting concerns (authentication, role checks, the uniform response wrapper, exception filter, audit) apply to all of them. PostgreSQL is the only store. The payment provider is outside the boundary and sits behind an interface. This is the module view of the domain. The next slide shows where each module runs today.</a:t>
+            </a:r>
           </a:p>
         </p:txBody>
       </p:sp>
@@ -3500,6 +3668,46 @@
           </a:p>
         </p:txBody>
       </p:sp>
+      <p:sp>
+        <p:nvSpPr>
+          <p:cNvPr id="18" name="MARKER 【待队友】确认每一节的主讲人（各节第一页"/>
+          <p:cNvSpPr txBox="1"/>
+          <p:nvPr/>
+        </p:nvSpPr>
+        <p:spPr>
+          <a:xfrm>
+            <a:off x="5120640" y="228600"/>
+            <a:ext cx="3566160" cy="502920"/>
+          </a:xfrm>
+          <a:prstGeom prst="rect">
+            <a:avLst/>
+          </a:prstGeom>
+          <a:solidFill>
+            <a:srgbClr val="FCE7F3"/>
+          </a:solidFill>
+          <a:ln>
+            <a:solidFill>
+              <a:srgbClr val="B0108A"/>
+            </a:solidFill>
+          </a:ln>
+        </p:spPr>
+        <p:txBody>
+          <a:bodyPr wrap="square" anchor="ctr" lIns="73152" rIns="73152">
+            <a:spAutoFit/>
+          </a:bodyPr>
+          <a:lstStyle/>
+          <a:p>
+            <a:r>
+              <a:rPr sz="1000" b="1">
+                <a:solidFill>
+                  <a:srgbClr val="B0108A"/>
+                </a:solidFill>
+              </a:rPr>
+              <a:t>【待队友】确认每一节的主讲人（各节第一页备注里有空位）</a:t>
+            </a:r>
+          </a:p>
+        </p:txBody>
+      </p:sp>
     </p:spTree>
   </p:cSld>
   <p:clrMapOvr>
@@ -4486,6 +4694,46 @@
               <a:t>10</a:t>
             </a:fld>
             <a:endParaRPr lang="en-US"/>
+          </a:p>
+        </p:txBody>
+      </p:sp>
+      <p:sp>
+        <p:nvSpPr>
+          <p:cNvPr id="29" name="MARKER 【待Azure】如果周二前部署到 Azu"/>
+          <p:cNvSpPr txBox="1"/>
+          <p:nvPr/>
+        </p:nvSpPr>
+        <p:spPr>
+          <a:xfrm>
+            <a:off x="5120640" y="347472"/>
+            <a:ext cx="3566160" cy="502920"/>
+          </a:xfrm>
+          <a:prstGeom prst="rect">
+            <a:avLst/>
+          </a:prstGeom>
+          <a:solidFill>
+            <a:srgbClr val="FCE7F3"/>
+          </a:solidFill>
+          <a:ln>
+            <a:solidFill>
+              <a:srgbClr val="B0108A"/>
+            </a:solidFill>
+          </a:ln>
+        </p:spPr>
+        <p:txBody>
+          <a:bodyPr wrap="square" anchor="ctr" lIns="73152" rIns="73152">
+            <a:spAutoFit/>
+          </a:bodyPr>
+          <a:lstStyle/>
+          <a:p>
+            <a:r>
+              <a:rPr sz="1000" b="1">
+                <a:solidFill>
+                  <a:srgbClr val="B0108A"/>
+                </a:solidFill>
+              </a:rPr>
+              <a:t>【待Azure】如果周二前部署到 Azure Container Apps，这页换成 Azure 图</a:t>
+            </a:r>
           </a:p>
         </p:txBody>
       </p:sp>
@@ -10557,7 +10805,7 @@
                   <a:schemeClr val="bg1"/>
                 </a:solidFill>
               </a:rPr>
-              <a:t>backend</a:t>
+              <a:t>backend + services</a:t>
             </a:r>
             <a:endParaRPr lang="en-US" sz="1100" dirty="0"/>
           </a:p>
@@ -10789,7 +11037,7 @@
                   <a:schemeClr val="bg1"/>
                 </a:solidFill>
               </a:rPr>
-              <a:t>container stack</a:t>
+              <a:t>container stacks</a:t>
             </a:r>
             <a:endParaRPr lang="en-US" sz="1100" dirty="0"/>
           </a:p>
@@ -10803,7 +11051,7 @@
                   <a:schemeClr val="bg1"/>
                 </a:solidFill>
               </a:rPr>
-              <a:t>smoke test</a:t>
+              <a:t>2 smoke tests</a:t>
             </a:r>
             <a:endParaRPr lang="en-US" sz="1100" dirty="0"/>
           </a:p>
@@ -11445,6 +11693,46 @@
               <a:t>16</a:t>
             </a:fld>
             <a:endParaRPr lang="en-US"/>
+          </a:p>
+        </p:txBody>
+      </p:sp>
+      <p:sp>
+        <p:nvSpPr>
+          <p:cNvPr id="26" name="MARKER 【可选】CD 运行页和回滚演练截图放备用"/>
+          <p:cNvSpPr txBox="1"/>
+          <p:nvPr/>
+        </p:nvSpPr>
+        <p:spPr>
+          <a:xfrm>
+            <a:off x="5120640" y="347472"/>
+            <a:ext cx="3566160" cy="502920"/>
+          </a:xfrm>
+          <a:prstGeom prst="rect">
+            <a:avLst/>
+          </a:prstGeom>
+          <a:solidFill>
+            <a:srgbClr val="FCE7F3"/>
+          </a:solidFill>
+          <a:ln>
+            <a:solidFill>
+              <a:srgbClr val="B0108A"/>
+            </a:solidFill>
+          </a:ln>
+        </p:spPr>
+        <p:txBody>
+          <a:bodyPr wrap="square" anchor="ctr" lIns="73152" rIns="73152">
+            <a:spAutoFit/>
+          </a:bodyPr>
+          <a:lstStyle/>
+          <a:p>
+            <a:r>
+              <a:rPr sz="1000" b="1">
+                <a:solidFill>
+                  <a:srgbClr val="B0108A"/>
+                </a:solidFill>
+              </a:rPr>
+              <a:t>【可选】CD 运行页和回滚演练截图放备用页</a:t>
+            </a:r>
           </a:p>
         </p:txBody>
       </p:sp>
@@ -11638,7 +11926,7 @@
                   <a:schemeClr val="tx1"/>
                 </a:solidFill>
               </a:rPr>
-              <a:t>run against real PostgreSQL 16, none skipped</a:t>
+              <a:t>on real PostgreSQL 16, none skipped; plus 53 service tests</a:t>
             </a:r>
             <a:endParaRPr lang="en-US" sz="1200" dirty="0"/>
           </a:p>
@@ -11971,7 +12259,7 @@
                   <a:schemeClr val="accent1"/>
                 </a:solidFill>
               </a:rPr>
-              <a:t>6</a:t>
+              <a:t>8</a:t>
             </a:r>
             <a:endParaRPr lang="en-US" sz="5400" dirty="0"/>
           </a:p>
@@ -12007,7 +12295,7 @@
                   <a:schemeClr val="tx1"/>
                 </a:solidFill>
               </a:rPr>
-              <a:t>CI gates</a:t>
+              <a:t>CI jobs</a:t>
             </a:r>
             <a:endParaRPr lang="en-US" sz="1700" dirty="0"/>
           </a:p>
@@ -12043,7 +12331,7 @@
                   <a:schemeClr val="tx1"/>
                 </a:solidFill>
               </a:rPr>
-              <a:t>tests, dependency scan, secret scan, container smoke, CodeQL</a:t>
+              <a:t>3 test jobs, 2 scans, 2 container smokes, CodeQL</a:t>
             </a:r>
             <a:endParaRPr lang="en-US" sz="1200" dirty="0"/>
           </a:p>
@@ -12079,7 +12367,7 @@
                   <a:schemeClr val="tx2"/>
                 </a:solidFill>
               </a:rPr>
-              <a:t>Green means: built from an empty database, tested on PostgreSQL, images start, one order is delivered end to end.</a:t>
+              <a:t>Green means: built from empty databases, tested on PostgreSQL, monolith and services start, one order is delivered.</a:t>
             </a:r>
             <a:endParaRPr lang="en-US" sz="1300" dirty="0"/>
           </a:p>
@@ -14932,7 +15220,7 @@
               <a:buAutoNum type="arabicPeriod" startAt="1"/>
             </a:pPr>
             <a:r>
-              <a:rPr lang="en-US" sz="1600" dirty="0">
+              <a:rPr lang="en-US" sz="1400" dirty="0">
                 <a:solidFill>
                   <a:schemeClr val="tx1"/>
                 </a:solidFill>
@@ -14951,7 +15239,7 @@
               <a:buAutoNum type="arabicPeriod" startAt="1"/>
             </a:pPr>
             <a:r>
-              <a:rPr lang="en-US" sz="1600" dirty="0">
+              <a:rPr lang="en-US" sz="1400" dirty="0">
                 <a:solidFill>
                   <a:schemeClr val="tx1"/>
                 </a:solidFill>
@@ -14970,7 +15258,7 @@
               <a:buAutoNum type="arabicPeriod" startAt="1"/>
             </a:pPr>
             <a:r>
-              <a:rPr lang="en-US" sz="1600" dirty="0">
+              <a:rPr lang="en-US" sz="1400" dirty="0">
                 <a:solidFill>
                   <a:schemeClr val="tx1"/>
                 </a:solidFill>
@@ -14986,7 +15274,7 @@
               <a:buAutoNum type="arabicPeriod" startAt="1"/>
             </a:pPr>
             <a:r>
-              <a:rPr lang="en-US" sz="1600" dirty="0">
+              <a:rPr lang="en-US" sz="1400" dirty="0">
                 <a:solidFill>
                   <a:schemeClr val="tx1"/>
                 </a:solidFill>
@@ -15089,12 +15377,12 @@
               <a:buChar char="•"/>
             </a:pPr>
             <a:r>
-              <a:rPr lang="en-US" sz="1600" dirty="0">
+              <a:rPr lang="en-US" sz="1400" dirty="0">
                 <a:solidFill>
                   <a:schemeClr val="tx1"/>
                 </a:solidFill>
               </a:rPr>
-              <a:t>Scalability: k6 run with 1, 2 and 3 replicas (recorded)</a:t>
+              <a:t>Scalability: k6 with 1, 2 and 3 replicas (recorded)</a:t>
             </a:r>
             <a:endParaRPr lang="en-US" sz="1600" dirty="0"/>
           </a:p>
@@ -15107,12 +15395,12 @@
               <a:buChar char="•"/>
             </a:pPr>
             <a:r>
-              <a:rPr lang="en-US" sz="1600" dirty="0">
+              <a:rPr lang="en-US" sz="1400" dirty="0">
                 <a:solidFill>
                   <a:schemeClr val="tx1"/>
                 </a:solidFill>
               </a:rPr>
-              <a:t>Consistency: race of 30 customers for 20 units, live</a:t>
+              <a:t>Consistency: 30 customers race for 20 units</a:t>
             </a:r>
             <a:endParaRPr lang="en-US" sz="1600" dirty="0"/>
           </a:p>
@@ -15125,12 +15413,12 @@
               <a:buChar char="•"/>
             </a:pPr>
             <a:r>
-              <a:rPr lang="en-US" sz="1600" dirty="0">
+              <a:rPr lang="en-US" sz="1400" dirty="0">
                 <a:solidFill>
                   <a:schemeClr val="tx1"/>
                 </a:solidFill>
               </a:rPr>
-              <a:t>Reliability: a declined payment changes nothing</a:t>
+              <a:t>Services: gateway → Catalog, a retried reservation</a:t>
             </a:r>
             <a:endParaRPr lang="en-US" sz="1600" dirty="0"/>
           </a:p>
@@ -15143,7 +15431,25 @@
               <a:buChar char="•"/>
             </a:pPr>
             <a:r>
-              <a:rPr lang="en-US" sz="1600" dirty="0">
+              <a:rPr lang="en-US" sz="1400" dirty="0">
+                <a:solidFill>
+                  <a:schemeClr val="tx1"/>
+                </a:solidFill>
+              </a:rPr>
+              <a:t>Reliability: a declined payment changes nothing</a:t>
+            </a:r>
+            <a:endParaRPr lang="en-US" sz="1600" dirty="0"/>
+          </a:p>
+          <a:p>
+            <a:pPr marL="177800" indent="-177800">
+              <a:spcAft>
+                <a:spcPts val="600"/>
+              </a:spcAft>
+              <a:buSzPct val="100000"/>
+              <a:buChar char="•"/>
+            </a:pPr>
+            <a:r>
+              <a:rPr lang="en-US" sz="1400" dirty="0">
                 <a:solidFill>
                   <a:schemeClr val="tx1"/>
                 </a:solidFill>
@@ -15577,7 +15883,7 @@
                   <a:schemeClr val="tx1"/>
                 </a:solidFill>
               </a:rPr>
-              <a:t>Deploy the same images to a managed platform with auto-scaling rules</a:t>
+              <a:t>Finish moving Order and Fulfilment; publish OrderConfirmed through an outbox</a:t>
             </a:r>
             <a:endParaRPr lang="en-US" sz="1400" dirty="0"/>
           </a:p>
@@ -15595,7 +15901,7 @@
                   <a:schemeClr val="tx1"/>
                 </a:solidFill>
               </a:rPr>
-              <a:t>Run migrations as a separate step before replicas start</a:t>
+              <a:t>Deploy the same images to a managed platform with auto-scaling rules</a:t>
             </a:r>
             <a:endParaRPr lang="en-US" sz="1400" dirty="0"/>
           </a:p>
@@ -15613,7 +15919,7 @@
                   <a:schemeClr val="tx1"/>
                 </a:solidFill>
               </a:rPr>
-              <a:t>Connect a real payment provider behind the gateway interface</a:t>
+              <a:t>Run migrations as a separate step before replicas start</a:t>
             </a:r>
             <a:endParaRPr lang="en-US" sz="1400" dirty="0"/>
           </a:p>
@@ -15631,7 +15937,7 @@
                   <a:schemeClr val="tx1"/>
                 </a:solidFill>
               </a:rPr>
-              <a:t>Rate-limit login; alert on audit events</a:t>
+              <a:t>Connect a real payment provider behind the gateway interface</a:t>
             </a:r>
             <a:endParaRPr lang="en-US" sz="1400" dirty="0"/>
           </a:p>
@@ -15649,7 +15955,7 @@
                   <a:schemeClr val="tx1"/>
                 </a:solidFill>
               </a:rPr>
-              <a:t>Store uploaded dish images on a persistent volume</a:t>
+              <a:t>Rate-limit login; alert on audit events</a:t>
             </a:r>
             <a:endParaRPr lang="en-US" sz="1400" dirty="0"/>
           </a:p>
@@ -15794,6 +16100,2508 @@
               <a:t>JiKeDa  ·  Team 3  ·  github.com/Friedriceee/5001</a:t>
             </a:r>
             <a:endParaRPr lang="en-US" sz="2000" dirty="0"/>
+          </a:p>
+        </p:txBody>
+      </p:sp>
+    </p:spTree>
+  </p:cSld>
+  <p:clrMapOvr>
+    <a:masterClrMapping/>
+  </p:clrMapOvr>
+</p:sld>
+</file>
+
+<file path=ppt/slides/slide23.xml><?xml version="1.0" encoding="utf-8"?>
+<p:sld xmlns:a="http://schemas.openxmlformats.org/drawingml/2006/main" xmlns:p="http://schemas.openxmlformats.org/presentationml/2006/main" xmlns:r="http://schemas.openxmlformats.org/officeDocument/2006/relationships">
+  <p:cSld>
+    <p:spTree>
+      <p:nvGrpSpPr>
+        <p:cNvPr id="1" name=""/>
+        <p:cNvGrpSpPr/>
+        <p:nvPr/>
+      </p:nvGrpSpPr>
+      <p:grpSpPr/>
+      <p:sp>
+        <p:nvSpPr>
+          <p:cNvPr id="2" name="Title"/>
+          <p:cNvSpPr txBox="1"/>
+          <p:nvPr/>
+        </p:nvSpPr>
+        <p:spPr>
+          <a:xfrm>
+            <a:off x="457200" y="274320"/>
+            <a:ext cx="8229600" cy="685800"/>
+          </a:xfrm>
+          <a:prstGeom prst="rect">
+            <a:avLst/>
+          </a:prstGeom>
+          <a:noFill/>
+          <a:ln/>
+        </p:spPr>
+        <p:txBody>
+          <a:bodyPr wrap="square" lIns="0" tIns="0" rIns="0" bIns="0" rtlCol="0" anchor="ctr"/>
+          <a:lstStyle/>
+          <a:p>
+            <a:pPr indent="0" marL="0">
+              <a:buNone/>
+            </a:pPr>
+            <a:r>
+              <a:rPr lang="en-US" sz="3000" b="1" dirty="0">
+                <a:solidFill>
+                  <a:schemeClr val="tx1"/>
+                </a:solidFill>
+              </a:rPr>
+              <a:t>Modules into services</a:t>
+            </a:r>
+            <a:endParaRPr lang="en-US" sz="3000" dirty="0"/>
+          </a:p>
+        </p:txBody>
+      </p:sp>
+      <p:sp>
+        <p:nvSpPr>
+          <p:cNvPr id="3" name="Clients card"/>
+          <p:cNvSpPr/>
+          <p:nvPr/>
+        </p:nvSpPr>
+        <p:spPr>
+          <a:xfrm>
+            <a:off x="365760" y="1188720"/>
+            <a:ext cx="1554480" cy="3108960"/>
+          </a:xfrm>
+          <a:prstGeom prst="roundRect">
+            <a:avLst>
+              <a:gd name="adj" fmla="val 4706"/>
+            </a:avLst>
+          </a:prstGeom>
+          <a:solidFill>
+            <a:schemeClr val="bg2"/>
+          </a:solidFill>
+          <a:ln w="12700">
+            <a:solidFill>
+              <a:schemeClr val="bg2"/>
+            </a:solidFill>
+            <a:prstDash val="solid"/>
+          </a:ln>
+        </p:spPr>
+      </p:sp>
+      <p:sp>
+        <p:nvSpPr>
+          <p:cNvPr id="4" name="Clients heading"/>
+          <p:cNvSpPr txBox="1"/>
+          <p:nvPr/>
+        </p:nvSpPr>
+        <p:spPr>
+          <a:xfrm>
+            <a:off x="457200" y="1280160"/>
+            <a:ext cx="1371600" cy="457200"/>
+          </a:xfrm>
+          <a:prstGeom prst="rect">
+            <a:avLst/>
+          </a:prstGeom>
+          <a:noFill/>
+          <a:ln/>
+        </p:spPr>
+        <p:txBody>
+          <a:bodyPr wrap="square" lIns="0" tIns="0" rIns="0" bIns="0" rtlCol="0" anchor="t"/>
+          <a:lstStyle/>
+          <a:p>
+            <a:pPr algn="ctr" indent="0" marL="0">
+              <a:buNone/>
+            </a:pPr>
+            <a:r>
+              <a:rPr lang="en-US" sz="1200" b="1" dirty="0">
+                <a:solidFill>
+                  <a:schemeClr val="tx1"/>
+                </a:solidFill>
+              </a:rPr>
+              <a:t>Vue 3 single-page app</a:t>
+            </a:r>
+            <a:endParaRPr lang="en-US" sz="1200" dirty="0"/>
+          </a:p>
+        </p:txBody>
+      </p:sp>
+      <p:sp>
+        <p:nvSpPr>
+          <p:cNvPr id="5" name="Customer portal"/>
+          <p:cNvSpPr txBox="1"/>
+          <p:nvPr/>
+        </p:nvSpPr>
+        <p:spPr>
+          <a:xfrm>
+            <a:off x="502920" y="1828800"/>
+            <a:ext cx="1280160" cy="411480"/>
+          </a:xfrm>
+          <a:prstGeom prst="roundRect">
+            <a:avLst>
+              <a:gd name="adj" fmla="val 13333"/>
+            </a:avLst>
+          </a:prstGeom>
+          <a:solidFill>
+            <a:schemeClr val="accent1"/>
+          </a:solidFill>
+          <a:ln>
+            <a:solidFill>
+              <a:schemeClr val="accent1"/>
+            </a:solidFill>
+          </a:ln>
+        </p:spPr>
+        <p:txBody>
+          <a:bodyPr wrap="square" lIns="508" tIns="508" rIns="508" bIns="508" rtlCol="0" anchor="ctr"/>
+          <a:lstStyle/>
+          <a:p>
+            <a:pPr algn="ctr" indent="0" marL="0">
+              <a:buNone/>
+            </a:pPr>
+            <a:r>
+              <a:rPr lang="en-US" sz="1200" b="1" dirty="0">
+                <a:solidFill>
+                  <a:schemeClr val="bg1"/>
+                </a:solidFill>
+              </a:rPr>
+              <a:t>Customer</a:t>
+            </a:r>
+            <a:endParaRPr lang="en-US" sz="1200" dirty="0"/>
+          </a:p>
+        </p:txBody>
+      </p:sp>
+      <p:sp>
+        <p:nvSpPr>
+          <p:cNvPr id="6" name="Merchant portal"/>
+          <p:cNvSpPr txBox="1"/>
+          <p:nvPr/>
+        </p:nvSpPr>
+        <p:spPr>
+          <a:xfrm>
+            <a:off x="502920" y="2377440"/>
+            <a:ext cx="1280160" cy="411480"/>
+          </a:xfrm>
+          <a:prstGeom prst="roundRect">
+            <a:avLst>
+              <a:gd name="adj" fmla="val 13333"/>
+            </a:avLst>
+          </a:prstGeom>
+          <a:solidFill>
+            <a:schemeClr val="accent2"/>
+          </a:solidFill>
+          <a:ln>
+            <a:solidFill>
+              <a:schemeClr val="accent2"/>
+            </a:solidFill>
+          </a:ln>
+        </p:spPr>
+        <p:txBody>
+          <a:bodyPr wrap="square" lIns="508" tIns="508" rIns="508" bIns="508" rtlCol="0" anchor="ctr"/>
+          <a:lstStyle/>
+          <a:p>
+            <a:pPr algn="ctr" indent="0" marL="0">
+              <a:buNone/>
+            </a:pPr>
+            <a:r>
+              <a:rPr lang="en-US" sz="1200" b="1" dirty="0">
+                <a:solidFill>
+                  <a:schemeClr val="bg1"/>
+                </a:solidFill>
+              </a:rPr>
+              <a:t>Merchant</a:t>
+            </a:r>
+            <a:endParaRPr lang="en-US" sz="1200" dirty="0"/>
+          </a:p>
+        </p:txBody>
+      </p:sp>
+      <p:sp>
+        <p:nvSpPr>
+          <p:cNvPr id="7" name="Rider portal"/>
+          <p:cNvSpPr txBox="1"/>
+          <p:nvPr/>
+        </p:nvSpPr>
+        <p:spPr>
+          <a:xfrm>
+            <a:off x="502920" y="2926080"/>
+            <a:ext cx="1280160" cy="411480"/>
+          </a:xfrm>
+          <a:prstGeom prst="roundRect">
+            <a:avLst>
+              <a:gd name="adj" fmla="val 13333"/>
+            </a:avLst>
+          </a:prstGeom>
+          <a:solidFill>
+            <a:schemeClr val="accent3"/>
+          </a:solidFill>
+          <a:ln>
+            <a:solidFill>
+              <a:schemeClr val="accent3"/>
+            </a:solidFill>
+          </a:ln>
+        </p:spPr>
+        <p:txBody>
+          <a:bodyPr wrap="square" lIns="508" tIns="508" rIns="508" bIns="508" rtlCol="0" anchor="ctr"/>
+          <a:lstStyle/>
+          <a:p>
+            <a:pPr algn="ctr" indent="0" marL="0">
+              <a:buNone/>
+            </a:pPr>
+            <a:r>
+              <a:rPr lang="en-US" sz="1200" b="1" dirty="0">
+                <a:solidFill>
+                  <a:schemeClr val="bg1"/>
+                </a:solidFill>
+              </a:rPr>
+              <a:t>Rider</a:t>
+            </a:r>
+            <a:endParaRPr lang="en-US" sz="1200" dirty="0"/>
+          </a:p>
+        </p:txBody>
+      </p:sp>
+      <p:sp>
+        <p:nvSpPr>
+          <p:cNvPr id="8" name="Admin portal"/>
+          <p:cNvSpPr txBox="1"/>
+          <p:nvPr/>
+        </p:nvSpPr>
+        <p:spPr>
+          <a:xfrm>
+            <a:off x="502920" y="3474720"/>
+            <a:ext cx="1280160" cy="411480"/>
+          </a:xfrm>
+          <a:prstGeom prst="roundRect">
+            <a:avLst>
+              <a:gd name="adj" fmla="val 13333"/>
+            </a:avLst>
+          </a:prstGeom>
+          <a:solidFill>
+            <a:schemeClr val="accent6"/>
+          </a:solidFill>
+          <a:ln>
+            <a:solidFill>
+              <a:schemeClr val="accent6"/>
+            </a:solidFill>
+          </a:ln>
+        </p:spPr>
+        <p:txBody>
+          <a:bodyPr wrap="square" lIns="508" tIns="508" rIns="508" bIns="508" rtlCol="0" anchor="ctr"/>
+          <a:lstStyle/>
+          <a:p>
+            <a:pPr algn="ctr" indent="0" marL="0">
+              <a:buNone/>
+            </a:pPr>
+            <a:r>
+              <a:rPr lang="en-US" sz="1200" b="1" dirty="0">
+                <a:solidFill>
+                  <a:schemeClr val="bg1"/>
+                </a:solidFill>
+              </a:rPr>
+              <a:t>Admin</a:t>
+            </a:r>
+            <a:endParaRPr lang="en-US" sz="1200" dirty="0"/>
+          </a:p>
+        </p:txBody>
+      </p:sp>
+      <p:sp>
+        <p:nvSpPr>
+          <p:cNvPr id="25" name="Slide Number Placeholder 0"/>
+          <p:cNvSpPr>
+            <a:spLocks noGrp="1"/>
+          </p:cNvSpPr>
+          <p:nvPr>
+            <p:ph type="sldNum" sz="quarter" idx="4294967295"/>
+          </p:nvPr>
+        </p:nvSpPr>
+        <p:spPr>
+          <a:xfrm>
+            <a:off x="8229600" y="4754880"/>
+            <a:ext cx="457200" cy="274320"/>
+          </a:xfrm>
+          <a:prstGeom prst="rect">
+            <a:avLst/>
+          </a:prstGeom>
+          <a:extLst>
+            <a:ext uri="{C572A759-6A51-4108-AA02-DFA0A04FC94B}">
+              <ma14:wrappingTextBoxFlag xmlns:ma14="http://schemas.microsoft.com/office/mac/drawingml/2011/main" val="0"/>
+            </a:ext>
+          </a:extLst>
+        </p:spPr>
+        <p:txBody>
+          <a:bodyPr/>
+          <a:lstStyle>
+            <a:lvl1pPr>
+              <a:defRPr sz="1000">
+                <a:solidFill>
+                  <a:schemeClr val="accent5"/>
+                </a:solidFill>
+              </a:defRPr>
+            </a:lvl1pPr>
+          </a:lstStyle>
+          <a:p>
+            <a:pPr algn="r"/>
+            <a:fld id="{F7021451-1387-4CA6-816F-3879F97B5CBC}" type="slidenum">
+              <a:rPr b="0" lang="en-US"/>
+              <a:t>7</a:t>
+            </a:fld>
+            <a:endParaRPr lang="en-US"/>
+          </a:p>
+        </p:txBody>
+      </p:sp>
+      <p:sp>
+        <p:nvSpPr>
+          <p:cNvPr id="13" name="Gateway"/>
+          <p:cNvSpPr txBox="1"/>
+          <p:nvPr/>
+        </p:nvSpPr>
+        <p:spPr>
+          <a:xfrm>
+            <a:off x="2194560" y="2240280"/>
+            <a:ext cx="1051560" cy="868680"/>
+          </a:xfrm>
+          <a:prstGeom prst="roundRect">
+            <a:avLst>
+              <a:gd name="adj" fmla="val 10909"/>
+            </a:avLst>
+          </a:prstGeom>
+          <a:solidFill>
+            <a:schemeClr val="tx1"/>
+          </a:solidFill>
+          <a:ln>
+            <a:solidFill>
+              <a:schemeClr val="accent4"/>
+            </a:solidFill>
+          </a:ln>
+        </p:spPr>
+        <p:txBody>
+          <a:bodyPr wrap="square" lIns="508" tIns="508" rIns="508" bIns="508" rtlCol="0" anchor="ctr"/>
+          <a:lstStyle/>
+          <a:p>
+            <a:pPr algn="ctr" indent="0" marL="0">
+              <a:buNone/>
+            </a:pPr>
+            <a:r>
+              <a:rPr lang="en-US" sz="1200" b="1" dirty="0">
+                <a:solidFill>
+                  <a:schemeClr val="bg1"/>
+                </a:solidFill>
+              </a:rPr>
+              <a:t>YARP gateway</a:t>
+            </a:r>
+            <a:endParaRPr lang="en-US" sz="1200" dirty="0"/>
+          </a:p>
+          <a:p>
+            <a:pPr algn="ctr" indent="0" marL="0">
+              <a:buNone/>
+            </a:pPr>
+            <a:r>
+              <a:rPr lang="en-US" sz="1200" b="1" dirty="0">
+                <a:solidFill>
+                  <a:schemeClr val="bg1"/>
+                </a:solidFill>
+              </a:rPr>
+              <a:t>JWT · correlation id</a:t>
+            </a:r>
+            <a:endParaRPr lang="en-US" sz="1200" dirty="0"/>
+          </a:p>
+        </p:txBody>
+      </p:sp>
+      <p:sp>
+        <p:nvSpPr>
+          <p:cNvPr id="26" name="Clients to gateway"/>
+          <p:cNvSpPr/>
+          <p:nvPr/>
+        </p:nvSpPr>
+        <p:spPr>
+          <a:xfrm>
+            <a:off x="1920240" y="2670048"/>
+            <a:ext cx="274320" cy="0"/>
+          </a:xfrm>
+          <a:prstGeom prst="line">
+            <a:avLst/>
+          </a:prstGeom>
+          <a:noFill/>
+          <a:ln w="19050">
+            <a:solidFill>
+              <a:schemeClr val="tx2"/>
+            </a:solidFill>
+            <a:prstDash val="solid"/>
+            <a:tailEnd type="triangle"/>
+          </a:ln>
+        </p:spPr>
+      </p:sp>
+      <p:sp>
+        <p:nvSpPr>
+          <p:cNvPr id="26" name="Gateway to services"/>
+          <p:cNvSpPr/>
+          <p:nvPr/>
+        </p:nvSpPr>
+        <p:spPr>
+          <a:xfrm>
+            <a:off x="3246120" y="2670048"/>
+            <a:ext cx="228600" cy="0"/>
+          </a:xfrm>
+          <a:prstGeom prst="line">
+            <a:avLst/>
+          </a:prstGeom>
+          <a:noFill/>
+          <a:ln w="19050">
+            <a:solidFill>
+              <a:schemeClr val="tx2"/>
+            </a:solidFill>
+            <a:prstDash val="solid"/>
+            <a:tailEnd type="triangle"/>
+          </a:ln>
+        </p:spPr>
+      </p:sp>
+      <p:sp>
+        <p:nvSpPr>
+          <p:cNvPr id="9" name="Services card"/>
+          <p:cNvSpPr/>
+          <p:nvPr/>
+        </p:nvSpPr>
+        <p:spPr>
+          <a:xfrm>
+            <a:off x="3474720" y="1188720"/>
+            <a:ext cx="3429000" cy="3108960"/>
+          </a:xfrm>
+          <a:prstGeom prst="roundRect">
+            <a:avLst>
+              <a:gd name="adj" fmla="val 2353"/>
+            </a:avLst>
+          </a:prstGeom>
+          <a:solidFill>
+            <a:schemeClr val="bg2"/>
+          </a:solidFill>
+          <a:ln w="12700">
+            <a:solidFill>
+              <a:schemeClr val="bg2"/>
+            </a:solidFill>
+            <a:prstDash val="solid"/>
+          </a:ln>
+        </p:spPr>
+      </p:sp>
+      <p:sp>
+        <p:nvSpPr>
+          <p:cNvPr id="10" name="Services heading"/>
+          <p:cNvSpPr txBox="1"/>
+          <p:nvPr/>
+        </p:nvSpPr>
+        <p:spPr>
+          <a:xfrm>
+            <a:off x="3611880" y="1261872"/>
+            <a:ext cx="3200400" cy="274320"/>
+          </a:xfrm>
+          <a:prstGeom prst="rect">
+            <a:avLst/>
+          </a:prstGeom>
+          <a:noFill/>
+          <a:ln/>
+        </p:spPr>
+        <p:txBody>
+          <a:bodyPr wrap="square" lIns="0" tIns="0" rIns="0" bIns="0" rtlCol="0" anchor="t"/>
+          <a:lstStyle/>
+          <a:p>
+            <a:pPr indent="0" marL="0">
+              <a:buNone/>
+            </a:pPr>
+            <a:r>
+              <a:rPr lang="en-US" sz="1300" b="1" dirty="0">
+                <a:solidFill>
+                  <a:schemeClr val="tx1"/>
+                </a:solidFill>
+              </a:rPr>
+              <a:t>Services, one database each</a:t>
+            </a:r>
+            <a:endParaRPr lang="en-US" sz="1300" dirty="0"/>
+          </a:p>
+        </p:txBody>
+      </p:sp>
+      <p:sp>
+        <p:nvSpPr>
+          <p:cNvPr id="13" name="Identity service"/>
+          <p:cNvSpPr txBox="1"/>
+          <p:nvPr/>
+        </p:nvSpPr>
+        <p:spPr>
+          <a:xfrm>
+            <a:off x="3611880" y="1691640"/>
+            <a:ext cx="1143000" cy="475488"/>
+          </a:xfrm>
+          <a:prstGeom prst="roundRect">
+            <a:avLst>
+              <a:gd name="adj" fmla="val 10909"/>
+            </a:avLst>
+          </a:prstGeom>
+          <a:solidFill>
+            <a:schemeClr val="accent3"/>
+          </a:solidFill>
+          <a:ln>
+            <a:solidFill>
+              <a:schemeClr val="accent4"/>
+            </a:solidFill>
+          </a:ln>
+        </p:spPr>
+        <p:txBody>
+          <a:bodyPr wrap="square" lIns="508" tIns="508" rIns="508" bIns="508" rtlCol="0" anchor="ctr"/>
+          <a:lstStyle/>
+          <a:p>
+            <a:pPr algn="ctr" indent="0" marL="0">
+              <a:buNone/>
+            </a:pPr>
+            <a:r>
+              <a:rPr lang="en-US" sz="1200" b="1" dirty="0">
+                <a:solidFill>
+                  <a:schemeClr val="bg1"/>
+                </a:solidFill>
+              </a:rPr>
+              <a:t>Identity</a:t>
+            </a:r>
+            <a:endParaRPr lang="en-US" sz="1200" dirty="0"/>
+          </a:p>
+        </p:txBody>
+      </p:sp>
+      <p:sp>
+        <p:nvSpPr>
+          <p:cNvPr id="13" name="Identity db"/>
+          <p:cNvSpPr txBox="1"/>
+          <p:nvPr/>
+        </p:nvSpPr>
+        <p:spPr>
+          <a:xfrm>
+            <a:off x="4846320" y="1691640"/>
+            <a:ext cx="1051560" cy="475488"/>
+          </a:xfrm>
+          <a:prstGeom prst="roundRect">
+            <a:avLst>
+              <a:gd name="adj" fmla="val 10909"/>
+            </a:avLst>
+          </a:prstGeom>
+          <a:solidFill>
+            <a:schemeClr val="tx1"/>
+          </a:solidFill>
+          <a:ln>
+            <a:solidFill>
+              <a:schemeClr val="accent4"/>
+            </a:solidFill>
+          </a:ln>
+        </p:spPr>
+        <p:txBody>
+          <a:bodyPr wrap="square" lIns="508" tIns="508" rIns="508" bIns="508" rtlCol="0" anchor="ctr"/>
+          <a:lstStyle/>
+          <a:p>
+            <a:pPr algn="ctr" indent="0" marL="0">
+              <a:buNone/>
+            </a:pPr>
+            <a:r>
+              <a:rPr lang="en-US" sz="1200" b="1" dirty="0">
+                <a:solidFill>
+                  <a:schemeClr val="bg1"/>
+                </a:solidFill>
+              </a:rPr>
+              <a:t>identity_db</a:t>
+            </a:r>
+            <a:endParaRPr lang="en-US" sz="1200" dirty="0"/>
+          </a:p>
+        </p:txBody>
+      </p:sp>
+      <p:sp>
+        <p:nvSpPr>
+          <p:cNvPr id="21" name="Identity status"/>
+          <p:cNvSpPr txBox="1"/>
+          <p:nvPr/>
+        </p:nvSpPr>
+        <p:spPr>
+          <a:xfrm>
+            <a:off x="5943600" y="1728216"/>
+            <a:ext cx="914400" cy="411480"/>
+          </a:xfrm>
+          <a:prstGeom prst="rect">
+            <a:avLst/>
+          </a:prstGeom>
+          <a:noFill/>
+          <a:ln/>
+        </p:spPr>
+        <p:txBody>
+          <a:bodyPr wrap="square" lIns="0" tIns="0" rIns="0" bIns="0" rtlCol="0" anchor="t"/>
+          <a:lstStyle/>
+          <a:p>
+            <a:pPr algn="ctr" indent="0" marL="0">
+              <a:buNone/>
+            </a:pPr>
+            <a:r>
+              <a:rPr lang="en-US" sz="1100" dirty="0">
+                <a:solidFill>
+                  <a:schemeClr val="tx2"/>
+                </a:solidFill>
+              </a:rPr>
+              <a:t>Done</a:t>
+            </a:r>
+            <a:endParaRPr lang="en-US" sz="1100" dirty="0"/>
+          </a:p>
+          <a:p>
+            <a:pPr algn="ctr" indent="0" marL="0">
+              <a:buNone/>
+            </a:pPr>
+            <a:r>
+              <a:rPr lang="en-US" sz="1100" dirty="0">
+                <a:solidFill>
+                  <a:schemeClr val="tx2"/>
+                </a:solidFill>
+              </a:rPr>
+              <a:t>Member 2</a:t>
+            </a:r>
+            <a:endParaRPr lang="en-US" sz="1100" dirty="0"/>
+          </a:p>
+        </p:txBody>
+      </p:sp>
+      <p:sp>
+        <p:nvSpPr>
+          <p:cNvPr id="13" name="Catalog service"/>
+          <p:cNvSpPr txBox="1"/>
+          <p:nvPr/>
+        </p:nvSpPr>
+        <p:spPr>
+          <a:xfrm>
+            <a:off x="3611880" y="2313432"/>
+            <a:ext cx="1143000" cy="475488"/>
+          </a:xfrm>
+          <a:prstGeom prst="roundRect">
+            <a:avLst>
+              <a:gd name="adj" fmla="val 10909"/>
+            </a:avLst>
+          </a:prstGeom>
+          <a:solidFill>
+            <a:schemeClr val="accent3"/>
+          </a:solidFill>
+          <a:ln>
+            <a:solidFill>
+              <a:schemeClr val="accent4"/>
+            </a:solidFill>
+          </a:ln>
+        </p:spPr>
+        <p:txBody>
+          <a:bodyPr wrap="square" lIns="508" tIns="508" rIns="508" bIns="508" rtlCol="0" anchor="ctr"/>
+          <a:lstStyle/>
+          <a:p>
+            <a:pPr algn="ctr" indent="0" marL="0">
+              <a:buNone/>
+            </a:pPr>
+            <a:r>
+              <a:rPr lang="en-US" sz="1200" b="1" dirty="0">
+                <a:solidFill>
+                  <a:schemeClr val="bg1"/>
+                </a:solidFill>
+              </a:rPr>
+              <a:t>Catalog</a:t>
+            </a:r>
+            <a:endParaRPr lang="en-US" sz="1200" dirty="0"/>
+          </a:p>
+        </p:txBody>
+      </p:sp>
+      <p:sp>
+        <p:nvSpPr>
+          <p:cNvPr id="13" name="Catalog db"/>
+          <p:cNvSpPr txBox="1"/>
+          <p:nvPr/>
+        </p:nvSpPr>
+        <p:spPr>
+          <a:xfrm>
+            <a:off x="4846320" y="2313432"/>
+            <a:ext cx="1051560" cy="475488"/>
+          </a:xfrm>
+          <a:prstGeom prst="roundRect">
+            <a:avLst>
+              <a:gd name="adj" fmla="val 10909"/>
+            </a:avLst>
+          </a:prstGeom>
+          <a:solidFill>
+            <a:schemeClr val="tx1"/>
+          </a:solidFill>
+          <a:ln>
+            <a:solidFill>
+              <a:schemeClr val="accent4"/>
+            </a:solidFill>
+          </a:ln>
+        </p:spPr>
+        <p:txBody>
+          <a:bodyPr wrap="square" lIns="508" tIns="508" rIns="508" bIns="508" rtlCol="0" anchor="ctr"/>
+          <a:lstStyle/>
+          <a:p>
+            <a:pPr algn="ctr" indent="0" marL="0">
+              <a:buNone/>
+            </a:pPr>
+            <a:r>
+              <a:rPr lang="en-US" sz="1200" b="1" dirty="0">
+                <a:solidFill>
+                  <a:schemeClr val="bg1"/>
+                </a:solidFill>
+              </a:rPr>
+              <a:t>catalog_db</a:t>
+            </a:r>
+            <a:endParaRPr lang="en-US" sz="1200" dirty="0"/>
+          </a:p>
+        </p:txBody>
+      </p:sp>
+      <p:sp>
+        <p:nvSpPr>
+          <p:cNvPr id="21" name="Catalog status"/>
+          <p:cNvSpPr txBox="1"/>
+          <p:nvPr/>
+        </p:nvSpPr>
+        <p:spPr>
+          <a:xfrm>
+            <a:off x="5943600" y="2350008"/>
+            <a:ext cx="914400" cy="411480"/>
+          </a:xfrm>
+          <a:prstGeom prst="rect">
+            <a:avLst/>
+          </a:prstGeom>
+          <a:noFill/>
+          <a:ln/>
+        </p:spPr>
+        <p:txBody>
+          <a:bodyPr wrap="square" lIns="0" tIns="0" rIns="0" bIns="0" rtlCol="0" anchor="t"/>
+          <a:lstStyle/>
+          <a:p>
+            <a:pPr algn="ctr" indent="0" marL="0">
+              <a:buNone/>
+            </a:pPr>
+            <a:r>
+              <a:rPr lang="en-US" sz="1100" dirty="0">
+                <a:solidFill>
+                  <a:schemeClr val="tx2"/>
+                </a:solidFill>
+              </a:rPr>
+              <a:t>Done</a:t>
+            </a:r>
+            <a:endParaRPr lang="en-US" sz="1100" dirty="0"/>
+          </a:p>
+          <a:p>
+            <a:pPr algn="ctr" indent="0" marL="0">
+              <a:buNone/>
+            </a:pPr>
+            <a:r>
+              <a:rPr lang="en-US" sz="1100" dirty="0">
+                <a:solidFill>
+                  <a:schemeClr val="tx2"/>
+                </a:solidFill>
+              </a:rPr>
+              <a:t>Member 3</a:t>
+            </a:r>
+            <a:endParaRPr lang="en-US" sz="1100" dirty="0"/>
+          </a:p>
+        </p:txBody>
+      </p:sp>
+      <p:sp>
+        <p:nvSpPr>
+          <p:cNvPr id="13" name="Order service"/>
+          <p:cNvSpPr txBox="1"/>
+          <p:nvPr/>
+        </p:nvSpPr>
+        <p:spPr>
+          <a:xfrm>
+            <a:off x="3611880" y="2935224"/>
+            <a:ext cx="1143000" cy="475488"/>
+          </a:xfrm>
+          <a:prstGeom prst="roundRect">
+            <a:avLst>
+              <a:gd name="adj" fmla="val 10909"/>
+            </a:avLst>
+          </a:prstGeom>
+          <a:solidFill>
+            <a:schemeClr val="accent2"/>
+          </a:solidFill>
+          <a:ln>
+            <a:solidFill>
+              <a:schemeClr val="accent4"/>
+            </a:solidFill>
+          </a:ln>
+        </p:spPr>
+        <p:txBody>
+          <a:bodyPr wrap="square" lIns="508" tIns="508" rIns="508" bIns="508" rtlCol="0" anchor="ctr"/>
+          <a:lstStyle/>
+          <a:p>
+            <a:pPr algn="ctr" indent="0" marL="0">
+              <a:buNone/>
+            </a:pPr>
+            <a:r>
+              <a:rPr lang="en-US" sz="1200" b="1" dirty="0">
+                <a:solidFill>
+                  <a:schemeClr val="bg1"/>
+                </a:solidFill>
+              </a:rPr>
+              <a:t>Order</a:t>
+            </a:r>
+            <a:endParaRPr lang="en-US" sz="1200" dirty="0"/>
+          </a:p>
+        </p:txBody>
+      </p:sp>
+      <p:sp>
+        <p:nvSpPr>
+          <p:cNvPr id="13" name="Order db"/>
+          <p:cNvSpPr txBox="1"/>
+          <p:nvPr/>
+        </p:nvSpPr>
+        <p:spPr>
+          <a:xfrm>
+            <a:off x="4846320" y="2935224"/>
+            <a:ext cx="1051560" cy="475488"/>
+          </a:xfrm>
+          <a:prstGeom prst="roundRect">
+            <a:avLst>
+              <a:gd name="adj" fmla="val 10909"/>
+            </a:avLst>
+          </a:prstGeom>
+          <a:solidFill>
+            <a:schemeClr val="tx1"/>
+          </a:solidFill>
+          <a:ln>
+            <a:solidFill>
+              <a:schemeClr val="accent4"/>
+            </a:solidFill>
+          </a:ln>
+        </p:spPr>
+        <p:txBody>
+          <a:bodyPr wrap="square" lIns="508" tIns="508" rIns="508" bIns="508" rtlCol="0" anchor="ctr"/>
+          <a:lstStyle/>
+          <a:p>
+            <a:pPr algn="ctr" indent="0" marL="0">
+              <a:buNone/>
+            </a:pPr>
+            <a:r>
+              <a:rPr lang="en-US" sz="1200" b="1" dirty="0">
+                <a:solidFill>
+                  <a:schemeClr val="bg1"/>
+                </a:solidFill>
+              </a:rPr>
+              <a:t>order_db</a:t>
+            </a:r>
+            <a:endParaRPr lang="en-US" sz="1200" dirty="0"/>
+          </a:p>
+        </p:txBody>
+      </p:sp>
+      <p:sp>
+        <p:nvSpPr>
+          <p:cNvPr id="21" name="Order status"/>
+          <p:cNvSpPr txBox="1"/>
+          <p:nvPr/>
+        </p:nvSpPr>
+        <p:spPr>
+          <a:xfrm>
+            <a:off x="5943600" y="2971800"/>
+            <a:ext cx="914400" cy="411480"/>
+          </a:xfrm>
+          <a:prstGeom prst="rect">
+            <a:avLst/>
+          </a:prstGeom>
+          <a:noFill/>
+          <a:ln/>
+        </p:spPr>
+        <p:txBody>
+          <a:bodyPr wrap="square" lIns="0" tIns="0" rIns="0" bIns="0" rtlCol="0" anchor="t"/>
+          <a:lstStyle/>
+          <a:p>
+            <a:pPr algn="ctr" indent="0" marL="0">
+              <a:buNone/>
+            </a:pPr>
+            <a:r>
+              <a:rPr lang="en-US" sz="1100" dirty="0">
+                <a:solidFill>
+                  <a:schemeClr val="tx2"/>
+                </a:solidFill>
+              </a:rPr>
+              <a:t>Moving</a:t>
+            </a:r>
+            <a:endParaRPr lang="en-US" sz="1100" dirty="0"/>
+          </a:p>
+          <a:p>
+            <a:pPr algn="ctr" indent="0" marL="0">
+              <a:buNone/>
+            </a:pPr>
+            <a:r>
+              <a:rPr lang="en-US" sz="1100" dirty="0">
+                <a:solidFill>
+                  <a:schemeClr val="tx2"/>
+                </a:solidFill>
+              </a:rPr>
+              <a:t>Member 4</a:t>
+            </a:r>
+            <a:endParaRPr lang="en-US" sz="1100" dirty="0"/>
+          </a:p>
+        </p:txBody>
+      </p:sp>
+      <p:sp>
+        <p:nvSpPr>
+          <p:cNvPr id="13" name="Fulfilment service"/>
+          <p:cNvSpPr txBox="1"/>
+          <p:nvPr/>
+        </p:nvSpPr>
+        <p:spPr>
+          <a:xfrm>
+            <a:off x="3611880" y="3557016"/>
+            <a:ext cx="1143000" cy="475488"/>
+          </a:xfrm>
+          <a:prstGeom prst="roundRect">
+            <a:avLst>
+              <a:gd name="adj" fmla="val 10909"/>
+            </a:avLst>
+          </a:prstGeom>
+          <a:solidFill>
+            <a:schemeClr val="accent2"/>
+          </a:solidFill>
+          <a:ln>
+            <a:solidFill>
+              <a:schemeClr val="accent4"/>
+            </a:solidFill>
+          </a:ln>
+        </p:spPr>
+        <p:txBody>
+          <a:bodyPr wrap="square" lIns="508" tIns="508" rIns="508" bIns="508" rtlCol="0" anchor="ctr"/>
+          <a:lstStyle/>
+          <a:p>
+            <a:pPr algn="ctr" indent="0" marL="0">
+              <a:buNone/>
+            </a:pPr>
+            <a:r>
+              <a:rPr lang="en-US" sz="1200" b="1" dirty="0">
+                <a:solidFill>
+                  <a:schemeClr val="bg1"/>
+                </a:solidFill>
+              </a:rPr>
+              <a:t>Fulfilment</a:t>
+            </a:r>
+            <a:endParaRPr lang="en-US" sz="1200" dirty="0"/>
+          </a:p>
+        </p:txBody>
+      </p:sp>
+      <p:sp>
+        <p:nvSpPr>
+          <p:cNvPr id="13" name="Fulfilment db"/>
+          <p:cNvSpPr txBox="1"/>
+          <p:nvPr/>
+        </p:nvSpPr>
+        <p:spPr>
+          <a:xfrm>
+            <a:off x="4846320" y="3557016"/>
+            <a:ext cx="1051560" cy="475488"/>
+          </a:xfrm>
+          <a:prstGeom prst="roundRect">
+            <a:avLst>
+              <a:gd name="adj" fmla="val 10909"/>
+            </a:avLst>
+          </a:prstGeom>
+          <a:solidFill>
+            <a:schemeClr val="tx1"/>
+          </a:solidFill>
+          <a:ln>
+            <a:solidFill>
+              <a:schemeClr val="accent4"/>
+            </a:solidFill>
+          </a:ln>
+        </p:spPr>
+        <p:txBody>
+          <a:bodyPr wrap="square" lIns="508" tIns="508" rIns="508" bIns="508" rtlCol="0" anchor="ctr"/>
+          <a:lstStyle/>
+          <a:p>
+            <a:pPr algn="ctr" indent="0" marL="0">
+              <a:buNone/>
+            </a:pPr>
+            <a:r>
+              <a:rPr lang="en-US" sz="1200" b="1" dirty="0">
+                <a:solidFill>
+                  <a:schemeClr val="bg1"/>
+                </a:solidFill>
+              </a:rPr>
+              <a:t>fulfilment_db</a:t>
+            </a:r>
+            <a:endParaRPr lang="en-US" sz="1200" dirty="0"/>
+          </a:p>
+        </p:txBody>
+      </p:sp>
+      <p:sp>
+        <p:nvSpPr>
+          <p:cNvPr id="21" name="Fulfilment status"/>
+          <p:cNvSpPr txBox="1"/>
+          <p:nvPr/>
+        </p:nvSpPr>
+        <p:spPr>
+          <a:xfrm>
+            <a:off x="5943600" y="3593592"/>
+            <a:ext cx="914400" cy="411480"/>
+          </a:xfrm>
+          <a:prstGeom prst="rect">
+            <a:avLst/>
+          </a:prstGeom>
+          <a:noFill/>
+          <a:ln/>
+        </p:spPr>
+        <p:txBody>
+          <a:bodyPr wrap="square" lIns="0" tIns="0" rIns="0" bIns="0" rtlCol="0" anchor="t"/>
+          <a:lstStyle/>
+          <a:p>
+            <a:pPr algn="ctr" indent="0" marL="0">
+              <a:buNone/>
+            </a:pPr>
+            <a:r>
+              <a:rPr lang="en-US" sz="1100" dirty="0">
+                <a:solidFill>
+                  <a:schemeClr val="tx2"/>
+                </a:solidFill>
+              </a:rPr>
+              <a:t>Moving</a:t>
+            </a:r>
+            <a:endParaRPr lang="en-US" sz="1100" dirty="0"/>
+          </a:p>
+          <a:p>
+            <a:pPr algn="ctr" indent="0" marL="0">
+              <a:buNone/>
+            </a:pPr>
+            <a:r>
+              <a:rPr lang="en-US" sz="1100" dirty="0">
+                <a:solidFill>
+                  <a:schemeClr val="tx2"/>
+                </a:solidFill>
+              </a:rPr>
+              <a:t>Member 5</a:t>
+            </a:r>
+            <a:endParaRPr lang="en-US" sz="1100" dirty="0"/>
+          </a:p>
+        </p:txBody>
+      </p:sp>
+      <p:sp>
+        <p:nvSpPr>
+          <p:cNvPr id="9" name="Monolith card"/>
+          <p:cNvSpPr/>
+          <p:nvPr/>
+        </p:nvSpPr>
+        <p:spPr>
+          <a:xfrm>
+            <a:off x="7132320" y="1188720"/>
+            <a:ext cx="1645920" cy="3108960"/>
+          </a:xfrm>
+          <a:prstGeom prst="roundRect">
+            <a:avLst>
+              <a:gd name="adj" fmla="val 2353"/>
+            </a:avLst>
+          </a:prstGeom>
+          <a:solidFill>
+            <a:schemeClr val="bg2"/>
+          </a:solidFill>
+          <a:ln w="12700">
+            <a:solidFill>
+              <a:schemeClr val="bg2"/>
+            </a:solidFill>
+            <a:prstDash val="solid"/>
+          </a:ln>
+        </p:spPr>
+      </p:sp>
+      <p:sp>
+        <p:nvSpPr>
+          <p:cNvPr id="10" name="Monolith heading"/>
+          <p:cNvSpPr txBox="1"/>
+          <p:nvPr/>
+        </p:nvSpPr>
+        <p:spPr>
+          <a:xfrm>
+            <a:off x="7223760" y="1261872"/>
+            <a:ext cx="1463040" cy="274320"/>
+          </a:xfrm>
+          <a:prstGeom prst="rect">
+            <a:avLst/>
+          </a:prstGeom>
+          <a:noFill/>
+          <a:ln/>
+        </p:spPr>
+        <p:txBody>
+          <a:bodyPr wrap="square" lIns="0" tIns="0" rIns="0" bIns="0" rtlCol="0" anchor="t"/>
+          <a:lstStyle/>
+          <a:p>
+            <a:pPr indent="0" marL="0">
+              <a:buNone/>
+            </a:pPr>
+            <a:r>
+              <a:rPr lang="en-US" sz="1300" b="1" dirty="0">
+                <a:solidFill>
+                  <a:schemeClr val="tx1"/>
+                </a:solidFill>
+              </a:rPr>
+              <a:t>Monolith</a:t>
+            </a:r>
+            <a:endParaRPr lang="en-US" sz="1300" dirty="0"/>
+          </a:p>
+        </p:txBody>
+      </p:sp>
+      <p:sp>
+        <p:nvSpPr>
+          <p:cNvPr id="21" name="Monolith text"/>
+          <p:cNvSpPr txBox="1"/>
+          <p:nvPr/>
+        </p:nvSpPr>
+        <p:spPr>
+          <a:xfrm>
+            <a:off x="7223760" y="1645920"/>
+            <a:ext cx="1463040" cy="2468880"/>
+          </a:xfrm>
+          <a:prstGeom prst="rect">
+            <a:avLst/>
+          </a:prstGeom>
+          <a:noFill/>
+          <a:ln/>
+        </p:spPr>
+        <p:txBody>
+          <a:bodyPr wrap="square" lIns="0" tIns="0" rIns="0" bIns="0" rtlCol="0" anchor="t"/>
+          <a:lstStyle/>
+          <a:p>
+            <a:pPr algn="ctr" indent="0" marL="0">
+              <a:buNone/>
+            </a:pPr>
+            <a:r>
+              <a:rPr lang="en-US" sz="1100" dirty="0">
+                <a:solidFill>
+                  <a:schemeClr val="tx2"/>
+                </a:solidFill>
+              </a:rPr>
+              <a:t>Still serves the full order flow.</a:t>
+            </a:r>
+            <a:endParaRPr lang="en-US" sz="1100" dirty="0"/>
+          </a:p>
+          <a:p>
+            <a:pPr algn="ctr" indent="0" marL="0">
+              <a:buNone/>
+            </a:pPr>
+            <a:r>
+              <a:rPr lang="en-US" sz="1100" dirty="0">
+                <a:solidFill>
+                  <a:schemeClr val="tx2"/>
+                </a:solidFill>
+              </a:rPr>
+              <a:t>Each module leaves with its own tables.</a:t>
+            </a:r>
+            <a:endParaRPr lang="en-US" sz="1100" dirty="0"/>
+          </a:p>
+          <a:p>
+            <a:pPr algn="ctr" indent="0" marL="0">
+              <a:buNone/>
+            </a:pPr>
+            <a:r>
+              <a:rPr lang="en-US" sz="1100" dirty="0">
+                <a:solidFill>
+                  <a:schemeClr val="tx2"/>
+                </a:solidFill>
+              </a:rPr>
+              <a:t>Retired when Order and Fulfilment move.</a:t>
+            </a:r>
+            <a:endParaRPr lang="en-US" sz="1100" dirty="0"/>
+          </a:p>
+        </p:txBody>
+      </p:sp>
+      <p:sp>
+        <p:nvSpPr>
+          <p:cNvPr id="21" name="Migration rule"/>
+          <p:cNvSpPr txBox="1"/>
+          <p:nvPr/>
+        </p:nvSpPr>
+        <p:spPr>
+          <a:xfrm>
+            <a:off x="365760" y="4434840"/>
+            <a:ext cx="8412480" cy="274320"/>
+          </a:xfrm>
+          <a:prstGeom prst="rect">
+            <a:avLst/>
+          </a:prstGeom>
+          <a:noFill/>
+          <a:ln/>
+        </p:spPr>
+        <p:txBody>
+          <a:bodyPr wrap="square" lIns="0" tIns="0" rIns="0" bIns="0" rtlCol="0" anchor="t"/>
+          <a:lstStyle/>
+          <a:p>
+            <a:pPr algn="ctr" indent="0" marL="0">
+              <a:buNone/>
+            </a:pPr>
+            <a:r>
+              <a:rPr lang="en-US" sz="1100" dirty="0">
+                <a:solidFill>
+                  <a:schemeClr val="tx2"/>
+                </a:solidFill>
+              </a:rPr>
+              <a:t>Rule: no service reads another service's database; they talk over HTTP (and events once Order publishes OrderConfirmed).</a:t>
+            </a:r>
+            <a:endParaRPr lang="en-US" sz="1100" dirty="0"/>
+          </a:p>
+        </p:txBody>
+      </p:sp>
+      <p:sp>
+        <p:nvSpPr>
+          <p:cNvPr id="27" name="MARKER 【待Member4/5】周二前更新 Or"/>
+          <p:cNvSpPr txBox="1"/>
+          <p:nvPr/>
+        </p:nvSpPr>
+        <p:spPr>
+          <a:xfrm>
+            <a:off x="5120640" y="347472"/>
+            <a:ext cx="3566160" cy="502920"/>
+          </a:xfrm>
+          <a:prstGeom prst="rect">
+            <a:avLst/>
+          </a:prstGeom>
+          <a:solidFill>
+            <a:srgbClr val="FCE7F3"/>
+          </a:solidFill>
+          <a:ln>
+            <a:solidFill>
+              <a:srgbClr val="B0108A"/>
+            </a:solidFill>
+          </a:ln>
+        </p:spPr>
+        <p:txBody>
+          <a:bodyPr wrap="square" anchor="ctr" lIns="73152" rIns="73152">
+            <a:spAutoFit/>
+          </a:bodyPr>
+          <a:lstStyle/>
+          <a:p>
+            <a:r>
+              <a:rPr sz="1000" b="1">
+                <a:solidFill>
+                  <a:srgbClr val="B0108A"/>
+                </a:solidFill>
+              </a:rPr>
+              <a:t>【待Member4/5】周二前更新 Order/Fulfilment 的状态（Done/Moving）</a:t>
+            </a:r>
+          </a:p>
+        </p:txBody>
+      </p:sp>
+    </p:spTree>
+  </p:cSld>
+  <p:clrMapOvr>
+    <a:masterClrMapping/>
+  </p:clrMapOvr>
+</p:sld>
+</file>
+
+<file path=ppt/slides/slide24.xml><?xml version="1.0" encoding="utf-8"?>
+<p:sld xmlns:a="http://schemas.openxmlformats.org/drawingml/2006/main" xmlns:p="http://schemas.openxmlformats.org/presentationml/2006/main" xmlns:r="http://schemas.openxmlformats.org/officeDocument/2006/relationships">
+  <p:cSld>
+    <p:spTree>
+      <p:nvGrpSpPr>
+        <p:cNvPr id="1" name=""/>
+        <p:cNvGrpSpPr/>
+        <p:nvPr/>
+      </p:nvGrpSpPr>
+      <p:grpSpPr/>
+      <p:sp>
+        <p:nvSpPr>
+          <p:cNvPr id="2" name="Title"/>
+          <p:cNvSpPr txBox="1"/>
+          <p:nvPr/>
+        </p:nvSpPr>
+        <p:spPr>
+          <a:xfrm>
+            <a:off x="457200" y="274320"/>
+            <a:ext cx="8229600" cy="685800"/>
+          </a:xfrm>
+          <a:prstGeom prst="rect">
+            <a:avLst/>
+          </a:prstGeom>
+          <a:noFill/>
+          <a:ln/>
+        </p:spPr>
+        <p:txBody>
+          <a:bodyPr wrap="square" lIns="0" tIns="0" rIns="0" bIns="0" rtlCol="0" anchor="ctr"/>
+          <a:lstStyle/>
+          <a:p>
+            <a:pPr indent="0" marL="0">
+              <a:buNone/>
+            </a:pPr>
+            <a:r>
+              <a:rPr lang="en-US" sz="3000" b="1" dirty="0">
+                <a:solidFill>
+                  <a:schemeClr val="tx1"/>
+                </a:solidFill>
+              </a:rPr>
+              <a:t>Across a service boundary: stock</a:t>
+            </a:r>
+            <a:endParaRPr lang="en-US" sz="3000" dirty="0"/>
+          </a:p>
+        </p:txBody>
+      </p:sp>
+      <p:graphicFrame>
+        <p:nvGraphicFramePr>
+          <p:cNvPr id="15" name="Table 0"/>
+          <p:cNvGraphicFramePr>
+            <a:graphicFrameLocks noGrp="1"/>
+          </p:cNvGraphicFramePr>
+          <p:nvPr>
+            <p:extLst>
+              <p:ext uri="{D42A27DB-BD31-4B8C-83A1-F6EECF244321}">
+                <p14:modId xmlns:p14="http://schemas.microsoft.com/office/powerpoint/2010/main" val="1579011935"/>
+              </p:ext>
+            </p:extLst>
+          </p:nvPr>
+        </p:nvGraphicFramePr>
+        <p:xfrm>
+          <a:off x="457200" y="1097280"/>
+          <a:ext cx="8229600" cy="914400"/>
+        </p:xfrm>
+        <a:graphic>
+          <a:graphicData uri="http://schemas.openxmlformats.org/drawingml/2006/table">
+            <a:tbl>
+              <a:tblPr/>
+              <a:tblGrid>
+                <a:gridCol w="2743200"/>
+                <a:gridCol w="3749040"/>
+                <a:gridCol w="1737360"/>
+              </a:tblGrid>
+              <a:tr h="365760">
+                <a:tc>
+                  <a:txBody>
+                    <a:bodyPr/>
+                    <a:lstStyle/>
+                    <a:p>
+                      <a:pPr indent="0" marL="0">
+                        <a:buNone/>
+                      </a:pPr>
+                      <a:r>
+                        <a:rPr lang="en-US" sz="1300" b="1" dirty="0">
+                          <a:solidFill>
+                            <a:schemeClr val="bg1"/>
+                          </a:solidFill>
+                        </a:rPr>
+                        <a:t>If this happens</a:t>
+                      </a:r>
+                      <a:endParaRPr lang="en-US" sz="1300" dirty="0"/>
+                    </a:p>
+                  </a:txBody>
+                  <a:tcPr marL="91440" marR="91440" marT="36576" marB="36576" anchor="ctr">
+                    <a:lnL w="9525" cap="flat" cmpd="sng" algn="ctr">
+                      <a:solidFill>
+                        <a:srgbClr val="D5D8E0"/>
+                      </a:solidFill>
+                      <a:prstDash val="solid"/>
+                      <a:round/>
+                      <a:headEnd type="none" w="med" len="med"/>
+                      <a:tailEnd type="none" w="med" len="med"/>
+                    </a:lnL>
+                    <a:lnR w="9525" cap="flat" cmpd="sng" algn="ctr">
+                      <a:solidFill>
+                        <a:srgbClr val="D5D8E0"/>
+                      </a:solidFill>
+                      <a:prstDash val="solid"/>
+                      <a:round/>
+                      <a:headEnd type="none" w="med" len="med"/>
+                      <a:tailEnd type="none" w="med" len="med"/>
+                    </a:lnR>
+                    <a:lnT w="9525" cap="flat" cmpd="sng" algn="ctr">
+                      <a:solidFill>
+                        <a:srgbClr val="D5D8E0"/>
+                      </a:solidFill>
+                      <a:prstDash val="solid"/>
+                      <a:round/>
+                      <a:headEnd type="none" w="med" len="med"/>
+                      <a:tailEnd type="none" w="med" len="med"/>
+                    </a:lnT>
+                    <a:lnB w="9525" cap="flat" cmpd="sng" algn="ctr">
+                      <a:solidFill>
+                        <a:srgbClr val="D5D8E0"/>
+                      </a:solidFill>
+                      <a:prstDash val="solid"/>
+                      <a:round/>
+                      <a:headEnd type="none" w="med" len="med"/>
+                      <a:tailEnd type="none" w="med" len="med"/>
+                    </a:lnB>
+                    <a:solidFill>
+                      <a:schemeClr val="tx1"/>
+                    </a:solidFill>
+                  </a:tcPr>
+                </a:tc>
+                <a:tc>
+                  <a:txBody>
+                    <a:bodyPr/>
+                    <a:lstStyle/>
+                    <a:p>
+                      <a:pPr indent="0" marL="0">
+                        <a:buNone/>
+                      </a:pPr>
+                      <a:r>
+                        <a:rPr lang="en-US" sz="1300" b="1" dirty="0">
+                          <a:solidFill>
+                            <a:schemeClr val="bg1"/>
+                          </a:solidFill>
+                        </a:rPr>
+                        <a:t>The system does this</a:t>
+                      </a:r>
+                      <a:endParaRPr lang="en-US" sz="1300" dirty="0"/>
+                    </a:p>
+                  </a:txBody>
+                  <a:tcPr marL="91440" marR="91440" marT="36576" marB="36576" anchor="ctr">
+                    <a:lnL w="9525" cap="flat" cmpd="sng" algn="ctr">
+                      <a:solidFill>
+                        <a:srgbClr val="D5D8E0"/>
+                      </a:solidFill>
+                      <a:prstDash val="solid"/>
+                      <a:round/>
+                      <a:headEnd type="none" w="med" len="med"/>
+                      <a:tailEnd type="none" w="med" len="med"/>
+                    </a:lnL>
+                    <a:lnR w="9525" cap="flat" cmpd="sng" algn="ctr">
+                      <a:solidFill>
+                        <a:srgbClr val="D5D8E0"/>
+                      </a:solidFill>
+                      <a:prstDash val="solid"/>
+                      <a:round/>
+                      <a:headEnd type="none" w="med" len="med"/>
+                      <a:tailEnd type="none" w="med" len="med"/>
+                    </a:lnR>
+                    <a:lnT w="9525" cap="flat" cmpd="sng" algn="ctr">
+                      <a:solidFill>
+                        <a:srgbClr val="D5D8E0"/>
+                      </a:solidFill>
+                      <a:prstDash val="solid"/>
+                      <a:round/>
+                      <a:headEnd type="none" w="med" len="med"/>
+                      <a:tailEnd type="none" w="med" len="med"/>
+                    </a:lnT>
+                    <a:lnB w="9525" cap="flat" cmpd="sng" algn="ctr">
+                      <a:solidFill>
+                        <a:srgbClr val="D5D8E0"/>
+                      </a:solidFill>
+                      <a:prstDash val="solid"/>
+                      <a:round/>
+                      <a:headEnd type="none" w="med" len="med"/>
+                      <a:tailEnd type="none" w="med" len="med"/>
+                    </a:lnB>
+                    <a:solidFill>
+                      <a:schemeClr val="tx1"/>
+                    </a:solidFill>
+                  </a:tcPr>
+                </a:tc>
+                <a:tc>
+                  <a:txBody>
+                    <a:bodyPr/>
+                    <a:lstStyle/>
+                    <a:p>
+                      <a:pPr indent="0" marL="0">
+                        <a:buNone/>
+                      </a:pPr>
+                      <a:r>
+                        <a:rPr lang="en-US" sz="1300" b="1" dirty="0">
+                          <a:solidFill>
+                            <a:schemeClr val="bg1"/>
+                          </a:solidFill>
+                        </a:rPr>
+                        <a:t>Checked by</a:t>
+                      </a:r>
+                      <a:endParaRPr lang="en-US" sz="1300" dirty="0"/>
+                    </a:p>
+                  </a:txBody>
+                  <a:tcPr marL="91440" marR="91440" marT="36576" marB="36576" anchor="ctr">
+                    <a:lnL w="9525" cap="flat" cmpd="sng" algn="ctr">
+                      <a:solidFill>
+                        <a:srgbClr val="D5D8E0"/>
+                      </a:solidFill>
+                      <a:prstDash val="solid"/>
+                      <a:round/>
+                      <a:headEnd type="none" w="med" len="med"/>
+                      <a:tailEnd type="none" w="med" len="med"/>
+                    </a:lnL>
+                    <a:lnR w="9525" cap="flat" cmpd="sng" algn="ctr">
+                      <a:solidFill>
+                        <a:srgbClr val="D5D8E0"/>
+                      </a:solidFill>
+                      <a:prstDash val="solid"/>
+                      <a:round/>
+                      <a:headEnd type="none" w="med" len="med"/>
+                      <a:tailEnd type="none" w="med" len="med"/>
+                    </a:lnR>
+                    <a:lnT w="9525" cap="flat" cmpd="sng" algn="ctr">
+                      <a:solidFill>
+                        <a:srgbClr val="D5D8E0"/>
+                      </a:solidFill>
+                      <a:prstDash val="solid"/>
+                      <a:round/>
+                      <a:headEnd type="none" w="med" len="med"/>
+                      <a:tailEnd type="none" w="med" len="med"/>
+                    </a:lnT>
+                    <a:lnB w="9525" cap="flat" cmpd="sng" algn="ctr">
+                      <a:solidFill>
+                        <a:srgbClr val="D5D8E0"/>
+                      </a:solidFill>
+                      <a:prstDash val="solid"/>
+                      <a:round/>
+                      <a:headEnd type="none" w="med" len="med"/>
+                      <a:tailEnd type="none" w="med" len="med"/>
+                    </a:lnB>
+                    <a:solidFill>
+                      <a:schemeClr val="tx1"/>
+                    </a:solidFill>
+                  </a:tcPr>
+                </a:tc>
+              </a:tr>
+              <a:tr h="530352">
+                <a:tc>
+                  <a:txBody>
+                    <a:bodyPr/>
+                    <a:lstStyle/>
+                    <a:p>
+                      <a:pPr indent="0" marL="0">
+                        <a:buNone/>
+                      </a:pPr>
+                      <a:r>
+                        <a:rPr lang="en-US" sz="1200" b="1" dirty="0">
+                          <a:solidFill>
+                            <a:srgbClr val="000000"/>
+                          </a:solidFill>
+                        </a:rPr>
+                        <a:t>Order reserves stock with a reservationId</a:t>
+                      </a:r>
+                      <a:endParaRPr lang="en-US" sz="1200" dirty="0"/>
+                    </a:p>
+                  </a:txBody>
+                  <a:tcPr marL="91440" marR="91440" marT="36576" marB="36576" anchor="ctr">
+                    <a:lnL w="9525" cap="flat" cmpd="sng" algn="ctr">
+                      <a:solidFill>
+                        <a:srgbClr val="D5D8E0"/>
+                      </a:solidFill>
+                      <a:prstDash val="solid"/>
+                      <a:round/>
+                      <a:headEnd type="none" w="med" len="med"/>
+                      <a:tailEnd type="none" w="med" len="med"/>
+                    </a:lnL>
+                    <a:lnR w="9525" cap="flat" cmpd="sng" algn="ctr">
+                      <a:solidFill>
+                        <a:srgbClr val="D5D8E0"/>
+                      </a:solidFill>
+                      <a:prstDash val="solid"/>
+                      <a:round/>
+                      <a:headEnd type="none" w="med" len="med"/>
+                      <a:tailEnd type="none" w="med" len="med"/>
+                    </a:lnR>
+                    <a:lnT w="9525" cap="flat" cmpd="sng" algn="ctr">
+                      <a:solidFill>
+                        <a:srgbClr val="D5D8E0"/>
+                      </a:solidFill>
+                      <a:prstDash val="solid"/>
+                      <a:round/>
+                      <a:headEnd type="none" w="med" len="med"/>
+                      <a:tailEnd type="none" w="med" len="med"/>
+                    </a:lnT>
+                    <a:lnB w="9525" cap="flat" cmpd="sng" algn="ctr">
+                      <a:solidFill>
+                        <a:srgbClr val="D5D8E0"/>
+                      </a:solidFill>
+                      <a:prstDash val="solid"/>
+                      <a:round/>
+                      <a:headEnd type="none" w="med" len="med"/>
+                      <a:tailEnd type="none" w="med" len="med"/>
+                    </a:lnB>
+                    <a:solidFill>
+                      <a:schemeClr val="bg1"/>
+                    </a:solidFill>
+                  </a:tcPr>
+                </a:tc>
+                <a:tc>
+                  <a:txBody>
+                    <a:bodyPr/>
+                    <a:lstStyle/>
+                    <a:p>
+                      <a:pPr indent="0" marL="0">
+                        <a:buNone/>
+                      </a:pPr>
+                      <a:r>
+                        <a:rPr lang="en-US" sz="1200" dirty="0">
+                          <a:solidFill>
+                            <a:srgbClr val="000000"/>
+                          </a:solidFill>
+                        </a:rPr>
+                        <a:t>All lines or none; returns price snapshots and the total</a:t>
+                      </a:r>
+                      <a:endParaRPr lang="en-US" sz="1200" dirty="0"/>
+                    </a:p>
+                  </a:txBody>
+                  <a:tcPr marL="91440" marR="91440" marT="36576" marB="36576" anchor="ctr">
+                    <a:lnL w="9525" cap="flat" cmpd="sng" algn="ctr">
+                      <a:solidFill>
+                        <a:srgbClr val="D5D8E0"/>
+                      </a:solidFill>
+                      <a:prstDash val="solid"/>
+                      <a:round/>
+                      <a:headEnd type="none" w="med" len="med"/>
+                      <a:tailEnd type="none" w="med" len="med"/>
+                    </a:lnL>
+                    <a:lnR w="9525" cap="flat" cmpd="sng" algn="ctr">
+                      <a:solidFill>
+                        <a:srgbClr val="D5D8E0"/>
+                      </a:solidFill>
+                      <a:prstDash val="solid"/>
+                      <a:round/>
+                      <a:headEnd type="none" w="med" len="med"/>
+                      <a:tailEnd type="none" w="med" len="med"/>
+                    </a:lnR>
+                    <a:lnT w="9525" cap="flat" cmpd="sng" algn="ctr">
+                      <a:solidFill>
+                        <a:srgbClr val="D5D8E0"/>
+                      </a:solidFill>
+                      <a:prstDash val="solid"/>
+                      <a:round/>
+                      <a:headEnd type="none" w="med" len="med"/>
+                      <a:tailEnd type="none" w="med" len="med"/>
+                    </a:lnT>
+                    <a:lnB w="9525" cap="flat" cmpd="sng" algn="ctr">
+                      <a:solidFill>
+                        <a:srgbClr val="D5D8E0"/>
+                      </a:solidFill>
+                      <a:prstDash val="solid"/>
+                      <a:round/>
+                      <a:headEnd type="none" w="med" len="med"/>
+                      <a:tailEnd type="none" w="med" len="med"/>
+                    </a:lnB>
+                    <a:solidFill>
+                      <a:schemeClr val="bg1"/>
+                    </a:solidFill>
+                  </a:tcPr>
+                </a:tc>
+                <a:tc>
+                  <a:txBody>
+                    <a:bodyPr/>
+                    <a:lstStyle/>
+                    <a:p>
+                      <a:pPr indent="0" marL="0">
+                        <a:buNone/>
+                      </a:pPr>
+                      <a:r>
+                        <a:rPr lang="en-US" sz="1200" dirty="0">
+                          <a:solidFill>
+                            <a:srgbClr val="000000"/>
+                          </a:solidFill>
+                        </a:rPr>
+                        <a:t>Endpoint tests, CI smoke</a:t>
+                      </a:r>
+                      <a:endParaRPr lang="en-US" sz="1200" dirty="0"/>
+                    </a:p>
+                  </a:txBody>
+                  <a:tcPr marL="91440" marR="91440" marT="36576" marB="36576" anchor="ctr">
+                    <a:lnL w="9525" cap="flat" cmpd="sng" algn="ctr">
+                      <a:solidFill>
+                        <a:srgbClr val="D5D8E0"/>
+                      </a:solidFill>
+                      <a:prstDash val="solid"/>
+                      <a:round/>
+                      <a:headEnd type="none" w="med" len="med"/>
+                      <a:tailEnd type="none" w="med" len="med"/>
+                    </a:lnL>
+                    <a:lnR w="9525" cap="flat" cmpd="sng" algn="ctr">
+                      <a:solidFill>
+                        <a:srgbClr val="D5D8E0"/>
+                      </a:solidFill>
+                      <a:prstDash val="solid"/>
+                      <a:round/>
+                      <a:headEnd type="none" w="med" len="med"/>
+                      <a:tailEnd type="none" w="med" len="med"/>
+                    </a:lnR>
+                    <a:lnT w="9525" cap="flat" cmpd="sng" algn="ctr">
+                      <a:solidFill>
+                        <a:srgbClr val="D5D8E0"/>
+                      </a:solidFill>
+                      <a:prstDash val="solid"/>
+                      <a:round/>
+                      <a:headEnd type="none" w="med" len="med"/>
+                      <a:tailEnd type="none" w="med" len="med"/>
+                    </a:lnT>
+                    <a:lnB w="9525" cap="flat" cmpd="sng" algn="ctr">
+                      <a:solidFill>
+                        <a:srgbClr val="D5D8E0"/>
+                      </a:solidFill>
+                      <a:prstDash val="solid"/>
+                      <a:round/>
+                      <a:headEnd type="none" w="med" len="med"/>
+                      <a:tailEnd type="none" w="med" len="med"/>
+                    </a:lnB>
+                    <a:solidFill>
+                      <a:schemeClr val="bg1"/>
+                    </a:solidFill>
+                  </a:tcPr>
+                </a:tc>
+              </a:tr>
+              <a:tr h="530352">
+                <a:tc>
+                  <a:txBody>
+                    <a:bodyPr/>
+                    <a:lstStyle/>
+                    <a:p>
+                      <a:pPr indent="0" marL="0">
+                        <a:buNone/>
+                      </a:pPr>
+                      <a:r>
+                        <a:rPr lang="en-US" sz="1200" b="1" dirty="0">
+                          <a:solidFill>
+                            <a:srgbClr val="000000"/>
+                          </a:solidFill>
+                        </a:rPr>
+                        <a:t>The same call is retried (timeout, restart)</a:t>
+                      </a:r>
+                      <a:endParaRPr lang="en-US" sz="1200" dirty="0"/>
+                    </a:p>
+                  </a:txBody>
+                  <a:tcPr marL="91440" marR="91440" marT="36576" marB="36576" anchor="ctr">
+                    <a:lnL w="9525" cap="flat" cmpd="sng" algn="ctr">
+                      <a:solidFill>
+                        <a:srgbClr val="D5D8E0"/>
+                      </a:solidFill>
+                      <a:prstDash val="solid"/>
+                      <a:round/>
+                      <a:headEnd type="none" w="med" len="med"/>
+                      <a:tailEnd type="none" w="med" len="med"/>
+                    </a:lnL>
+                    <a:lnR w="9525" cap="flat" cmpd="sng" algn="ctr">
+                      <a:solidFill>
+                        <a:srgbClr val="D5D8E0"/>
+                      </a:solidFill>
+                      <a:prstDash val="solid"/>
+                      <a:round/>
+                      <a:headEnd type="none" w="med" len="med"/>
+                      <a:tailEnd type="none" w="med" len="med"/>
+                    </a:lnR>
+                    <a:lnT w="9525" cap="flat" cmpd="sng" algn="ctr">
+                      <a:solidFill>
+                        <a:srgbClr val="D5D8E0"/>
+                      </a:solidFill>
+                      <a:prstDash val="solid"/>
+                      <a:round/>
+                      <a:headEnd type="none" w="med" len="med"/>
+                      <a:tailEnd type="none" w="med" len="med"/>
+                    </a:lnT>
+                    <a:lnB w="9525" cap="flat" cmpd="sng" algn="ctr">
+                      <a:solidFill>
+                        <a:srgbClr val="D5D8E0"/>
+                      </a:solidFill>
+                      <a:prstDash val="solid"/>
+                      <a:round/>
+                      <a:headEnd type="none" w="med" len="med"/>
+                      <a:tailEnd type="none" w="med" len="med"/>
+                    </a:lnB>
+                    <a:solidFill>
+                      <a:schemeClr val="bg1"/>
+                    </a:solidFill>
+                  </a:tcPr>
+                </a:tc>
+                <a:tc>
+                  <a:txBody>
+                    <a:bodyPr/>
+                    <a:lstStyle/>
+                    <a:p>
+                      <a:pPr indent="0" marL="0">
+                        <a:buNone/>
+                      </a:pPr>
+                      <a:r>
+                        <a:rPr lang="en-US" sz="1200" dirty="0">
+                          <a:solidFill>
+                            <a:srgbClr val="000000"/>
+                          </a:solidFill>
+                        </a:rPr>
+                        <a:t>Returns the stored reservation; no second deduction</a:t>
+                      </a:r>
+                      <a:endParaRPr lang="en-US" sz="1200" dirty="0"/>
+                    </a:p>
+                  </a:txBody>
+                  <a:tcPr marL="91440" marR="91440" marT="36576" marB="36576" anchor="ctr">
+                    <a:lnL w="9525" cap="flat" cmpd="sng" algn="ctr">
+                      <a:solidFill>
+                        <a:srgbClr val="D5D8E0"/>
+                      </a:solidFill>
+                      <a:prstDash val="solid"/>
+                      <a:round/>
+                      <a:headEnd type="none" w="med" len="med"/>
+                      <a:tailEnd type="none" w="med" len="med"/>
+                    </a:lnL>
+                    <a:lnR w="9525" cap="flat" cmpd="sng" algn="ctr">
+                      <a:solidFill>
+                        <a:srgbClr val="D5D8E0"/>
+                      </a:solidFill>
+                      <a:prstDash val="solid"/>
+                      <a:round/>
+                      <a:headEnd type="none" w="med" len="med"/>
+                      <a:tailEnd type="none" w="med" len="med"/>
+                    </a:lnR>
+                    <a:lnT w="9525" cap="flat" cmpd="sng" algn="ctr">
+                      <a:solidFill>
+                        <a:srgbClr val="D5D8E0"/>
+                      </a:solidFill>
+                      <a:prstDash val="solid"/>
+                      <a:round/>
+                      <a:headEnd type="none" w="med" len="med"/>
+                      <a:tailEnd type="none" w="med" len="med"/>
+                    </a:lnT>
+                    <a:lnB w="9525" cap="flat" cmpd="sng" algn="ctr">
+                      <a:solidFill>
+                        <a:srgbClr val="D5D8E0"/>
+                      </a:solidFill>
+                      <a:prstDash val="solid"/>
+                      <a:round/>
+                      <a:headEnd type="none" w="med" len="med"/>
+                      <a:tailEnd type="none" w="med" len="med"/>
+                    </a:lnB>
+                    <a:solidFill>
+                      <a:schemeClr val="bg1"/>
+                    </a:solidFill>
+                  </a:tcPr>
+                </a:tc>
+                <a:tc>
+                  <a:txBody>
+                    <a:bodyPr/>
+                    <a:lstStyle/>
+                    <a:p>
+                      <a:pPr indent="0" marL="0">
+                        <a:buNone/>
+                      </a:pPr>
+                      <a:r>
+                        <a:rPr lang="en-US" sz="1200" dirty="0">
+                          <a:solidFill>
+                            <a:srgbClr val="000000"/>
+                          </a:solidFill>
+                        </a:rPr>
+                        <a:t>10 concurrent replays on PostgreSQL</a:t>
+                      </a:r>
+                      <a:endParaRPr lang="en-US" sz="1200" dirty="0"/>
+                    </a:p>
+                  </a:txBody>
+                  <a:tcPr marL="91440" marR="91440" marT="36576" marB="36576" anchor="ctr">
+                    <a:lnL w="9525" cap="flat" cmpd="sng" algn="ctr">
+                      <a:solidFill>
+                        <a:srgbClr val="D5D8E0"/>
+                      </a:solidFill>
+                      <a:prstDash val="solid"/>
+                      <a:round/>
+                      <a:headEnd type="none" w="med" len="med"/>
+                      <a:tailEnd type="none" w="med" len="med"/>
+                    </a:lnL>
+                    <a:lnR w="9525" cap="flat" cmpd="sng" algn="ctr">
+                      <a:solidFill>
+                        <a:srgbClr val="D5D8E0"/>
+                      </a:solidFill>
+                      <a:prstDash val="solid"/>
+                      <a:round/>
+                      <a:headEnd type="none" w="med" len="med"/>
+                      <a:tailEnd type="none" w="med" len="med"/>
+                    </a:lnR>
+                    <a:lnT w="9525" cap="flat" cmpd="sng" algn="ctr">
+                      <a:solidFill>
+                        <a:srgbClr val="D5D8E0"/>
+                      </a:solidFill>
+                      <a:prstDash val="solid"/>
+                      <a:round/>
+                      <a:headEnd type="none" w="med" len="med"/>
+                      <a:tailEnd type="none" w="med" len="med"/>
+                    </a:lnT>
+                    <a:lnB w="9525" cap="flat" cmpd="sng" algn="ctr">
+                      <a:solidFill>
+                        <a:srgbClr val="D5D8E0"/>
+                      </a:solidFill>
+                      <a:prstDash val="solid"/>
+                      <a:round/>
+                      <a:headEnd type="none" w="med" len="med"/>
+                      <a:tailEnd type="none" w="med" len="med"/>
+                    </a:lnB>
+                    <a:solidFill>
+                      <a:schemeClr val="bg1"/>
+                    </a:solidFill>
+                  </a:tcPr>
+                </a:tc>
+              </a:tr>
+              <a:tr h="530352">
+                <a:tc>
+                  <a:txBody>
+                    <a:bodyPr/>
+                    <a:lstStyle/>
+                    <a:p>
+                      <a:pPr indent="0" marL="0">
+                        <a:buNone/>
+                      </a:pPr>
+                      <a:r>
+                        <a:rPr lang="en-US" sz="1200" b="1" dirty="0">
+                          <a:solidFill>
+                            <a:srgbClr val="000000"/>
+                          </a:solidFill>
+                        </a:rPr>
+                        <a:t>30 checkouts race for the last 20 units</a:t>
+                      </a:r>
+                      <a:endParaRPr lang="en-US" sz="1200" dirty="0"/>
+                    </a:p>
+                  </a:txBody>
+                  <a:tcPr marL="91440" marR="91440" marT="36576" marB="36576" anchor="ctr">
+                    <a:lnL w="9525" cap="flat" cmpd="sng" algn="ctr">
+                      <a:solidFill>
+                        <a:srgbClr val="D5D8E0"/>
+                      </a:solidFill>
+                      <a:prstDash val="solid"/>
+                      <a:round/>
+                      <a:headEnd type="none" w="med" len="med"/>
+                      <a:tailEnd type="none" w="med" len="med"/>
+                    </a:lnL>
+                    <a:lnR w="9525" cap="flat" cmpd="sng" algn="ctr">
+                      <a:solidFill>
+                        <a:srgbClr val="D5D8E0"/>
+                      </a:solidFill>
+                      <a:prstDash val="solid"/>
+                      <a:round/>
+                      <a:headEnd type="none" w="med" len="med"/>
+                      <a:tailEnd type="none" w="med" len="med"/>
+                    </a:lnR>
+                    <a:lnT w="9525" cap="flat" cmpd="sng" algn="ctr">
+                      <a:solidFill>
+                        <a:srgbClr val="D5D8E0"/>
+                      </a:solidFill>
+                      <a:prstDash val="solid"/>
+                      <a:round/>
+                      <a:headEnd type="none" w="med" len="med"/>
+                      <a:tailEnd type="none" w="med" len="med"/>
+                    </a:lnT>
+                    <a:lnB w="9525" cap="flat" cmpd="sng" algn="ctr">
+                      <a:solidFill>
+                        <a:srgbClr val="D5D8E0"/>
+                      </a:solidFill>
+                      <a:prstDash val="solid"/>
+                      <a:round/>
+                      <a:headEnd type="none" w="med" len="med"/>
+                      <a:tailEnd type="none" w="med" len="med"/>
+                    </a:lnB>
+                    <a:solidFill>
+                      <a:schemeClr val="bg1"/>
+                    </a:solidFill>
+                  </a:tcPr>
+                </a:tc>
+                <a:tc>
+                  <a:txBody>
+                    <a:bodyPr/>
+                    <a:lstStyle/>
+                    <a:p>
+                      <a:pPr indent="0" marL="0">
+                        <a:buNone/>
+                      </a:pPr>
+                      <a:r>
+                        <a:rPr lang="en-US" sz="1200" dirty="0">
+                          <a:solidFill>
+                            <a:srgbClr val="000000"/>
+                          </a:solidFill>
+                        </a:rPr>
+                        <a:t>Exactly 20 succeed; stock ends at 0</a:t>
+                      </a:r>
+                      <a:endParaRPr lang="en-US" sz="1200" dirty="0"/>
+                    </a:p>
+                  </a:txBody>
+                  <a:tcPr marL="91440" marR="91440" marT="36576" marB="36576" anchor="ctr">
+                    <a:lnL w="9525" cap="flat" cmpd="sng" algn="ctr">
+                      <a:solidFill>
+                        <a:srgbClr val="D5D8E0"/>
+                      </a:solidFill>
+                      <a:prstDash val="solid"/>
+                      <a:round/>
+                      <a:headEnd type="none" w="med" len="med"/>
+                      <a:tailEnd type="none" w="med" len="med"/>
+                    </a:lnL>
+                    <a:lnR w="9525" cap="flat" cmpd="sng" algn="ctr">
+                      <a:solidFill>
+                        <a:srgbClr val="D5D8E0"/>
+                      </a:solidFill>
+                      <a:prstDash val="solid"/>
+                      <a:round/>
+                      <a:headEnd type="none" w="med" len="med"/>
+                      <a:tailEnd type="none" w="med" len="med"/>
+                    </a:lnR>
+                    <a:lnT w="9525" cap="flat" cmpd="sng" algn="ctr">
+                      <a:solidFill>
+                        <a:srgbClr val="D5D8E0"/>
+                      </a:solidFill>
+                      <a:prstDash val="solid"/>
+                      <a:round/>
+                      <a:headEnd type="none" w="med" len="med"/>
+                      <a:tailEnd type="none" w="med" len="med"/>
+                    </a:lnT>
+                    <a:lnB w="9525" cap="flat" cmpd="sng" algn="ctr">
+                      <a:solidFill>
+                        <a:srgbClr val="D5D8E0"/>
+                      </a:solidFill>
+                      <a:prstDash val="solid"/>
+                      <a:round/>
+                      <a:headEnd type="none" w="med" len="med"/>
+                      <a:tailEnd type="none" w="med" len="med"/>
+                    </a:lnB>
+                    <a:solidFill>
+                      <a:schemeClr val="bg1"/>
+                    </a:solidFill>
+                  </a:tcPr>
+                </a:tc>
+                <a:tc>
+                  <a:txBody>
+                    <a:bodyPr/>
+                    <a:lstStyle/>
+                    <a:p>
+                      <a:pPr indent="0" marL="0">
+                        <a:buNone/>
+                      </a:pPr>
+                      <a:r>
+                        <a:rPr lang="en-US" sz="1200" dirty="0">
+                          <a:solidFill>
+                            <a:srgbClr val="000000"/>
+                          </a:solidFill>
+                        </a:rPr>
+                        <a:t>PostgreSQL race test</a:t>
+                      </a:r>
+                      <a:endParaRPr lang="en-US" sz="1200" dirty="0"/>
+                    </a:p>
+                  </a:txBody>
+                  <a:tcPr marL="91440" marR="91440" marT="36576" marB="36576" anchor="ctr">
+                    <a:lnL w="9525" cap="flat" cmpd="sng" algn="ctr">
+                      <a:solidFill>
+                        <a:srgbClr val="D5D8E0"/>
+                      </a:solidFill>
+                      <a:prstDash val="solid"/>
+                      <a:round/>
+                      <a:headEnd type="none" w="med" len="med"/>
+                      <a:tailEnd type="none" w="med" len="med"/>
+                    </a:lnL>
+                    <a:lnR w="9525" cap="flat" cmpd="sng" algn="ctr">
+                      <a:solidFill>
+                        <a:srgbClr val="D5D8E0"/>
+                      </a:solidFill>
+                      <a:prstDash val="solid"/>
+                      <a:round/>
+                      <a:headEnd type="none" w="med" len="med"/>
+                      <a:tailEnd type="none" w="med" len="med"/>
+                    </a:lnR>
+                    <a:lnT w="9525" cap="flat" cmpd="sng" algn="ctr">
+                      <a:solidFill>
+                        <a:srgbClr val="D5D8E0"/>
+                      </a:solidFill>
+                      <a:prstDash val="solid"/>
+                      <a:round/>
+                      <a:headEnd type="none" w="med" len="med"/>
+                      <a:tailEnd type="none" w="med" len="med"/>
+                    </a:lnT>
+                    <a:lnB w="9525" cap="flat" cmpd="sng" algn="ctr">
+                      <a:solidFill>
+                        <a:srgbClr val="D5D8E0"/>
+                      </a:solidFill>
+                      <a:prstDash val="solid"/>
+                      <a:round/>
+                      <a:headEnd type="none" w="med" len="med"/>
+                      <a:tailEnd type="none" w="med" len="med"/>
+                    </a:lnB>
+                    <a:solidFill>
+                      <a:schemeClr val="bg1"/>
+                    </a:solidFill>
+                  </a:tcPr>
+                </a:tc>
+              </a:tr>
+              <a:tr h="530352">
+                <a:tc>
+                  <a:txBody>
+                    <a:bodyPr/>
+                    <a:lstStyle/>
+                    <a:p>
+                      <a:pPr indent="0" marL="0">
+                        <a:buNone/>
+                      </a:pPr>
+                      <a:r>
+                        <a:rPr lang="en-US" sz="1200" b="1" dirty="0">
+                          <a:solidFill>
+                            <a:srgbClr val="000000"/>
+                          </a:solidFill>
+                        </a:rPr>
+                        <a:t>Order is cancelled or a merchant rejects</a:t>
+                      </a:r>
+                      <a:endParaRPr lang="en-US" sz="1200" dirty="0"/>
+                    </a:p>
+                  </a:txBody>
+                  <a:tcPr marL="91440" marR="91440" marT="36576" marB="36576" anchor="ctr">
+                    <a:lnL w="9525" cap="flat" cmpd="sng" algn="ctr">
+                      <a:solidFill>
+                        <a:srgbClr val="D5D8E0"/>
+                      </a:solidFill>
+                      <a:prstDash val="solid"/>
+                      <a:round/>
+                      <a:headEnd type="none" w="med" len="med"/>
+                      <a:tailEnd type="none" w="med" len="med"/>
+                    </a:lnL>
+                    <a:lnR w="9525" cap="flat" cmpd="sng" algn="ctr">
+                      <a:solidFill>
+                        <a:srgbClr val="D5D8E0"/>
+                      </a:solidFill>
+                      <a:prstDash val="solid"/>
+                      <a:round/>
+                      <a:headEnd type="none" w="med" len="med"/>
+                      <a:tailEnd type="none" w="med" len="med"/>
+                    </a:lnR>
+                    <a:lnT w="9525" cap="flat" cmpd="sng" algn="ctr">
+                      <a:solidFill>
+                        <a:srgbClr val="D5D8E0"/>
+                      </a:solidFill>
+                      <a:prstDash val="solid"/>
+                      <a:round/>
+                      <a:headEnd type="none" w="med" len="med"/>
+                      <a:tailEnd type="none" w="med" len="med"/>
+                    </a:lnT>
+                    <a:lnB w="9525" cap="flat" cmpd="sng" algn="ctr">
+                      <a:solidFill>
+                        <a:srgbClr val="D5D8E0"/>
+                      </a:solidFill>
+                      <a:prstDash val="solid"/>
+                      <a:round/>
+                      <a:headEnd type="none" w="med" len="med"/>
+                      <a:tailEnd type="none" w="med" len="med"/>
+                    </a:lnB>
+                    <a:solidFill>
+                      <a:schemeClr val="bg1"/>
+                    </a:solidFill>
+                  </a:tcPr>
+                </a:tc>
+                <a:tc>
+                  <a:txBody>
+                    <a:bodyPr/>
+                    <a:lstStyle/>
+                    <a:p>
+                      <a:pPr indent="0" marL="0">
+                        <a:buNone/>
+                      </a:pPr>
+                      <a:r>
+                        <a:rPr lang="en-US" sz="1200" dirty="0">
+                          <a:solidFill>
+                            <a:srgbClr val="000000"/>
+                          </a:solidFill>
+                        </a:rPr>
+                        <a:t>Release restores stock once, optionally for one merchant</a:t>
+                      </a:r>
+                      <a:endParaRPr lang="en-US" sz="1200" dirty="0"/>
+                    </a:p>
+                  </a:txBody>
+                  <a:tcPr marL="91440" marR="91440" marT="36576" marB="36576" anchor="ctr">
+                    <a:lnL w="9525" cap="flat" cmpd="sng" algn="ctr">
+                      <a:solidFill>
+                        <a:srgbClr val="D5D8E0"/>
+                      </a:solidFill>
+                      <a:prstDash val="solid"/>
+                      <a:round/>
+                      <a:headEnd type="none" w="med" len="med"/>
+                      <a:tailEnd type="none" w="med" len="med"/>
+                    </a:lnL>
+                    <a:lnR w="9525" cap="flat" cmpd="sng" algn="ctr">
+                      <a:solidFill>
+                        <a:srgbClr val="D5D8E0"/>
+                      </a:solidFill>
+                      <a:prstDash val="solid"/>
+                      <a:round/>
+                      <a:headEnd type="none" w="med" len="med"/>
+                      <a:tailEnd type="none" w="med" len="med"/>
+                    </a:lnR>
+                    <a:lnT w="9525" cap="flat" cmpd="sng" algn="ctr">
+                      <a:solidFill>
+                        <a:srgbClr val="D5D8E0"/>
+                      </a:solidFill>
+                      <a:prstDash val="solid"/>
+                      <a:round/>
+                      <a:headEnd type="none" w="med" len="med"/>
+                      <a:tailEnd type="none" w="med" len="med"/>
+                    </a:lnT>
+                    <a:lnB w="9525" cap="flat" cmpd="sng" algn="ctr">
+                      <a:solidFill>
+                        <a:srgbClr val="D5D8E0"/>
+                      </a:solidFill>
+                      <a:prstDash val="solid"/>
+                      <a:round/>
+                      <a:headEnd type="none" w="med" len="med"/>
+                      <a:tailEnd type="none" w="med" len="med"/>
+                    </a:lnB>
+                    <a:solidFill>
+                      <a:schemeClr val="bg1"/>
+                    </a:solidFill>
+                  </a:tcPr>
+                </a:tc>
+                <a:tc>
+                  <a:txBody>
+                    <a:bodyPr/>
+                    <a:lstStyle/>
+                    <a:p>
+                      <a:pPr indent="0" marL="0">
+                        <a:buNone/>
+                      </a:pPr>
+                      <a:r>
+                        <a:rPr lang="en-US" sz="1200" dirty="0">
+                          <a:solidFill>
+                            <a:srgbClr val="000000"/>
+                          </a:solidFill>
+                        </a:rPr>
+                        <a:t>Service and PostgreSQL tests</a:t>
+                      </a:r>
+                      <a:endParaRPr lang="en-US" sz="1200" dirty="0"/>
+                    </a:p>
+                  </a:txBody>
+                  <a:tcPr marL="91440" marR="91440" marT="36576" marB="36576" anchor="ctr">
+                    <a:lnL w="9525" cap="flat" cmpd="sng" algn="ctr">
+                      <a:solidFill>
+                        <a:srgbClr val="D5D8E0"/>
+                      </a:solidFill>
+                      <a:prstDash val="solid"/>
+                      <a:round/>
+                      <a:headEnd type="none" w="med" len="med"/>
+                      <a:tailEnd type="none" w="med" len="med"/>
+                    </a:lnL>
+                    <a:lnR w="9525" cap="flat" cmpd="sng" algn="ctr">
+                      <a:solidFill>
+                        <a:srgbClr val="D5D8E0"/>
+                      </a:solidFill>
+                      <a:prstDash val="solid"/>
+                      <a:round/>
+                      <a:headEnd type="none" w="med" len="med"/>
+                      <a:tailEnd type="none" w="med" len="med"/>
+                    </a:lnR>
+                    <a:lnT w="9525" cap="flat" cmpd="sng" algn="ctr">
+                      <a:solidFill>
+                        <a:srgbClr val="D5D8E0"/>
+                      </a:solidFill>
+                      <a:prstDash val="solid"/>
+                      <a:round/>
+                      <a:headEnd type="none" w="med" len="med"/>
+                      <a:tailEnd type="none" w="med" len="med"/>
+                    </a:lnT>
+                    <a:lnB w="9525" cap="flat" cmpd="sng" algn="ctr">
+                      <a:solidFill>
+                        <a:srgbClr val="D5D8E0"/>
+                      </a:solidFill>
+                      <a:prstDash val="solid"/>
+                      <a:round/>
+                      <a:headEnd type="none" w="med" len="med"/>
+                      <a:tailEnd type="none" w="med" len="med"/>
+                    </a:lnB>
+                    <a:solidFill>
+                      <a:schemeClr val="bg1"/>
+                    </a:solidFill>
+                  </a:tcPr>
+                </a:tc>
+              </a:tr>
+              <a:tr h="530352">
+                <a:tc>
+                  <a:txBody>
+                    <a:bodyPr/>
+                    <a:lstStyle/>
+                    <a:p>
+                      <a:pPr indent="0" marL="0">
+                        <a:buNone/>
+                      </a:pPr>
+                      <a:r>
+                        <a:rPr lang="en-US" sz="1200" b="1" dirty="0">
+                          <a:solidFill>
+                            <a:srgbClr val="000000"/>
+                          </a:solidFill>
+                        </a:rPr>
+                        <a:t>A customer calls it directly</a:t>
+                      </a:r>
+                      <a:endParaRPr lang="en-US" sz="1200" dirty="0"/>
+                    </a:p>
+                  </a:txBody>
+                  <a:tcPr marL="91440" marR="91440" marT="36576" marB="36576" anchor="ctr">
+                    <a:lnL w="9525" cap="flat" cmpd="sng" algn="ctr">
+                      <a:solidFill>
+                        <a:srgbClr val="D5D8E0"/>
+                      </a:solidFill>
+                      <a:prstDash val="solid"/>
+                      <a:round/>
+                      <a:headEnd type="none" w="med" len="med"/>
+                      <a:tailEnd type="none" w="med" len="med"/>
+                    </a:lnL>
+                    <a:lnR w="9525" cap="flat" cmpd="sng" algn="ctr">
+                      <a:solidFill>
+                        <a:srgbClr val="D5D8E0"/>
+                      </a:solidFill>
+                      <a:prstDash val="solid"/>
+                      <a:round/>
+                      <a:headEnd type="none" w="med" len="med"/>
+                      <a:tailEnd type="none" w="med" len="med"/>
+                    </a:lnR>
+                    <a:lnT w="9525" cap="flat" cmpd="sng" algn="ctr">
+                      <a:solidFill>
+                        <a:srgbClr val="D5D8E0"/>
+                      </a:solidFill>
+                      <a:prstDash val="solid"/>
+                      <a:round/>
+                      <a:headEnd type="none" w="med" len="med"/>
+                      <a:tailEnd type="none" w="med" len="med"/>
+                    </a:lnT>
+                    <a:lnB w="9525" cap="flat" cmpd="sng" algn="ctr">
+                      <a:solidFill>
+                        <a:srgbClr val="D5D8E0"/>
+                      </a:solidFill>
+                      <a:prstDash val="solid"/>
+                      <a:round/>
+                      <a:headEnd type="none" w="med" len="med"/>
+                      <a:tailEnd type="none" w="med" len="med"/>
+                    </a:lnB>
+                    <a:solidFill>
+                      <a:schemeClr val="bg1"/>
+                    </a:solidFill>
+                  </a:tcPr>
+                </a:tc>
+                <a:tc>
+                  <a:txBody>
+                    <a:bodyPr/>
+                    <a:lstStyle/>
+                    <a:p>
+                      <a:pPr indent="0" marL="0">
+                        <a:buNone/>
+                      </a:pPr>
+                      <a:r>
+                        <a:rPr lang="en-US" sz="1200" dirty="0">
+                          <a:solidFill>
+                            <a:srgbClr val="000000"/>
+                          </a:solidFill>
+                        </a:rPr>
+                        <a:t>Gateway has no /internal route (404); a JWT is still required</a:t>
+                      </a:r>
+                      <a:endParaRPr lang="en-US" sz="1200" dirty="0"/>
+                    </a:p>
+                  </a:txBody>
+                  <a:tcPr marL="91440" marR="91440" marT="36576" marB="36576" anchor="ctr">
+                    <a:lnL w="9525" cap="flat" cmpd="sng" algn="ctr">
+                      <a:solidFill>
+                        <a:srgbClr val="D5D8E0"/>
+                      </a:solidFill>
+                      <a:prstDash val="solid"/>
+                      <a:round/>
+                      <a:headEnd type="none" w="med" len="med"/>
+                      <a:tailEnd type="none" w="med" len="med"/>
+                    </a:lnL>
+                    <a:lnR w="9525" cap="flat" cmpd="sng" algn="ctr">
+                      <a:solidFill>
+                        <a:srgbClr val="D5D8E0"/>
+                      </a:solidFill>
+                      <a:prstDash val="solid"/>
+                      <a:round/>
+                      <a:headEnd type="none" w="med" len="med"/>
+                      <a:tailEnd type="none" w="med" len="med"/>
+                    </a:lnR>
+                    <a:lnT w="9525" cap="flat" cmpd="sng" algn="ctr">
+                      <a:solidFill>
+                        <a:srgbClr val="D5D8E0"/>
+                      </a:solidFill>
+                      <a:prstDash val="solid"/>
+                      <a:round/>
+                      <a:headEnd type="none" w="med" len="med"/>
+                      <a:tailEnd type="none" w="med" len="med"/>
+                    </a:lnT>
+                    <a:lnB w="9525" cap="flat" cmpd="sng" algn="ctr">
+                      <a:solidFill>
+                        <a:srgbClr val="D5D8E0"/>
+                      </a:solidFill>
+                      <a:prstDash val="solid"/>
+                      <a:round/>
+                      <a:headEnd type="none" w="med" len="med"/>
+                      <a:tailEnd type="none" w="med" len="med"/>
+                    </a:lnB>
+                    <a:solidFill>
+                      <a:schemeClr val="bg1"/>
+                    </a:solidFill>
+                  </a:tcPr>
+                </a:tc>
+                <a:tc>
+                  <a:txBody>
+                    <a:bodyPr/>
+                    <a:lstStyle/>
+                    <a:p>
+                      <a:pPr indent="0" marL="0">
+                        <a:buNone/>
+                      </a:pPr>
+                      <a:r>
+                        <a:rPr lang="en-US" sz="1200" dirty="0">
+                          <a:solidFill>
+                            <a:srgbClr val="000000"/>
+                          </a:solidFill>
+                        </a:rPr>
+                        <a:t>CI microservices smoke</a:t>
+                      </a:r>
+                      <a:endParaRPr lang="en-US" sz="1200" dirty="0"/>
+                    </a:p>
+                  </a:txBody>
+                  <a:tcPr marL="91440" marR="91440" marT="36576" marB="36576" anchor="ctr">
+                    <a:lnL w="9525" cap="flat" cmpd="sng" algn="ctr">
+                      <a:solidFill>
+                        <a:srgbClr val="D5D8E0"/>
+                      </a:solidFill>
+                      <a:prstDash val="solid"/>
+                      <a:round/>
+                      <a:headEnd type="none" w="med" len="med"/>
+                      <a:tailEnd type="none" w="med" len="med"/>
+                    </a:lnL>
+                    <a:lnR w="9525" cap="flat" cmpd="sng" algn="ctr">
+                      <a:solidFill>
+                        <a:srgbClr val="D5D8E0"/>
+                      </a:solidFill>
+                      <a:prstDash val="solid"/>
+                      <a:round/>
+                      <a:headEnd type="none" w="med" len="med"/>
+                      <a:tailEnd type="none" w="med" len="med"/>
+                    </a:lnR>
+                    <a:lnT w="9525" cap="flat" cmpd="sng" algn="ctr">
+                      <a:solidFill>
+                        <a:srgbClr val="D5D8E0"/>
+                      </a:solidFill>
+                      <a:prstDash val="solid"/>
+                      <a:round/>
+                      <a:headEnd type="none" w="med" len="med"/>
+                      <a:tailEnd type="none" w="med" len="med"/>
+                    </a:lnT>
+                    <a:lnB w="9525" cap="flat" cmpd="sng" algn="ctr">
+                      <a:solidFill>
+                        <a:srgbClr val="D5D8E0"/>
+                      </a:solidFill>
+                      <a:prstDash val="solid"/>
+                      <a:round/>
+                      <a:headEnd type="none" w="med" len="med"/>
+                      <a:tailEnd type="none" w="med" len="med"/>
+                    </a:lnB>
+                    <a:solidFill>
+                      <a:schemeClr val="bg1"/>
+                    </a:solidFill>
+                  </a:tcPr>
+                </a:tc>
+              </a:tr>
+            </a:tbl>
+          </a:graphicData>
+        </a:graphic>
+      </p:graphicFrame>
+      <p:sp>
+        <p:nvSpPr>
+          <p:cNvPr id="25" name="Slide Number Placeholder 0"/>
+          <p:cNvSpPr>
+            <a:spLocks noGrp="1"/>
+          </p:cNvSpPr>
+          <p:nvPr>
+            <p:ph type="sldNum" sz="quarter" idx="4294967295"/>
+          </p:nvPr>
+        </p:nvSpPr>
+        <p:spPr>
+          <a:xfrm>
+            <a:off x="8229600" y="4754880"/>
+            <a:ext cx="457200" cy="274320"/>
+          </a:xfrm>
+          <a:prstGeom prst="rect">
+            <a:avLst/>
+          </a:prstGeom>
+          <a:extLst>
+            <a:ext uri="{C572A759-6A51-4108-AA02-DFA0A04FC94B}">
+              <ma14:wrappingTextBoxFlag xmlns:ma14="http://schemas.microsoft.com/office/mac/drawingml/2011/main" val="0"/>
+            </a:ext>
+          </a:extLst>
+        </p:spPr>
+        <p:txBody>
+          <a:bodyPr/>
+          <a:lstStyle>
+            <a:lvl1pPr>
+              <a:defRPr sz="1000">
+                <a:solidFill>
+                  <a:schemeClr val="accent5"/>
+                </a:solidFill>
+              </a:defRPr>
+            </a:lvl1pPr>
+          </a:lstStyle>
+          <a:p>
+            <a:pPr algn="r"/>
+            <a:fld id="{F7021451-1387-4CA6-816F-3879F97B5CBC}" type="slidenum">
+              <a:rPr b="0" lang="en-US"/>
+              <a:t>14</a:t>
+            </a:fld>
+            <a:endParaRPr lang="en-US"/>
           </a:p>
         </p:txBody>
       </p:sp>
@@ -16967,7 +19775,7 @@
                             <a:srgbClr val="000000"/>
                           </a:solidFill>
                         </a:rPr>
-                        <a:t>One modular API with feature modules; nginx at the edge</a:t>
+                        <a:t>YARP gateway; Identity and Catalog run as services; Order and Fulfilment moving; the monolith still serves the full flow</a:t>
                       </a:r>
                       <a:endParaRPr lang="en-US" sz="1200" dirty="0"/>
                     </a:p>
@@ -17028,7 +19836,7 @@
                             <a:srgbClr val="A86A00"/>
                           </a:solidFill>
                         </a:rPr>
-                        <a:t>Changed</a:t>
+                        <a:t>In progress</a:t>
                       </a:r>
                       <a:endParaRPr lang="en-US" sz="1200" dirty="0"/>
                     </a:p>
@@ -17213,7 +20021,7 @@
                             <a:srgbClr val="000000"/>
                           </a:solidFill>
                         </a:rPr>
-                        <a:t>One PostgreSQL database; modules call each other inside one transaction</a:t>
+                        <a:t>One database per service; replay-safe stock reservation between services; no Service Bus yet</a:t>
                       </a:r>
                       <a:endParaRPr lang="en-US" sz="1200" dirty="0"/>
                     </a:p>
@@ -17274,7 +20082,7 @@
                             <a:srgbClr val="A86A00"/>
                           </a:solidFill>
                         </a:rPr>
-                        <a:t>Changed</a:t>
+                        <a:t>Partly</a:t>
                       </a:r>
                       <a:endParaRPr lang="en-US" sz="1200" dirty="0"/>
                     </a:p>
@@ -18391,6 +21199,47 @@
           </a:p>
         </p:txBody>
       </p:sp>
+      <p:sp>
+        <p:nvSpPr>
+          <p:cNvPr id="26" name="MARKER 【待队友】全组统一口径：先做模块化单体保"/>
+          <p:cNvSpPr txBox="1"/>
+          <p:nvPr/>
+        </p:nvSpPr>
+        <p:spPr>
+          <a:xfrm>
+            <a:off x="5120640" y="347472"/>
+            <a:ext cx="3566160" cy="502920"/>
+          </a:xfrm>
+          <a:prstGeom prst="rect">
+            <a:avLst/>
+          </a:prstGeom>
+          <a:solidFill>
+            <a:srgbClr val="FCE7F3"/>
+          </a:solidFill>
+          <a:ln>
+            <a:solidFill>
+              <a:srgbClr val="B0108A"/>
+            </a:solidFill>
+          </a:ln>
+        </p:spPr>
+        <p:txBody>
+          <a:bodyPr wrap="square" anchor="ctr" lIns="73152" rIns="73152">
+            <a:spAutoFit/>
+          </a:bodyPr>
+          <a:lstStyle/>
+          <a:p>
+            <a:r>
+              <a:rPr sz="1000" b="1">
+                <a:solidFill>
+                  <a:srgbClr val="B0108A"/>
+                </a:solidFill>
+              </a:rPr>
+              <a:t>【待队友】全组统一口径：先做模块化单体保证正确，再逐个拆服务（见备注）
+【待Member4/5】周二前更新 Order/Fulfilment 状态</a:t>
+            </a:r>
+          </a:p>
+        </p:txBody>
+      </p:sp>
     </p:spTree>
   </p:cSld>
   <p:clrMapOvr>
@@ -19662,6 +22511,46 @@
               <a:t>5</a:t>
             </a:fld>
             <a:endParaRPr lang="en-US"/>
+          </a:p>
+        </p:txBody>
+      </p:sp>
+      <p:sp>
+        <p:nvSpPr>
+          <p:cNvPr id="39" name="MARKER 【待队友】右侧换成每人实际投入（人天）；"/>
+          <p:cNvSpPr txBox="1"/>
+          <p:nvPr/>
+        </p:nvSpPr>
+        <p:spPr>
+          <a:xfrm>
+            <a:off x="5120640" y="347472"/>
+            <a:ext cx="3566160" cy="502920"/>
+          </a:xfrm>
+          <a:prstGeom prst="rect">
+            <a:avLst/>
+          </a:prstGeom>
+          <a:solidFill>
+            <a:srgbClr val="FCE7F3"/>
+          </a:solidFill>
+          <a:ln>
+            <a:solidFill>
+              <a:srgbClr val="B0108A"/>
+            </a:solidFill>
+          </a:ln>
+        </p:spPr>
+        <p:txBody>
+          <a:bodyPr wrap="square" anchor="ctr" lIns="73152" rIns="73152">
+            <a:spAutoFit/>
+          </a:bodyPr>
+          <a:lstStyle/>
+          <a:p>
+            <a:r>
+              <a:rPr sz="1000" b="1">
+                <a:solidFill>
+                  <a:srgbClr val="B0108A"/>
+                </a:solidFill>
+              </a:rPr>
+              <a:t>【待队友】右侧换成每人实际投入（人天）；Lil-Draky 是哪位成员？Sprint 5 微服务拆分要不要加一行</a:t>
+            </a:r>
           </a:p>
         </p:txBody>
       </p:sp>
@@ -19953,7 +22842,7 @@
                             <a:srgbClr val="000000"/>
                           </a:solidFill>
                         </a:rPr>
-                        <a:t>Modular monolith, one folder per feature</a:t>
+                        <a:t>Monolith first, then carve out services</a:t>
                       </a:r>
                       <a:endParaRPr lang="en-US" sz="1200" dirty="0"/>
                     </a:p>
@@ -20014,7 +22903,7 @@
                             <a:srgbClr val="000000"/>
                           </a:solidFill>
                         </a:rPr>
-                        <a:t>Five-person team; checkout must change cart, stock, coupons and order in one transaction</a:t>
+                        <a:t>Checkout needs one transaction across cart, stock, coupons and order; get it correct, then split along the module seams</a:t>
                       </a:r>
                       <a:endParaRPr lang="en-US" sz="1200" dirty="0"/>
                     </a:p>
@@ -20075,7 +22964,7 @@
                             <a:srgbClr val="000000"/>
                           </a:solidFill>
                         </a:rPr>
-                        <a:t>Scales out as one unit; modules can be split later</a:t>
+                        <a:t>Two systems run side by side while modules move</a:t>
                       </a:r>
                       <a:endParaRPr lang="en-US" sz="1200" dirty="0"/>
                     </a:p>

</xml_diff>